<commit_message>
Update product portfolio deck
</commit_message>
<xml_diff>
--- a/outputs/B端数字孪生AI产品经理作品集_李沛宣.pptx
+++ b/outputs/B端数字孪生AI产品经理作品集_李沛宣.pptx
@@ -2,26 +2,26 @@
 <file path=ppt/presentation.xml><?xml version="1.0" encoding="utf-8"?>
 <p:presentation xmlns:p="http://schemas.openxmlformats.org/presentationml/2006/main">
   <p:sldMasterIdLst>
-    <p:sldMasterId xmlns:r="http://schemas.openxmlformats.org/officeDocument/2006/relationships" id="2147483648" r:id="R0acd916868d542e6"/>
+    <p:sldMasterId xmlns:r="http://schemas.openxmlformats.org/officeDocument/2006/relationships" id="2147483648" r:id="Rf699605232164cd8"/>
   </p:sldMasterIdLst>
   <p:notesMasterIdLst>
-    <p:notesMasterId xmlns:r="http://schemas.openxmlformats.org/officeDocument/2006/relationships" r:id="Rf118408312cc4f67"/>
+    <p:notesMasterId xmlns:r="http://schemas.openxmlformats.org/officeDocument/2006/relationships" r:id="R94d01c5e8c49422a"/>
   </p:notesMasterIdLst>
   <p:sldIdLst>
-    <p:sldId xmlns:r="http://schemas.openxmlformats.org/officeDocument/2006/relationships" id="256" r:id="R19510678f5d64319"/>
-    <p:sldId xmlns:r="http://schemas.openxmlformats.org/officeDocument/2006/relationships" id="257" r:id="R2b88145c9c2a4398"/>
-    <p:sldId xmlns:r="http://schemas.openxmlformats.org/officeDocument/2006/relationships" id="258" r:id="R1204a9233ad2419b"/>
-    <p:sldId xmlns:r="http://schemas.openxmlformats.org/officeDocument/2006/relationships" id="259" r:id="R779615b6cb714359"/>
-    <p:sldId xmlns:r="http://schemas.openxmlformats.org/officeDocument/2006/relationships" id="260" r:id="R53941f64dfcb4963"/>
-    <p:sldId xmlns:r="http://schemas.openxmlformats.org/officeDocument/2006/relationships" id="261" r:id="Rd9cc6d0c1b2344dc"/>
-    <p:sldId xmlns:r="http://schemas.openxmlformats.org/officeDocument/2006/relationships" id="262" r:id="R320afb34d459476f"/>
-    <p:sldId xmlns:r="http://schemas.openxmlformats.org/officeDocument/2006/relationships" id="263" r:id="Rcf0a9cba75c74a48"/>
-    <p:sldId xmlns:r="http://schemas.openxmlformats.org/officeDocument/2006/relationships" id="264" r:id="Re5c8a85d764f46d7"/>
-    <p:sldId xmlns:r="http://schemas.openxmlformats.org/officeDocument/2006/relationships" id="265" r:id="Rc9ab5d686e1d48fa"/>
-    <p:sldId xmlns:r="http://schemas.openxmlformats.org/officeDocument/2006/relationships" id="266" r:id="Re75be686eef44ea8"/>
-    <p:sldId xmlns:r="http://schemas.openxmlformats.org/officeDocument/2006/relationships" id="267" r:id="R52442f814c81413b"/>
-    <p:sldId xmlns:r="http://schemas.openxmlformats.org/officeDocument/2006/relationships" id="268" r:id="Re3ebfda999fb4a08"/>
-    <p:sldId xmlns:r="http://schemas.openxmlformats.org/officeDocument/2006/relationships" id="269" r:id="R333ae5d0885b46cb"/>
+    <p:sldId xmlns:r="http://schemas.openxmlformats.org/officeDocument/2006/relationships" id="256" r:id="R7e7bec9484544527"/>
+    <p:sldId xmlns:r="http://schemas.openxmlformats.org/officeDocument/2006/relationships" id="257" r:id="R8556ce2224574a57"/>
+    <p:sldId xmlns:r="http://schemas.openxmlformats.org/officeDocument/2006/relationships" id="258" r:id="R48f20a2b3d1d4375"/>
+    <p:sldId xmlns:r="http://schemas.openxmlformats.org/officeDocument/2006/relationships" id="259" r:id="R7138ad6b893c4244"/>
+    <p:sldId xmlns:r="http://schemas.openxmlformats.org/officeDocument/2006/relationships" id="260" r:id="R5b842db8b55744b9"/>
+    <p:sldId xmlns:r="http://schemas.openxmlformats.org/officeDocument/2006/relationships" id="261" r:id="Re7fe558dd9e249e7"/>
+    <p:sldId xmlns:r="http://schemas.openxmlformats.org/officeDocument/2006/relationships" id="262" r:id="R2f817c8bfffd44d9"/>
+    <p:sldId xmlns:r="http://schemas.openxmlformats.org/officeDocument/2006/relationships" id="263" r:id="Re849747905324b00"/>
+    <p:sldId xmlns:r="http://schemas.openxmlformats.org/officeDocument/2006/relationships" id="264" r:id="R9bc5eedf63ee4697"/>
+    <p:sldId xmlns:r="http://schemas.openxmlformats.org/officeDocument/2006/relationships" id="265" r:id="Rc15a1639e2914a16"/>
+    <p:sldId xmlns:r="http://schemas.openxmlformats.org/officeDocument/2006/relationships" id="266" r:id="Rdd90472642954973"/>
+    <p:sldId xmlns:r="http://schemas.openxmlformats.org/officeDocument/2006/relationships" id="267" r:id="R9b8db44250f9411e"/>
+    <p:sldId xmlns:r="http://schemas.openxmlformats.org/officeDocument/2006/relationships" id="268" r:id="R1571ed746daa4483"/>
+    <p:sldId xmlns:r="http://schemas.openxmlformats.org/officeDocument/2006/relationships" id="269" r:id="R1a78ee755cac489f"/>
   </p:sldIdLst>
   <p:sldSz cx="12192000" cy="6858000"/>
   <p:notesSz cx="6858000" cy="9144000"/>
@@ -1472,7 +1472,7 @@
   </p:cSld>
   <p:clrMap bg1="lt1" tx1="dk1" bg2="lt2" tx2="dk2" accent1="accent1" accent2="accent2" accent3="accent3" accent4="accent4" accent5="accent5" accent6="accent6" hlink="hlink" folHlink="folHlink"/>
   <p:sldLayoutIdLst>
-    <p:sldLayoutId xmlns:r="http://schemas.openxmlformats.org/officeDocument/2006/relationships" id="2147483649" r:id="Rfdea72534ed94da1"/>
+    <p:sldLayoutId xmlns:r="http://schemas.openxmlformats.org/officeDocument/2006/relationships" id="2147483649" r:id="R8781a3fb6cf64e5b"/>
   </p:sldLayoutIdLst>
   <p:txStyles>
     <p:titleStyle>
@@ -2144,6 +2144,7 @@
           <a:lstStyle xmlns:a="http://schemas.openxmlformats.org/drawingml/2006/main"/>
           <a:p xmlns:a="http://schemas.openxmlformats.org/drawingml/2006/main">
             <a:pPr algn="l">
+              <a:buNone/>
               <a:defRPr sz="1125" b="1">
                 <a:solidFill>
                   <a:srgbClr val="1F6B57"/>
@@ -2200,6 +2201,7 @@
           <a:lstStyle xmlns:a="http://schemas.openxmlformats.org/drawingml/2006/main"/>
           <a:p xmlns:a="http://schemas.openxmlformats.org/drawingml/2006/main">
             <a:pPr algn="l">
+              <a:buNone/>
               <a:defRPr sz="3600" b="1">
                 <a:solidFill>
                   <a:srgbClr val="17211F"/>
@@ -2256,6 +2258,7 @@
           <a:lstStyle xmlns:a="http://schemas.openxmlformats.org/drawingml/2006/main"/>
           <a:p xmlns:a="http://schemas.openxmlformats.org/drawingml/2006/main">
             <a:pPr algn="l">
+              <a:buNone/>
               <a:defRPr sz="1650" b="0">
                 <a:solidFill>
                   <a:srgbClr val="65716D"/>
@@ -2347,6 +2350,7 @@
           <a:lstStyle xmlns:a="http://schemas.openxmlformats.org/drawingml/2006/main"/>
           <a:p xmlns:a="http://schemas.openxmlformats.org/drawingml/2006/main">
             <a:pPr algn="ctr">
+              <a:buNone/>
               <a:defRPr sz="1050" b="1">
                 <a:solidFill>
                   <a:srgbClr val="17211F"/>
@@ -2469,6 +2473,7 @@
           <a:lstStyle xmlns:a="http://schemas.openxmlformats.org/drawingml/2006/main"/>
           <a:p xmlns:a="http://schemas.openxmlformats.org/drawingml/2006/main">
             <a:pPr algn="ctr">
+              <a:buNone/>
               <a:defRPr sz="1050" b="1">
                 <a:solidFill>
                   <a:srgbClr val="17211F"/>
@@ -2591,6 +2596,7 @@
           <a:lstStyle xmlns:a="http://schemas.openxmlformats.org/drawingml/2006/main"/>
           <a:p xmlns:a="http://schemas.openxmlformats.org/drawingml/2006/main">
             <a:pPr algn="ctr">
+              <a:buNone/>
               <a:defRPr sz="1050" b="1">
                 <a:solidFill>
                   <a:srgbClr val="17211F"/>
@@ -2713,6 +2719,7 @@
           <a:lstStyle xmlns:a="http://schemas.openxmlformats.org/drawingml/2006/main"/>
           <a:p xmlns:a="http://schemas.openxmlformats.org/drawingml/2006/main">
             <a:pPr algn="ctr">
+              <a:buNone/>
               <a:defRPr sz="1050" b="1">
                 <a:solidFill>
                   <a:srgbClr val="17211F"/>
@@ -2835,6 +2842,7 @@
           <a:lstStyle xmlns:a="http://schemas.openxmlformats.org/drawingml/2006/main"/>
           <a:p xmlns:a="http://schemas.openxmlformats.org/drawingml/2006/main">
             <a:pPr algn="ctr">
+              <a:buNone/>
               <a:defRPr sz="1050" b="1">
                 <a:solidFill>
                   <a:srgbClr val="17211F"/>
@@ -2926,6 +2934,7 @@
           <a:lstStyle xmlns:a="http://schemas.openxmlformats.org/drawingml/2006/main"/>
           <a:p xmlns:a="http://schemas.openxmlformats.org/drawingml/2006/main">
             <a:pPr algn="ctr">
+              <a:buNone/>
               <a:defRPr sz="975" b="1">
                 <a:solidFill>
                   <a:srgbClr val="1F6B57"/>
@@ -3017,6 +3026,7 @@
           <a:lstStyle xmlns:a="http://schemas.openxmlformats.org/drawingml/2006/main"/>
           <a:p xmlns:a="http://schemas.openxmlformats.org/drawingml/2006/main">
             <a:pPr algn="ctr">
+              <a:buNone/>
               <a:defRPr sz="975" b="1">
                 <a:solidFill>
                   <a:srgbClr val="218A8A"/>
@@ -3108,6 +3118,7 @@
           <a:lstStyle xmlns:a="http://schemas.openxmlformats.org/drawingml/2006/main"/>
           <a:p xmlns:a="http://schemas.openxmlformats.org/drawingml/2006/main">
             <a:pPr algn="ctr">
+              <a:buNone/>
               <a:defRPr sz="975" b="1">
                 <a:solidFill>
                   <a:srgbClr val="1F6B57"/>
@@ -3199,6 +3210,7 @@
           <a:lstStyle xmlns:a="http://schemas.openxmlformats.org/drawingml/2006/main"/>
           <a:p xmlns:a="http://schemas.openxmlformats.org/drawingml/2006/main">
             <a:pPr algn="ctr">
+              <a:buNone/>
               <a:defRPr sz="975" b="1">
                 <a:solidFill>
                   <a:srgbClr val="218A8A"/>
@@ -3290,6 +3302,7 @@
           <a:lstStyle xmlns:a="http://schemas.openxmlformats.org/drawingml/2006/main"/>
           <a:p xmlns:a="http://schemas.openxmlformats.org/drawingml/2006/main">
             <a:pPr algn="ctr">
+              <a:buNone/>
               <a:defRPr sz="975" b="1">
                 <a:solidFill>
                   <a:srgbClr val="1F6B57"/>
@@ -3346,6 +3359,7 @@
           <a:lstStyle xmlns:a="http://schemas.openxmlformats.org/drawingml/2006/main"/>
           <a:p xmlns:a="http://schemas.openxmlformats.org/drawingml/2006/main">
             <a:pPr algn="l">
+              <a:buNone/>
               <a:defRPr sz="1200" b="1">
                 <a:solidFill>
                   <a:srgbClr val="65716D"/>
@@ -3437,6 +3451,7 @@
           <a:lstStyle xmlns:a="http://schemas.openxmlformats.org/drawingml/2006/main"/>
           <a:p xmlns:a="http://schemas.openxmlformats.org/drawingml/2006/main">
             <a:pPr algn="ctr">
+              <a:buNone/>
               <a:defRPr sz="3900" b="1">
                 <a:solidFill>
                   <a:srgbClr val="1F6B57"/>
@@ -3493,6 +3508,7 @@
           <a:lstStyle xmlns:a="http://schemas.openxmlformats.org/drawingml/2006/main"/>
           <a:p xmlns:a="http://schemas.openxmlformats.org/drawingml/2006/main">
             <a:pPr algn="ctr">
+              <a:buNone/>
               <a:defRPr sz="1200" b="1">
                 <a:solidFill>
                   <a:srgbClr val="102C35"/>
@@ -3516,6 +3532,7 @@
           </a:p>
           <a:p xmlns:a="http://schemas.openxmlformats.org/drawingml/2006/main">
             <a:pPr algn="ctr">
+              <a:buNone/>
               <a:defRPr sz="1200" b="1">
                 <a:solidFill>
                   <a:srgbClr val="102C35"/>
@@ -3601,6 +3618,7 @@
           <a:lstStyle xmlns:a="http://schemas.openxmlformats.org/drawingml/2006/main"/>
           <a:p xmlns:a="http://schemas.openxmlformats.org/drawingml/2006/main">
             <a:pPr algn="l">
+              <a:buNone/>
               <a:defRPr sz="975" b="1">
                 <a:solidFill>
                   <a:srgbClr val="C47A2C"/>
@@ -3657,6 +3675,7 @@
           <a:lstStyle xmlns:a="http://schemas.openxmlformats.org/drawingml/2006/main"/>
           <a:p xmlns:a="http://schemas.openxmlformats.org/drawingml/2006/main">
             <a:pPr algn="l">
+              <a:buNone/>
               <a:defRPr sz="2175" b="1">
                 <a:solidFill>
                   <a:srgbClr val="17211F"/>
@@ -3713,6 +3732,7 @@
           <a:lstStyle xmlns:a="http://schemas.openxmlformats.org/drawingml/2006/main"/>
           <a:p xmlns:a="http://schemas.openxmlformats.org/drawingml/2006/main">
             <a:pPr algn="l">
+              <a:buNone/>
               <a:defRPr sz="1200" b="0">
                 <a:solidFill>
                   <a:srgbClr val="65716D"/>
@@ -3835,6 +3855,7 @@
           <a:lstStyle xmlns:a="http://schemas.openxmlformats.org/drawingml/2006/main"/>
           <a:p xmlns:a="http://schemas.openxmlformats.org/drawingml/2006/main">
             <a:pPr algn="l">
+              <a:buNone/>
               <a:defRPr sz="1425" b="1">
                 <a:solidFill>
                   <a:srgbClr val="1F6B57"/>
@@ -3891,6 +3912,7 @@
           <a:lstStyle xmlns:a="http://schemas.openxmlformats.org/drawingml/2006/main"/>
           <a:p xmlns:a="http://schemas.openxmlformats.org/drawingml/2006/main">
             <a:pPr algn="l">
+              <a:buNone/>
               <a:defRPr sz="1350" b="0">
                 <a:solidFill>
                   <a:srgbClr val="17211F"/>
@@ -4013,6 +4035,7 @@
           <a:lstStyle xmlns:a="http://schemas.openxmlformats.org/drawingml/2006/main"/>
           <a:p xmlns:a="http://schemas.openxmlformats.org/drawingml/2006/main">
             <a:pPr algn="l">
+              <a:buNone/>
               <a:defRPr sz="1425" b="1">
                 <a:solidFill>
                   <a:srgbClr val="102C35"/>
@@ -4069,6 +4092,7 @@
           <a:lstStyle xmlns:a="http://schemas.openxmlformats.org/drawingml/2006/main"/>
           <a:p xmlns:a="http://schemas.openxmlformats.org/drawingml/2006/main">
             <a:pPr algn="l">
+              <a:buNone/>
               <a:defRPr sz="1350" b="0">
                 <a:solidFill>
                   <a:srgbClr val="17211F"/>
@@ -4191,6 +4215,7 @@
           <a:lstStyle xmlns:a="http://schemas.openxmlformats.org/drawingml/2006/main"/>
           <a:p xmlns:a="http://schemas.openxmlformats.org/drawingml/2006/main">
             <a:pPr algn="l">
+              <a:buNone/>
               <a:defRPr sz="1425" b="1">
                 <a:solidFill>
                   <a:srgbClr val="218A8A"/>
@@ -4247,6 +4272,7 @@
           <a:lstStyle xmlns:a="http://schemas.openxmlformats.org/drawingml/2006/main"/>
           <a:p xmlns:a="http://schemas.openxmlformats.org/drawingml/2006/main">
             <a:pPr algn="l">
+              <a:buNone/>
               <a:defRPr sz="1350" b="0">
                 <a:solidFill>
                   <a:srgbClr val="17211F"/>
@@ -4369,6 +4395,7 @@
           <a:lstStyle xmlns:a="http://schemas.openxmlformats.org/drawingml/2006/main"/>
           <a:p xmlns:a="http://schemas.openxmlformats.org/drawingml/2006/main">
             <a:pPr algn="l">
+              <a:buNone/>
               <a:defRPr sz="1425" b="1">
                 <a:solidFill>
                   <a:srgbClr val="C47A2C"/>
@@ -4425,6 +4452,7 @@
           <a:lstStyle xmlns:a="http://schemas.openxmlformats.org/drawingml/2006/main"/>
           <a:p xmlns:a="http://schemas.openxmlformats.org/drawingml/2006/main">
             <a:pPr algn="l">
+              <a:buNone/>
               <a:defRPr sz="1350" b="0">
                 <a:solidFill>
                   <a:srgbClr val="17211F"/>
@@ -4481,6 +4509,7 @@
           <a:lstStyle xmlns:a="http://schemas.openxmlformats.org/drawingml/2006/main"/>
           <a:p xmlns:a="http://schemas.openxmlformats.org/drawingml/2006/main">
             <a:pPr algn="ctr">
+              <a:buNone/>
               <a:defRPr sz="1500" b="1">
                 <a:solidFill>
                   <a:srgbClr val="17211F"/>
@@ -4537,6 +4566,7 @@
           <a:lstStyle xmlns:a="http://schemas.openxmlformats.org/drawingml/2006/main"/>
           <a:p xmlns:a="http://schemas.openxmlformats.org/drawingml/2006/main">
             <a:pPr algn="l">
+              <a:buNone/>
               <a:defRPr sz="750" b="0">
                 <a:solidFill>
                   <a:srgbClr val="65716D"/>
@@ -4622,6 +4652,7 @@
           <a:lstStyle xmlns:a="http://schemas.openxmlformats.org/drawingml/2006/main"/>
           <a:p xmlns:a="http://schemas.openxmlformats.org/drawingml/2006/main">
             <a:pPr algn="l">
+              <a:buNone/>
               <a:defRPr sz="975" b="1">
                 <a:solidFill>
                   <a:srgbClr val="C47A2C"/>
@@ -4678,6 +4709,7 @@
           <a:lstStyle xmlns:a="http://schemas.openxmlformats.org/drawingml/2006/main"/>
           <a:p xmlns:a="http://schemas.openxmlformats.org/drawingml/2006/main">
             <a:pPr algn="l">
+              <a:buNone/>
               <a:defRPr sz="2175" b="1">
                 <a:solidFill>
                   <a:srgbClr val="17211F"/>
@@ -4734,6 +4766,7 @@
           <a:lstStyle xmlns:a="http://schemas.openxmlformats.org/drawingml/2006/main"/>
           <a:p xmlns:a="http://schemas.openxmlformats.org/drawingml/2006/main">
             <a:pPr algn="l">
+              <a:buNone/>
               <a:defRPr sz="1200" b="0">
                 <a:solidFill>
                   <a:srgbClr val="65716D"/>
@@ -4891,6 +4924,7 @@
           <a:lstStyle xmlns:a="http://schemas.openxmlformats.org/drawingml/2006/main"/>
           <a:p xmlns:a="http://schemas.openxmlformats.org/drawingml/2006/main">
             <a:pPr algn="ctr">
+              <a:buNone/>
               <a:defRPr sz="1800" b="1">
                 <a:solidFill>
                   <a:srgbClr val="1F6B57"/>
@@ -4947,6 +4981,7 @@
           <a:lstStyle xmlns:a="http://schemas.openxmlformats.org/drawingml/2006/main"/>
           <a:p xmlns:a="http://schemas.openxmlformats.org/drawingml/2006/main">
             <a:pPr algn="l">
+              <a:buNone/>
               <a:defRPr sz="1650" b="1">
                 <a:solidFill>
                   <a:srgbClr val="1F6B57"/>
@@ -5003,6 +5038,7 @@
           <a:lstStyle xmlns:a="http://schemas.openxmlformats.org/drawingml/2006/main"/>
           <a:p xmlns:a="http://schemas.openxmlformats.org/drawingml/2006/main">
             <a:pPr algn="l">
+              <a:buNone/>
               <a:defRPr sz="1275" b="0">
                 <a:solidFill>
                   <a:srgbClr val="65716D"/>
@@ -5129,6 +5165,7 @@
           <a:lstStyle xmlns:a="http://schemas.openxmlformats.org/drawingml/2006/main"/>
           <a:p xmlns:a="http://schemas.openxmlformats.org/drawingml/2006/main">
             <a:pPr algn="ctr">
+              <a:buNone/>
               <a:defRPr sz="1800" b="1">
                 <a:solidFill>
                   <a:srgbClr val="1F6B57"/>
@@ -5185,6 +5222,7 @@
           <a:lstStyle xmlns:a="http://schemas.openxmlformats.org/drawingml/2006/main"/>
           <a:p xmlns:a="http://schemas.openxmlformats.org/drawingml/2006/main">
             <a:pPr algn="l">
+              <a:buNone/>
               <a:defRPr sz="1650" b="1">
                 <a:solidFill>
                   <a:srgbClr val="1F6B57"/>
@@ -5241,6 +5279,7 @@
           <a:lstStyle xmlns:a="http://schemas.openxmlformats.org/drawingml/2006/main"/>
           <a:p xmlns:a="http://schemas.openxmlformats.org/drawingml/2006/main">
             <a:pPr algn="l">
+              <a:buNone/>
               <a:defRPr sz="1275" b="0">
                 <a:solidFill>
                   <a:srgbClr val="65716D"/>
@@ -5367,6 +5406,7 @@
           <a:lstStyle xmlns:a="http://schemas.openxmlformats.org/drawingml/2006/main"/>
           <a:p xmlns:a="http://schemas.openxmlformats.org/drawingml/2006/main">
             <a:pPr algn="ctr">
+              <a:buNone/>
               <a:defRPr sz="1800" b="1">
                 <a:solidFill>
                   <a:srgbClr val="218A8A"/>
@@ -5423,6 +5463,7 @@
           <a:lstStyle xmlns:a="http://schemas.openxmlformats.org/drawingml/2006/main"/>
           <a:p xmlns:a="http://schemas.openxmlformats.org/drawingml/2006/main">
             <a:pPr algn="l">
+              <a:buNone/>
               <a:defRPr sz="1650" b="1">
                 <a:solidFill>
                   <a:srgbClr val="1F6B57"/>
@@ -5479,6 +5520,7 @@
           <a:lstStyle xmlns:a="http://schemas.openxmlformats.org/drawingml/2006/main"/>
           <a:p xmlns:a="http://schemas.openxmlformats.org/drawingml/2006/main">
             <a:pPr algn="l">
+              <a:buNone/>
               <a:defRPr sz="1275" b="0">
                 <a:solidFill>
                   <a:srgbClr val="65716D"/>
@@ -5605,6 +5647,7 @@
           <a:lstStyle xmlns:a="http://schemas.openxmlformats.org/drawingml/2006/main"/>
           <a:p xmlns:a="http://schemas.openxmlformats.org/drawingml/2006/main">
             <a:pPr algn="ctr">
+              <a:buNone/>
               <a:defRPr sz="1800" b="1">
                 <a:solidFill>
                   <a:srgbClr val="1F6B57"/>
@@ -5661,6 +5704,7 @@
           <a:lstStyle xmlns:a="http://schemas.openxmlformats.org/drawingml/2006/main"/>
           <a:p xmlns:a="http://schemas.openxmlformats.org/drawingml/2006/main">
             <a:pPr algn="l">
+              <a:buNone/>
               <a:defRPr sz="1650" b="1">
                 <a:solidFill>
                   <a:srgbClr val="1F6B57"/>
@@ -5717,6 +5761,7 @@
           <a:lstStyle xmlns:a="http://schemas.openxmlformats.org/drawingml/2006/main"/>
           <a:p xmlns:a="http://schemas.openxmlformats.org/drawingml/2006/main">
             <a:pPr algn="l">
+              <a:buNone/>
               <a:defRPr sz="1275" b="0">
                 <a:solidFill>
                   <a:srgbClr val="65716D"/>
@@ -5773,6 +5818,7 @@
           <a:lstStyle xmlns:a="http://schemas.openxmlformats.org/drawingml/2006/main"/>
           <a:p xmlns:a="http://schemas.openxmlformats.org/drawingml/2006/main">
             <a:pPr algn="ctr">
+              <a:buNone/>
               <a:defRPr sz="1500" b="1">
                 <a:solidFill>
                   <a:srgbClr val="17211F"/>
@@ -5829,6 +5875,7 @@
           <a:lstStyle xmlns:a="http://schemas.openxmlformats.org/drawingml/2006/main"/>
           <a:p xmlns:a="http://schemas.openxmlformats.org/drawingml/2006/main">
             <a:pPr algn="l">
+              <a:buNone/>
               <a:defRPr sz="750" b="0">
                 <a:solidFill>
                   <a:srgbClr val="65716D"/>
@@ -5851,6 +5898,1384 @@
             </a:r>
           </a:p>
         </p:txBody>
+      </p:sp>
+      <p:sp>
+        <p:nvSpPr>
+          <p:cNvPr id="27" name="material-slot-运维看板截图">
+            <a:extLst xmlns:a="http://schemas.openxmlformats.org/drawingml/2006/main">
+              <a:ext uri="{FF2B5EF4-FFF2-40B4-BE49-F238E27FC236}">
+                <a16:creationId xmlns:a16="http://schemas.microsoft.com/office/drawing/2014/main" id="{BA474615-7390-4B38-BC9A-21D48AB08C89}"/>
+              </a:ext>
+            </a:extLst>
+          </p:cNvPr>
+          <p:cNvSpPr>
+            <a:spLocks xmlns:a="http://schemas.openxmlformats.org/drawingml/2006/main" noGrp="1"/>
+          </p:cNvSpPr>
+          <p:nvPr/>
+        </p:nvSpPr>
+        <p:spPr>
+          <a:xfrm xmlns:a="http://schemas.openxmlformats.org/drawingml/2006/main">
+            <a:off x="3714750" y="2343150"/>
+            <a:ext cx="1619250" cy="552450"/>
+          </a:xfrm>
+          <a:prstGeom xmlns:a="http://schemas.openxmlformats.org/drawingml/2006/main" prst="roundRect">
+            <a:avLst>
+              <a:gd name="adj" fmla="val 13793"/>
+            </a:avLst>
+          </a:prstGeom>
+          <a:solidFill xmlns:a="http://schemas.openxmlformats.org/drawingml/2006/main">
+            <a:srgbClr val="FBFCFA"/>
+          </a:solidFill>
+          <a:ln xmlns:a="http://schemas.openxmlformats.org/drawingml/2006/main" w="14288">
+            <a:solidFill>
+              <a:srgbClr val="1F6B57"/>
+            </a:solidFill>
+            <a:prstDash val="dash"/>
+          </a:ln>
+        </p:spPr>
+      </p:sp>
+      <p:sp>
+        <p:nvSpPr>
+          <p:cNvPr id="28" name="">
+            <a:extLst xmlns:a="http://schemas.openxmlformats.org/drawingml/2006/main">
+              <a:ext uri="{FF2B5EF4-FFF2-40B4-BE49-F238E27FC236}">
+                <a16:creationId xmlns:a16="http://schemas.microsoft.com/office/drawing/2014/main" id="{70D00719-62B3-48B4-AAAC-869728C2E0C0}"/>
+              </a:ext>
+            </a:extLst>
+          </p:cNvPr>
+          <p:cNvSpPr>
+            <a:spLocks xmlns:a="http://schemas.openxmlformats.org/drawingml/2006/main" noGrp="1"/>
+          </p:cNvSpPr>
+          <p:nvPr/>
+        </p:nvSpPr>
+        <p:spPr>
+          <a:xfrm xmlns:a="http://schemas.openxmlformats.org/drawingml/2006/main">
+            <a:off x="3886200" y="2476500"/>
+            <a:ext cx="781050" cy="228600"/>
+          </a:xfrm>
+          <a:prstGeom xmlns:a="http://schemas.openxmlformats.org/drawingml/2006/main" prst="rect">
+            <a:avLst/>
+          </a:prstGeom>
+          <a:noFill xmlns:a="http://schemas.openxmlformats.org/drawingml/2006/main"/>
+          <a:ln xmlns:a="http://schemas.openxmlformats.org/drawingml/2006/main" w="0">
+            <a:noFill/>
+            <a:prstDash val="solid"/>
+          </a:ln>
+        </p:spPr>
+        <p:txBody>
+          <a:bodyPr xmlns:a="http://schemas.openxmlformats.org/drawingml/2006/main"/>
+          <a:lstStyle xmlns:a="http://schemas.openxmlformats.org/drawingml/2006/main"/>
+          <a:p xmlns:a="http://schemas.openxmlformats.org/drawingml/2006/main">
+            <a:pPr>
+              <a:buNone/>
+              <a:defRPr sz="975" b="1">
+                <a:solidFill>
+                  <a:srgbClr val="1F6B57"/>
+                </a:solidFill>
+                <a:latin typeface="Microsoft YaHei"/>
+                <a:ea typeface="Microsoft YaHei"/>
+                <a:cs typeface="Microsoft YaHei"/>
+              </a:defRPr>
+            </a:pPr>
+            <a:r>
+              <a:rPr sz="975" b="1">
+                <a:solidFill>
+                  <a:srgbClr val="1F6B57"/>
+                </a:solidFill>
+                <a:latin typeface="Microsoft YaHei"/>
+                <a:ea typeface="Microsoft YaHei"/>
+                <a:cs typeface="Microsoft YaHei"/>
+              </a:rPr>
+              <a:t>待补充</a:t>
+            </a:r>
+          </a:p>
+        </p:txBody>
+      </p:sp>
+      <p:sp>
+        <p:nvSpPr>
+          <p:cNvPr id="29" name="">
+            <a:extLst xmlns:a="http://schemas.openxmlformats.org/drawingml/2006/main">
+              <a:ext uri="{FF2B5EF4-FFF2-40B4-BE49-F238E27FC236}">
+                <a16:creationId xmlns:a16="http://schemas.microsoft.com/office/drawing/2014/main" id="{0A5E9F2C-4FA4-4954-9FDF-44C4E2E8D096}"/>
+              </a:ext>
+            </a:extLst>
+          </p:cNvPr>
+          <p:cNvSpPr>
+            <a:spLocks xmlns:a="http://schemas.openxmlformats.org/drawingml/2006/main" noGrp="1"/>
+          </p:cNvSpPr>
+          <p:nvPr/>
+        </p:nvSpPr>
+        <p:spPr>
+          <a:xfrm xmlns:a="http://schemas.openxmlformats.org/drawingml/2006/main">
+            <a:off x="4686300" y="2457450"/>
+            <a:ext cx="476250" cy="266700"/>
+          </a:xfrm>
+          <a:prstGeom xmlns:a="http://schemas.openxmlformats.org/drawingml/2006/main" prst="rect">
+            <a:avLst/>
+          </a:prstGeom>
+          <a:noFill xmlns:a="http://schemas.openxmlformats.org/drawingml/2006/main"/>
+          <a:ln xmlns:a="http://schemas.openxmlformats.org/drawingml/2006/main" w="0">
+            <a:noFill/>
+            <a:prstDash val="solid"/>
+          </a:ln>
+        </p:spPr>
+        <p:txBody>
+          <a:bodyPr xmlns:a="http://schemas.openxmlformats.org/drawingml/2006/main"/>
+          <a:lstStyle xmlns:a="http://schemas.openxmlformats.org/drawingml/2006/main"/>
+          <a:p xmlns:a="http://schemas.openxmlformats.org/drawingml/2006/main">
+            <a:pPr>
+              <a:buNone/>
+              <a:defRPr sz="1275" b="1">
+                <a:solidFill>
+                  <a:srgbClr val="1A2A26"/>
+                </a:solidFill>
+                <a:latin typeface="Microsoft YaHei"/>
+                <a:ea typeface="Microsoft YaHei"/>
+                <a:cs typeface="Microsoft YaHei"/>
+              </a:defRPr>
+            </a:pPr>
+            <a:r>
+              <a:rPr sz="1275" b="1">
+                <a:solidFill>
+                  <a:srgbClr val="1A2A26"/>
+                </a:solidFill>
+                <a:latin typeface="Microsoft YaHei"/>
+                <a:ea typeface="Microsoft YaHei"/>
+                <a:cs typeface="Microsoft YaHei"/>
+              </a:rPr>
+              <a:t>运维看板截图</a:t>
+            </a:r>
+          </a:p>
+        </p:txBody>
+      </p:sp>
+      <p:sp>
+        <p:nvSpPr>
+          <p:cNvPr id="30" name="">
+            <a:extLst xmlns:a="http://schemas.openxmlformats.org/drawingml/2006/main">
+              <a:ext uri="{FF2B5EF4-FFF2-40B4-BE49-F238E27FC236}">
+                <a16:creationId xmlns:a16="http://schemas.microsoft.com/office/drawing/2014/main" id="{DCD77B78-1FEA-493E-AED7-11381E6434B5}"/>
+              </a:ext>
+            </a:extLst>
+          </p:cNvPr>
+          <p:cNvSpPr>
+            <a:spLocks xmlns:a="http://schemas.openxmlformats.org/drawingml/2006/main" noGrp="1"/>
+          </p:cNvSpPr>
+          <p:nvPr/>
+        </p:nvSpPr>
+        <p:spPr>
+          <a:xfrm xmlns:a="http://schemas.openxmlformats.org/drawingml/2006/main">
+            <a:off x="3886200" y="2743200"/>
+            <a:ext cx="1276350" cy="76200"/>
+          </a:xfrm>
+          <a:prstGeom xmlns:a="http://schemas.openxmlformats.org/drawingml/2006/main" prst="rect">
+            <a:avLst/>
+          </a:prstGeom>
+          <a:noFill xmlns:a="http://schemas.openxmlformats.org/drawingml/2006/main"/>
+          <a:ln xmlns:a="http://schemas.openxmlformats.org/drawingml/2006/main" w="0">
+            <a:noFill/>
+            <a:prstDash val="solid"/>
+          </a:ln>
+        </p:spPr>
+        <p:txBody>
+          <a:bodyPr xmlns:a="http://schemas.openxmlformats.org/drawingml/2006/main"/>
+          <a:lstStyle xmlns:a="http://schemas.openxmlformats.org/drawingml/2006/main"/>
+          <a:p xmlns:a="http://schemas.openxmlformats.org/drawingml/2006/main">
+            <a:pPr>
+              <a:buNone/>
+              <a:defRPr sz="938">
+                <a:solidFill>
+                  <a:srgbClr val="6B746F"/>
+                </a:solidFill>
+                <a:latin typeface="Microsoft YaHei"/>
+                <a:ea typeface="Microsoft YaHei"/>
+                <a:cs typeface="Microsoft YaHei"/>
+              </a:defRPr>
+            </a:pPr>
+            <a:r>
+              <a:rPr sz="938">
+                <a:solidFill>
+                  <a:srgbClr val="6B746F"/>
+                </a:solidFill>
+                <a:latin typeface="Microsoft YaHei"/>
+                <a:ea typeface="Microsoft YaHei"/>
+                <a:cs typeface="Microsoft YaHei"/>
+              </a:rPr>
+              <a:t>异常列表 / 风险等级 / 响应时限</a:t>
+            </a:r>
+          </a:p>
+        </p:txBody>
+      </p:sp>
+      <p:sp>
+        <p:nvSpPr>
+          <p:cNvPr id="31" name="material-slot-设备详情截图">
+            <a:extLst xmlns:a="http://schemas.openxmlformats.org/drawingml/2006/main">
+              <a:ext uri="{FF2B5EF4-FFF2-40B4-BE49-F238E27FC236}">
+                <a16:creationId xmlns:a16="http://schemas.microsoft.com/office/drawing/2014/main" id="{F41FA367-0B37-4ADE-A600-DFEBE4F5E4EC}"/>
+              </a:ext>
+            </a:extLst>
+          </p:cNvPr>
+          <p:cNvSpPr>
+            <a:spLocks xmlns:a="http://schemas.openxmlformats.org/drawingml/2006/main" noGrp="1"/>
+          </p:cNvSpPr>
+          <p:nvPr/>
+        </p:nvSpPr>
+        <p:spPr>
+          <a:xfrm xmlns:a="http://schemas.openxmlformats.org/drawingml/2006/main">
+            <a:off x="9048750" y="2343150"/>
+            <a:ext cx="1619250" cy="552450"/>
+          </a:xfrm>
+          <a:prstGeom xmlns:a="http://schemas.openxmlformats.org/drawingml/2006/main" prst="roundRect">
+            <a:avLst>
+              <a:gd name="adj" fmla="val 13793"/>
+            </a:avLst>
+          </a:prstGeom>
+          <a:solidFill xmlns:a="http://schemas.openxmlformats.org/drawingml/2006/main">
+            <a:srgbClr val="FBFCFA"/>
+          </a:solidFill>
+          <a:ln xmlns:a="http://schemas.openxmlformats.org/drawingml/2006/main" w="14288">
+            <a:solidFill>
+              <a:srgbClr val="1F6B57"/>
+            </a:solidFill>
+            <a:prstDash val="dash"/>
+          </a:ln>
+        </p:spPr>
+      </p:sp>
+      <p:sp>
+        <p:nvSpPr>
+          <p:cNvPr id="32" name="">
+            <a:extLst xmlns:a="http://schemas.openxmlformats.org/drawingml/2006/main">
+              <a:ext uri="{FF2B5EF4-FFF2-40B4-BE49-F238E27FC236}">
+                <a16:creationId xmlns:a16="http://schemas.microsoft.com/office/drawing/2014/main" id="{03FF7D7D-EB5E-4C18-8B38-15D893090A58}"/>
+              </a:ext>
+            </a:extLst>
+          </p:cNvPr>
+          <p:cNvSpPr>
+            <a:spLocks xmlns:a="http://schemas.openxmlformats.org/drawingml/2006/main" noGrp="1"/>
+          </p:cNvSpPr>
+          <p:nvPr/>
+        </p:nvSpPr>
+        <p:spPr>
+          <a:xfrm xmlns:a="http://schemas.openxmlformats.org/drawingml/2006/main">
+            <a:off x="9220200" y="2476500"/>
+            <a:ext cx="781050" cy="228600"/>
+          </a:xfrm>
+          <a:prstGeom xmlns:a="http://schemas.openxmlformats.org/drawingml/2006/main" prst="rect">
+            <a:avLst/>
+          </a:prstGeom>
+          <a:noFill xmlns:a="http://schemas.openxmlformats.org/drawingml/2006/main"/>
+          <a:ln xmlns:a="http://schemas.openxmlformats.org/drawingml/2006/main" w="0">
+            <a:noFill/>
+            <a:prstDash val="solid"/>
+          </a:ln>
+        </p:spPr>
+        <p:txBody>
+          <a:bodyPr xmlns:a="http://schemas.openxmlformats.org/drawingml/2006/main"/>
+          <a:lstStyle xmlns:a="http://schemas.openxmlformats.org/drawingml/2006/main"/>
+          <a:p xmlns:a="http://schemas.openxmlformats.org/drawingml/2006/main">
+            <a:pPr>
+              <a:buNone/>
+              <a:defRPr sz="975" b="1">
+                <a:solidFill>
+                  <a:srgbClr val="1F6B57"/>
+                </a:solidFill>
+                <a:latin typeface="Microsoft YaHei"/>
+                <a:ea typeface="Microsoft YaHei"/>
+                <a:cs typeface="Microsoft YaHei"/>
+              </a:defRPr>
+            </a:pPr>
+            <a:r>
+              <a:rPr sz="975" b="1">
+                <a:solidFill>
+                  <a:srgbClr val="1F6B57"/>
+                </a:solidFill>
+                <a:latin typeface="Microsoft YaHei"/>
+                <a:ea typeface="Microsoft YaHei"/>
+                <a:cs typeface="Microsoft YaHei"/>
+              </a:rPr>
+              <a:t>待补充</a:t>
+            </a:r>
+          </a:p>
+        </p:txBody>
+      </p:sp>
+      <p:sp>
+        <p:nvSpPr>
+          <p:cNvPr id="33" name="">
+            <a:extLst xmlns:a="http://schemas.openxmlformats.org/drawingml/2006/main">
+              <a:ext uri="{FF2B5EF4-FFF2-40B4-BE49-F238E27FC236}">
+                <a16:creationId xmlns:a16="http://schemas.microsoft.com/office/drawing/2014/main" id="{4894F475-5290-45FE-860E-F8F3E7D4F02B}"/>
+              </a:ext>
+            </a:extLst>
+          </p:cNvPr>
+          <p:cNvSpPr>
+            <a:spLocks xmlns:a="http://schemas.openxmlformats.org/drawingml/2006/main" noGrp="1"/>
+          </p:cNvSpPr>
+          <p:nvPr/>
+        </p:nvSpPr>
+        <p:spPr>
+          <a:xfrm xmlns:a="http://schemas.openxmlformats.org/drawingml/2006/main">
+            <a:off x="10020300" y="2457450"/>
+            <a:ext cx="476250" cy="266700"/>
+          </a:xfrm>
+          <a:prstGeom xmlns:a="http://schemas.openxmlformats.org/drawingml/2006/main" prst="rect">
+            <a:avLst/>
+          </a:prstGeom>
+          <a:noFill xmlns:a="http://schemas.openxmlformats.org/drawingml/2006/main"/>
+          <a:ln xmlns:a="http://schemas.openxmlformats.org/drawingml/2006/main" w="0">
+            <a:noFill/>
+            <a:prstDash val="solid"/>
+          </a:ln>
+        </p:spPr>
+        <p:txBody>
+          <a:bodyPr xmlns:a="http://schemas.openxmlformats.org/drawingml/2006/main"/>
+          <a:lstStyle xmlns:a="http://schemas.openxmlformats.org/drawingml/2006/main"/>
+          <a:p xmlns:a="http://schemas.openxmlformats.org/drawingml/2006/main">
+            <a:pPr>
+              <a:buNone/>
+              <a:defRPr sz="1275" b="1">
+                <a:solidFill>
+                  <a:srgbClr val="1A2A26"/>
+                </a:solidFill>
+                <a:latin typeface="Microsoft YaHei"/>
+                <a:ea typeface="Microsoft YaHei"/>
+                <a:cs typeface="Microsoft YaHei"/>
+              </a:defRPr>
+            </a:pPr>
+            <a:r>
+              <a:rPr sz="1275" b="1">
+                <a:solidFill>
+                  <a:srgbClr val="1A2A26"/>
+                </a:solidFill>
+                <a:latin typeface="Microsoft YaHei"/>
+                <a:ea typeface="Microsoft YaHei"/>
+                <a:cs typeface="Microsoft YaHei"/>
+              </a:rPr>
+              <a:t>设备详情截图</a:t>
+            </a:r>
+          </a:p>
+        </p:txBody>
+      </p:sp>
+      <p:sp>
+        <p:nvSpPr>
+          <p:cNvPr id="34" name="">
+            <a:extLst xmlns:a="http://schemas.openxmlformats.org/drawingml/2006/main">
+              <a:ext uri="{FF2B5EF4-FFF2-40B4-BE49-F238E27FC236}">
+                <a16:creationId xmlns:a16="http://schemas.microsoft.com/office/drawing/2014/main" id="{134CF798-7062-4D6E-B9B3-7BEF610EB286}"/>
+              </a:ext>
+            </a:extLst>
+          </p:cNvPr>
+          <p:cNvSpPr>
+            <a:spLocks xmlns:a="http://schemas.openxmlformats.org/drawingml/2006/main" noGrp="1"/>
+          </p:cNvSpPr>
+          <p:nvPr/>
+        </p:nvSpPr>
+        <p:spPr>
+          <a:xfrm xmlns:a="http://schemas.openxmlformats.org/drawingml/2006/main">
+            <a:off x="9220200" y="2743200"/>
+            <a:ext cx="1276350" cy="76200"/>
+          </a:xfrm>
+          <a:prstGeom xmlns:a="http://schemas.openxmlformats.org/drawingml/2006/main" prst="rect">
+            <a:avLst/>
+          </a:prstGeom>
+          <a:noFill xmlns:a="http://schemas.openxmlformats.org/drawingml/2006/main"/>
+          <a:ln xmlns:a="http://schemas.openxmlformats.org/drawingml/2006/main" w="0">
+            <a:noFill/>
+            <a:prstDash val="solid"/>
+          </a:ln>
+        </p:spPr>
+        <p:txBody>
+          <a:bodyPr xmlns:a="http://schemas.openxmlformats.org/drawingml/2006/main"/>
+          <a:lstStyle xmlns:a="http://schemas.openxmlformats.org/drawingml/2006/main"/>
+          <a:p xmlns:a="http://schemas.openxmlformats.org/drawingml/2006/main">
+            <a:pPr>
+              <a:buNone/>
+              <a:defRPr sz="938">
+                <a:solidFill>
+                  <a:srgbClr val="6B746F"/>
+                </a:solidFill>
+                <a:latin typeface="Microsoft YaHei"/>
+                <a:ea typeface="Microsoft YaHei"/>
+                <a:cs typeface="Microsoft YaHei"/>
+              </a:defRPr>
+            </a:pPr>
+            <a:r>
+              <a:rPr sz="938">
+                <a:solidFill>
+                  <a:srgbClr val="6B746F"/>
+                </a:solidFill>
+                <a:latin typeface="Microsoft YaHei"/>
+                <a:ea typeface="Microsoft YaHei"/>
+                <a:cs typeface="Microsoft YaHei"/>
+              </a:rPr>
+              <a:t>曲线 / 台账 / 历史工单 / 3D位置</a:t>
+            </a:r>
+          </a:p>
+        </p:txBody>
+      </p:sp>
+      <p:sp>
+        <p:nvSpPr>
+          <p:cNvPr id="35" name="material-slot-诊断面板截图">
+            <a:extLst xmlns:a="http://schemas.openxmlformats.org/drawingml/2006/main">
+              <a:ext uri="{FF2B5EF4-FFF2-40B4-BE49-F238E27FC236}">
+                <a16:creationId xmlns:a16="http://schemas.microsoft.com/office/drawing/2014/main" id="{94176FD1-46B8-463C-B07B-25B52EFB47F6}"/>
+              </a:ext>
+            </a:extLst>
+          </p:cNvPr>
+          <p:cNvSpPr>
+            <a:spLocks xmlns:a="http://schemas.openxmlformats.org/drawingml/2006/main" noGrp="1"/>
+          </p:cNvSpPr>
+          <p:nvPr/>
+        </p:nvSpPr>
+        <p:spPr>
+          <a:xfrm xmlns:a="http://schemas.openxmlformats.org/drawingml/2006/main">
+            <a:off x="3714750" y="4210050"/>
+            <a:ext cx="1619250" cy="552450"/>
+          </a:xfrm>
+          <a:prstGeom xmlns:a="http://schemas.openxmlformats.org/drawingml/2006/main" prst="roundRect">
+            <a:avLst>
+              <a:gd name="adj" fmla="val 13793"/>
+            </a:avLst>
+          </a:prstGeom>
+          <a:solidFill xmlns:a="http://schemas.openxmlformats.org/drawingml/2006/main">
+            <a:srgbClr val="FBFCFA"/>
+          </a:solidFill>
+          <a:ln xmlns:a="http://schemas.openxmlformats.org/drawingml/2006/main" w="14288">
+            <a:solidFill>
+              <a:srgbClr val="1F6B57"/>
+            </a:solidFill>
+            <a:prstDash val="dash"/>
+          </a:ln>
+        </p:spPr>
+      </p:sp>
+      <p:sp>
+        <p:nvSpPr>
+          <p:cNvPr id="36" name="">
+            <a:extLst xmlns:a="http://schemas.openxmlformats.org/drawingml/2006/main">
+              <a:ext uri="{FF2B5EF4-FFF2-40B4-BE49-F238E27FC236}">
+                <a16:creationId xmlns:a16="http://schemas.microsoft.com/office/drawing/2014/main" id="{6542239B-5D75-40AD-9F60-D4111EE96E1D}"/>
+              </a:ext>
+            </a:extLst>
+          </p:cNvPr>
+          <p:cNvSpPr>
+            <a:spLocks xmlns:a="http://schemas.openxmlformats.org/drawingml/2006/main" noGrp="1"/>
+          </p:cNvSpPr>
+          <p:nvPr/>
+        </p:nvSpPr>
+        <p:spPr>
+          <a:xfrm xmlns:a="http://schemas.openxmlformats.org/drawingml/2006/main">
+            <a:off x="3886200" y="4343400"/>
+            <a:ext cx="781050" cy="228600"/>
+          </a:xfrm>
+          <a:prstGeom xmlns:a="http://schemas.openxmlformats.org/drawingml/2006/main" prst="rect">
+            <a:avLst/>
+          </a:prstGeom>
+          <a:noFill xmlns:a="http://schemas.openxmlformats.org/drawingml/2006/main"/>
+          <a:ln xmlns:a="http://schemas.openxmlformats.org/drawingml/2006/main" w="0">
+            <a:noFill/>
+            <a:prstDash val="solid"/>
+          </a:ln>
+        </p:spPr>
+        <p:txBody>
+          <a:bodyPr xmlns:a="http://schemas.openxmlformats.org/drawingml/2006/main"/>
+          <a:lstStyle xmlns:a="http://schemas.openxmlformats.org/drawingml/2006/main"/>
+          <a:p xmlns:a="http://schemas.openxmlformats.org/drawingml/2006/main">
+            <a:pPr>
+              <a:buNone/>
+              <a:defRPr sz="975" b="1">
+                <a:solidFill>
+                  <a:srgbClr val="1F6B57"/>
+                </a:solidFill>
+                <a:latin typeface="Microsoft YaHei"/>
+                <a:ea typeface="Microsoft YaHei"/>
+                <a:cs typeface="Microsoft YaHei"/>
+              </a:defRPr>
+            </a:pPr>
+            <a:r>
+              <a:rPr sz="975" b="1">
+                <a:solidFill>
+                  <a:srgbClr val="1F6B57"/>
+                </a:solidFill>
+                <a:latin typeface="Microsoft YaHei"/>
+                <a:ea typeface="Microsoft YaHei"/>
+                <a:cs typeface="Microsoft YaHei"/>
+              </a:rPr>
+              <a:t>待补充</a:t>
+            </a:r>
+          </a:p>
+        </p:txBody>
+      </p:sp>
+      <p:sp>
+        <p:nvSpPr>
+          <p:cNvPr id="37" name="">
+            <a:extLst xmlns:a="http://schemas.openxmlformats.org/drawingml/2006/main">
+              <a:ext uri="{FF2B5EF4-FFF2-40B4-BE49-F238E27FC236}">
+                <a16:creationId xmlns:a16="http://schemas.microsoft.com/office/drawing/2014/main" id="{3E6FAD3A-DEFD-4F7F-9D8B-17F028D14F6B}"/>
+              </a:ext>
+            </a:extLst>
+          </p:cNvPr>
+          <p:cNvSpPr>
+            <a:spLocks xmlns:a="http://schemas.openxmlformats.org/drawingml/2006/main" noGrp="1"/>
+          </p:cNvSpPr>
+          <p:nvPr/>
+        </p:nvSpPr>
+        <p:spPr>
+          <a:xfrm xmlns:a="http://schemas.openxmlformats.org/drawingml/2006/main">
+            <a:off x="4686300" y="4324350"/>
+            <a:ext cx="476250" cy="266700"/>
+          </a:xfrm>
+          <a:prstGeom xmlns:a="http://schemas.openxmlformats.org/drawingml/2006/main" prst="rect">
+            <a:avLst/>
+          </a:prstGeom>
+          <a:noFill xmlns:a="http://schemas.openxmlformats.org/drawingml/2006/main"/>
+          <a:ln xmlns:a="http://schemas.openxmlformats.org/drawingml/2006/main" w="0">
+            <a:noFill/>
+            <a:prstDash val="solid"/>
+          </a:ln>
+        </p:spPr>
+        <p:txBody>
+          <a:bodyPr xmlns:a="http://schemas.openxmlformats.org/drawingml/2006/main"/>
+          <a:lstStyle xmlns:a="http://schemas.openxmlformats.org/drawingml/2006/main"/>
+          <a:p xmlns:a="http://schemas.openxmlformats.org/drawingml/2006/main">
+            <a:pPr>
+              <a:buNone/>
+              <a:defRPr sz="1275" b="1">
+                <a:solidFill>
+                  <a:srgbClr val="1A2A26"/>
+                </a:solidFill>
+                <a:latin typeface="Microsoft YaHei"/>
+                <a:ea typeface="Microsoft YaHei"/>
+                <a:cs typeface="Microsoft YaHei"/>
+              </a:defRPr>
+            </a:pPr>
+            <a:r>
+              <a:rPr sz="1275" b="1">
+                <a:solidFill>
+                  <a:srgbClr val="1A2A26"/>
+                </a:solidFill>
+                <a:latin typeface="Microsoft YaHei"/>
+                <a:ea typeface="Microsoft YaHei"/>
+                <a:cs typeface="Microsoft YaHei"/>
+              </a:rPr>
+              <a:t>诊断面板截图</a:t>
+            </a:r>
+          </a:p>
+        </p:txBody>
+      </p:sp>
+      <p:sp>
+        <p:nvSpPr>
+          <p:cNvPr id="38" name="">
+            <a:extLst xmlns:a="http://schemas.openxmlformats.org/drawingml/2006/main">
+              <a:ext uri="{FF2B5EF4-FFF2-40B4-BE49-F238E27FC236}">
+                <a16:creationId xmlns:a16="http://schemas.microsoft.com/office/drawing/2014/main" id="{0189E518-5F2E-4663-920D-8515C20B70E5}"/>
+              </a:ext>
+            </a:extLst>
+          </p:cNvPr>
+          <p:cNvSpPr>
+            <a:spLocks xmlns:a="http://schemas.openxmlformats.org/drawingml/2006/main" noGrp="1"/>
+          </p:cNvSpPr>
+          <p:nvPr/>
+        </p:nvSpPr>
+        <p:spPr>
+          <a:xfrm xmlns:a="http://schemas.openxmlformats.org/drawingml/2006/main">
+            <a:off x="3886200" y="4610100"/>
+            <a:ext cx="1276350" cy="76200"/>
+          </a:xfrm>
+          <a:prstGeom xmlns:a="http://schemas.openxmlformats.org/drawingml/2006/main" prst="rect">
+            <a:avLst/>
+          </a:prstGeom>
+          <a:noFill xmlns:a="http://schemas.openxmlformats.org/drawingml/2006/main"/>
+          <a:ln xmlns:a="http://schemas.openxmlformats.org/drawingml/2006/main" w="0">
+            <a:noFill/>
+            <a:prstDash val="solid"/>
+          </a:ln>
+        </p:spPr>
+        <p:txBody>
+          <a:bodyPr xmlns:a="http://schemas.openxmlformats.org/drawingml/2006/main"/>
+          <a:lstStyle xmlns:a="http://schemas.openxmlformats.org/drawingml/2006/main"/>
+          <a:p xmlns:a="http://schemas.openxmlformats.org/drawingml/2006/main">
+            <a:pPr>
+              <a:buNone/>
+              <a:defRPr sz="938">
+                <a:solidFill>
+                  <a:srgbClr val="6B746F"/>
+                </a:solidFill>
+                <a:latin typeface="Microsoft YaHei"/>
+                <a:ea typeface="Microsoft YaHei"/>
+                <a:cs typeface="Microsoft YaHei"/>
+              </a:defRPr>
+            </a:pPr>
+            <a:r>
+              <a:rPr sz="938">
+                <a:solidFill>
+                  <a:srgbClr val="6B746F"/>
+                </a:solidFill>
+                <a:latin typeface="Microsoft YaHei"/>
+                <a:ea typeface="Microsoft YaHei"/>
+                <a:cs typeface="Microsoft YaHei"/>
+              </a:rPr>
+              <a:t>结论 / 证据 / 置信度 / 引用来源</a:t>
+            </a:r>
+          </a:p>
+        </p:txBody>
+      </p:sp>
+      <p:sp>
+        <p:nvSpPr>
+          <p:cNvPr id="39" name="material-slot-工单草稿截图">
+            <a:extLst xmlns:a="http://schemas.openxmlformats.org/drawingml/2006/main">
+              <a:ext uri="{FF2B5EF4-FFF2-40B4-BE49-F238E27FC236}">
+                <a16:creationId xmlns:a16="http://schemas.microsoft.com/office/drawing/2014/main" id="{81DA0876-6BEF-4C36-BC67-D98B7F567931}"/>
+              </a:ext>
+            </a:extLst>
+          </p:cNvPr>
+          <p:cNvSpPr>
+            <a:spLocks xmlns:a="http://schemas.openxmlformats.org/drawingml/2006/main" noGrp="1"/>
+          </p:cNvSpPr>
+          <p:nvPr/>
+        </p:nvSpPr>
+        <p:spPr>
+          <a:xfrm xmlns:a="http://schemas.openxmlformats.org/drawingml/2006/main">
+            <a:off x="9048750" y="4210050"/>
+            <a:ext cx="1619250" cy="552450"/>
+          </a:xfrm>
+          <a:prstGeom xmlns:a="http://schemas.openxmlformats.org/drawingml/2006/main" prst="roundRect">
+            <a:avLst>
+              <a:gd name="adj" fmla="val 13793"/>
+            </a:avLst>
+          </a:prstGeom>
+          <a:solidFill xmlns:a="http://schemas.openxmlformats.org/drawingml/2006/main">
+            <a:srgbClr val="FBFCFA"/>
+          </a:solidFill>
+          <a:ln xmlns:a="http://schemas.openxmlformats.org/drawingml/2006/main" w="14288">
+            <a:solidFill>
+              <a:srgbClr val="1F6B57"/>
+            </a:solidFill>
+            <a:prstDash val="dash"/>
+          </a:ln>
+        </p:spPr>
+      </p:sp>
+      <p:sp>
+        <p:nvSpPr>
+          <p:cNvPr id="40" name="">
+            <a:extLst xmlns:a="http://schemas.openxmlformats.org/drawingml/2006/main">
+              <a:ext uri="{FF2B5EF4-FFF2-40B4-BE49-F238E27FC236}">
+                <a16:creationId xmlns:a16="http://schemas.microsoft.com/office/drawing/2014/main" id="{CD89AD63-0E57-4DCE-BF11-3E66B4D06B20}"/>
+              </a:ext>
+            </a:extLst>
+          </p:cNvPr>
+          <p:cNvSpPr>
+            <a:spLocks xmlns:a="http://schemas.openxmlformats.org/drawingml/2006/main" noGrp="1"/>
+          </p:cNvSpPr>
+          <p:nvPr/>
+        </p:nvSpPr>
+        <p:spPr>
+          <a:xfrm xmlns:a="http://schemas.openxmlformats.org/drawingml/2006/main">
+            <a:off x="9220200" y="4343400"/>
+            <a:ext cx="781050" cy="228600"/>
+          </a:xfrm>
+          <a:prstGeom xmlns:a="http://schemas.openxmlformats.org/drawingml/2006/main" prst="rect">
+            <a:avLst/>
+          </a:prstGeom>
+          <a:noFill xmlns:a="http://schemas.openxmlformats.org/drawingml/2006/main"/>
+          <a:ln xmlns:a="http://schemas.openxmlformats.org/drawingml/2006/main" w="0">
+            <a:noFill/>
+            <a:prstDash val="solid"/>
+          </a:ln>
+        </p:spPr>
+        <p:txBody>
+          <a:bodyPr xmlns:a="http://schemas.openxmlformats.org/drawingml/2006/main"/>
+          <a:lstStyle xmlns:a="http://schemas.openxmlformats.org/drawingml/2006/main"/>
+          <a:p xmlns:a="http://schemas.openxmlformats.org/drawingml/2006/main">
+            <a:pPr>
+              <a:buNone/>
+              <a:defRPr sz="975" b="1">
+                <a:solidFill>
+                  <a:srgbClr val="1F6B57"/>
+                </a:solidFill>
+                <a:latin typeface="Microsoft YaHei"/>
+                <a:ea typeface="Microsoft YaHei"/>
+                <a:cs typeface="Microsoft YaHei"/>
+              </a:defRPr>
+            </a:pPr>
+            <a:r>
+              <a:rPr sz="975" b="1">
+                <a:solidFill>
+                  <a:srgbClr val="1F6B57"/>
+                </a:solidFill>
+                <a:latin typeface="Microsoft YaHei"/>
+                <a:ea typeface="Microsoft YaHei"/>
+                <a:cs typeface="Microsoft YaHei"/>
+              </a:rPr>
+              <a:t>待补充</a:t>
+            </a:r>
+          </a:p>
+        </p:txBody>
+      </p:sp>
+      <p:sp>
+        <p:nvSpPr>
+          <p:cNvPr id="41" name="">
+            <a:extLst xmlns:a="http://schemas.openxmlformats.org/drawingml/2006/main">
+              <a:ext uri="{FF2B5EF4-FFF2-40B4-BE49-F238E27FC236}">
+                <a16:creationId xmlns:a16="http://schemas.microsoft.com/office/drawing/2014/main" id="{78B09B2D-C835-475D-A6E7-19E84DB9714A}"/>
+              </a:ext>
+            </a:extLst>
+          </p:cNvPr>
+          <p:cNvSpPr>
+            <a:spLocks xmlns:a="http://schemas.openxmlformats.org/drawingml/2006/main" noGrp="1"/>
+          </p:cNvSpPr>
+          <p:nvPr/>
+        </p:nvSpPr>
+        <p:spPr>
+          <a:xfrm xmlns:a="http://schemas.openxmlformats.org/drawingml/2006/main">
+            <a:off x="10020300" y="4324350"/>
+            <a:ext cx="476250" cy="266700"/>
+          </a:xfrm>
+          <a:prstGeom xmlns:a="http://schemas.openxmlformats.org/drawingml/2006/main" prst="rect">
+            <a:avLst/>
+          </a:prstGeom>
+          <a:noFill xmlns:a="http://schemas.openxmlformats.org/drawingml/2006/main"/>
+          <a:ln xmlns:a="http://schemas.openxmlformats.org/drawingml/2006/main" w="0">
+            <a:noFill/>
+            <a:prstDash val="solid"/>
+          </a:ln>
+        </p:spPr>
+        <p:txBody>
+          <a:bodyPr xmlns:a="http://schemas.openxmlformats.org/drawingml/2006/main"/>
+          <a:lstStyle xmlns:a="http://schemas.openxmlformats.org/drawingml/2006/main"/>
+          <a:p xmlns:a="http://schemas.openxmlformats.org/drawingml/2006/main">
+            <a:pPr>
+              <a:buNone/>
+              <a:defRPr sz="1275" b="1">
+                <a:solidFill>
+                  <a:srgbClr val="1A2A26"/>
+                </a:solidFill>
+                <a:latin typeface="Microsoft YaHei"/>
+                <a:ea typeface="Microsoft YaHei"/>
+                <a:cs typeface="Microsoft YaHei"/>
+              </a:defRPr>
+            </a:pPr>
+            <a:r>
+              <a:rPr sz="1275" b="1">
+                <a:solidFill>
+                  <a:srgbClr val="1A2A26"/>
+                </a:solidFill>
+                <a:latin typeface="Microsoft YaHei"/>
+                <a:ea typeface="Microsoft YaHei"/>
+                <a:cs typeface="Microsoft YaHei"/>
+              </a:rPr>
+              <a:t>工单草稿截图</a:t>
+            </a:r>
+          </a:p>
+        </p:txBody>
+      </p:sp>
+      <p:sp>
+        <p:nvSpPr>
+          <p:cNvPr id="42" name="">
+            <a:extLst xmlns:a="http://schemas.openxmlformats.org/drawingml/2006/main">
+              <a:ext uri="{FF2B5EF4-FFF2-40B4-BE49-F238E27FC236}">
+                <a16:creationId xmlns:a16="http://schemas.microsoft.com/office/drawing/2014/main" id="{3EC66D96-0A69-4D9A-BEE6-BF5765A54445}"/>
+              </a:ext>
+            </a:extLst>
+          </p:cNvPr>
+          <p:cNvSpPr>
+            <a:spLocks xmlns:a="http://schemas.openxmlformats.org/drawingml/2006/main" noGrp="1"/>
+          </p:cNvSpPr>
+          <p:nvPr/>
+        </p:nvSpPr>
+        <p:spPr>
+          <a:xfrm xmlns:a="http://schemas.openxmlformats.org/drawingml/2006/main">
+            <a:off x="9220200" y="4610100"/>
+            <a:ext cx="1276350" cy="76200"/>
+          </a:xfrm>
+          <a:prstGeom xmlns:a="http://schemas.openxmlformats.org/drawingml/2006/main" prst="rect">
+            <a:avLst/>
+          </a:prstGeom>
+          <a:noFill xmlns:a="http://schemas.openxmlformats.org/drawingml/2006/main"/>
+          <a:ln xmlns:a="http://schemas.openxmlformats.org/drawingml/2006/main" w="0">
+            <a:noFill/>
+            <a:prstDash val="solid"/>
+          </a:ln>
+        </p:spPr>
+        <p:txBody>
+          <a:bodyPr xmlns:a="http://schemas.openxmlformats.org/drawingml/2006/main"/>
+          <a:lstStyle xmlns:a="http://schemas.openxmlformats.org/drawingml/2006/main"/>
+          <a:p xmlns:a="http://schemas.openxmlformats.org/drawingml/2006/main">
+            <a:pPr>
+              <a:buNone/>
+              <a:defRPr sz="938">
+                <a:solidFill>
+                  <a:srgbClr val="6B746F"/>
+                </a:solidFill>
+                <a:latin typeface="Microsoft YaHei"/>
+                <a:ea typeface="Microsoft YaHei"/>
+                <a:cs typeface="Microsoft YaHei"/>
+              </a:defRPr>
+            </a:pPr>
+            <a:r>
+              <a:rPr sz="938">
+                <a:solidFill>
+                  <a:srgbClr val="6B746F"/>
+                </a:solidFill>
+                <a:latin typeface="Microsoft YaHei"/>
+                <a:ea typeface="Microsoft YaHei"/>
+                <a:cs typeface="Microsoft YaHei"/>
+              </a:rPr>
+              <a:t>字段预填 / SOP步骤 / 验收标准</a:t>
+            </a:r>
+          </a:p>
+        </p:txBody>
+      </p:sp>
+      <p:sp>
+        <p:nvSpPr>
+          <p:cNvPr id="43" name="">
+            <a:extLst xmlns:a="http://schemas.openxmlformats.org/drawingml/2006/main">
+              <a:ext uri="{FF2B5EF4-FFF2-40B4-BE49-F238E27FC236}">
+                <a16:creationId xmlns:a16="http://schemas.microsoft.com/office/drawing/2014/main" id="{C62619E6-3424-4A85-8D4E-52038CFC6253}"/>
+              </a:ext>
+            </a:extLst>
+          </p:cNvPr>
+          <p:cNvSpPr>
+            <a:spLocks xmlns:a="http://schemas.openxmlformats.org/drawingml/2006/main" noGrp="1"/>
+          </p:cNvSpPr>
+          <p:nvPr/>
+        </p:nvSpPr>
+        <p:spPr>
+          <a:xfrm xmlns:a="http://schemas.openxmlformats.org/drawingml/2006/main">
+            <a:off x="3638550" y="2286000"/>
+            <a:ext cx="1809750" cy="1428750"/>
+          </a:xfrm>
+          <a:prstGeom xmlns:a="http://schemas.openxmlformats.org/drawingml/2006/main" prst="rect">
+            <a:avLst/>
+          </a:prstGeom>
+          <a:solidFill xmlns:a="http://schemas.openxmlformats.org/drawingml/2006/main">
+            <a:srgbClr val="FBFCFA"/>
+          </a:solidFill>
+          <a:ln xmlns:a="http://schemas.openxmlformats.org/drawingml/2006/main" w="0">
+            <a:noFill/>
+            <a:prstDash val="solid"/>
+          </a:ln>
+        </p:spPr>
+      </p:sp>
+      <p:sp>
+        <p:nvSpPr>
+          <p:cNvPr id="44" name="">
+            <a:extLst xmlns:a="http://schemas.openxmlformats.org/drawingml/2006/main">
+              <a:ext uri="{FF2B5EF4-FFF2-40B4-BE49-F238E27FC236}">
+                <a16:creationId xmlns:a16="http://schemas.microsoft.com/office/drawing/2014/main" id="{AF2D4508-B848-4C22-A622-303E0B321142}"/>
+              </a:ext>
+            </a:extLst>
+          </p:cNvPr>
+          <p:cNvSpPr>
+            <a:spLocks xmlns:a="http://schemas.openxmlformats.org/drawingml/2006/main" noGrp="1"/>
+          </p:cNvSpPr>
+          <p:nvPr/>
+        </p:nvSpPr>
+        <p:spPr>
+          <a:xfrm xmlns:a="http://schemas.openxmlformats.org/drawingml/2006/main">
+            <a:off x="8972550" y="2286000"/>
+            <a:ext cx="1809750" cy="1428750"/>
+          </a:xfrm>
+          <a:prstGeom xmlns:a="http://schemas.openxmlformats.org/drawingml/2006/main" prst="rect">
+            <a:avLst/>
+          </a:prstGeom>
+          <a:solidFill xmlns:a="http://schemas.openxmlformats.org/drawingml/2006/main">
+            <a:srgbClr val="FBFCFA"/>
+          </a:solidFill>
+          <a:ln xmlns:a="http://schemas.openxmlformats.org/drawingml/2006/main" w="0">
+            <a:noFill/>
+            <a:prstDash val="solid"/>
+          </a:ln>
+        </p:spPr>
+      </p:sp>
+      <p:sp>
+        <p:nvSpPr>
+          <p:cNvPr id="45" name="">
+            <a:extLst xmlns:a="http://schemas.openxmlformats.org/drawingml/2006/main">
+              <a:ext uri="{FF2B5EF4-FFF2-40B4-BE49-F238E27FC236}">
+                <a16:creationId xmlns:a16="http://schemas.microsoft.com/office/drawing/2014/main" id="{A1CE3066-5D38-4773-A9BF-5B154C6C7168}"/>
+              </a:ext>
+            </a:extLst>
+          </p:cNvPr>
+          <p:cNvSpPr>
+            <a:spLocks xmlns:a="http://schemas.openxmlformats.org/drawingml/2006/main" noGrp="1"/>
+          </p:cNvSpPr>
+          <p:nvPr/>
+        </p:nvSpPr>
+        <p:spPr>
+          <a:xfrm xmlns:a="http://schemas.openxmlformats.org/drawingml/2006/main">
+            <a:off x="3638550" y="4152900"/>
+            <a:ext cx="1809750" cy="1295400"/>
+          </a:xfrm>
+          <a:prstGeom xmlns:a="http://schemas.openxmlformats.org/drawingml/2006/main" prst="rect">
+            <a:avLst/>
+          </a:prstGeom>
+          <a:solidFill xmlns:a="http://schemas.openxmlformats.org/drawingml/2006/main">
+            <a:srgbClr val="FBFCFA"/>
+          </a:solidFill>
+          <a:ln xmlns:a="http://schemas.openxmlformats.org/drawingml/2006/main" w="0">
+            <a:noFill/>
+            <a:prstDash val="solid"/>
+          </a:ln>
+        </p:spPr>
+      </p:sp>
+      <p:sp>
+        <p:nvSpPr>
+          <p:cNvPr id="46" name="">
+            <a:extLst xmlns:a="http://schemas.openxmlformats.org/drawingml/2006/main">
+              <a:ext uri="{FF2B5EF4-FFF2-40B4-BE49-F238E27FC236}">
+                <a16:creationId xmlns:a16="http://schemas.microsoft.com/office/drawing/2014/main" id="{46A53167-9BBE-49E5-8731-93BA12D6DD16}"/>
+              </a:ext>
+            </a:extLst>
+          </p:cNvPr>
+          <p:cNvSpPr>
+            <a:spLocks xmlns:a="http://schemas.openxmlformats.org/drawingml/2006/main" noGrp="1"/>
+          </p:cNvSpPr>
+          <p:nvPr/>
+        </p:nvSpPr>
+        <p:spPr>
+          <a:xfrm xmlns:a="http://schemas.openxmlformats.org/drawingml/2006/main">
+            <a:off x="8972550" y="4152900"/>
+            <a:ext cx="1809750" cy="1295400"/>
+          </a:xfrm>
+          <a:prstGeom xmlns:a="http://schemas.openxmlformats.org/drawingml/2006/main" prst="rect">
+            <a:avLst/>
+          </a:prstGeom>
+          <a:solidFill xmlns:a="http://schemas.openxmlformats.org/drawingml/2006/main">
+            <a:srgbClr val="FBFCFA"/>
+          </a:solidFill>
+          <a:ln xmlns:a="http://schemas.openxmlformats.org/drawingml/2006/main" w="0">
+            <a:noFill/>
+            <a:prstDash val="solid"/>
+          </a:ln>
+        </p:spPr>
+      </p:sp>
+      <p:sp>
+        <p:nvSpPr>
+          <p:cNvPr id="47" name="">
+            <a:extLst xmlns:a="http://schemas.openxmlformats.org/drawingml/2006/main">
+              <a:ext uri="{FF2B5EF4-FFF2-40B4-BE49-F238E27FC236}">
+                <a16:creationId xmlns:a16="http://schemas.microsoft.com/office/drawing/2014/main" id="{32B0F13E-A4FF-4E79-A8DB-A6971E834820}"/>
+              </a:ext>
+            </a:extLst>
+          </p:cNvPr>
+          <p:cNvSpPr>
+            <a:spLocks xmlns:a="http://schemas.openxmlformats.org/drawingml/2006/main" noGrp="1"/>
+          </p:cNvSpPr>
+          <p:nvPr/>
+        </p:nvSpPr>
+        <p:spPr>
+          <a:xfrm xmlns:a="http://schemas.openxmlformats.org/drawingml/2006/main">
+            <a:off x="3771900" y="2419350"/>
+            <a:ext cx="1524000" cy="419100"/>
+          </a:xfrm>
+          <a:prstGeom xmlns:a="http://schemas.openxmlformats.org/drawingml/2006/main" prst="roundRect">
+            <a:avLst>
+              <a:gd name="adj" fmla="val 18182"/>
+            </a:avLst>
+          </a:prstGeom>
+          <a:solidFill xmlns:a="http://schemas.openxmlformats.org/drawingml/2006/main">
+            <a:srgbClr val="F7FAF8"/>
+          </a:solidFill>
+          <a:ln xmlns:a="http://schemas.openxmlformats.org/drawingml/2006/main" w="13335">
+            <a:solidFill>
+              <a:srgbClr val="1F6B57"/>
+            </a:solidFill>
+            <a:prstDash val="dash"/>
+          </a:ln>
+        </p:spPr>
+      </p:sp>
+      <p:sp>
+        <p:nvSpPr>
+          <p:cNvPr id="48" name="">
+            <a:extLst xmlns:a="http://schemas.openxmlformats.org/drawingml/2006/main">
+              <a:ext uri="{FF2B5EF4-FFF2-40B4-BE49-F238E27FC236}">
+                <a16:creationId xmlns:a16="http://schemas.microsoft.com/office/drawing/2014/main" id="{3A8F63B7-2A5C-45C8-90A9-61F12F88DD0F}"/>
+              </a:ext>
+            </a:extLst>
+          </p:cNvPr>
+          <p:cNvSpPr>
+            <a:spLocks xmlns:a="http://schemas.openxmlformats.org/drawingml/2006/main" noGrp="1"/>
+          </p:cNvSpPr>
+          <p:nvPr/>
+        </p:nvSpPr>
+        <p:spPr>
+          <a:xfrm xmlns:a="http://schemas.openxmlformats.org/drawingml/2006/main">
+            <a:off x="3867150" y="2533650"/>
+            <a:ext cx="1333500" cy="190500"/>
+          </a:xfrm>
+          <a:prstGeom xmlns:a="http://schemas.openxmlformats.org/drawingml/2006/main" prst="rect">
+            <a:avLst/>
+          </a:prstGeom>
+          <a:noFill xmlns:a="http://schemas.openxmlformats.org/drawingml/2006/main"/>
+          <a:ln xmlns:a="http://schemas.openxmlformats.org/drawingml/2006/main" w="0">
+            <a:noFill/>
+            <a:prstDash val="solid"/>
+          </a:ln>
+        </p:spPr>
+        <p:txBody>
+          <a:bodyPr xmlns:a="http://schemas.openxmlformats.org/drawingml/2006/main"/>
+          <a:lstStyle xmlns:a="http://schemas.openxmlformats.org/drawingml/2006/main"/>
+          <a:p xmlns:a="http://schemas.openxmlformats.org/drawingml/2006/main">
+            <a:pPr algn="ctr">
+              <a:buNone/>
+              <a:defRPr sz="863" b="1">
+                <a:solidFill>
+                  <a:srgbClr val="1F6B57"/>
+                </a:solidFill>
+                <a:latin typeface="Microsoft YaHei"/>
+                <a:ea typeface="Microsoft YaHei"/>
+                <a:cs typeface="Microsoft YaHei"/>
+              </a:defRPr>
+            </a:pPr>
+            <a:r>
+              <a:rPr sz="863" b="1">
+                <a:solidFill>
+                  <a:srgbClr val="1F6B57"/>
+                </a:solidFill>
+                <a:latin typeface="Microsoft YaHei"/>
+                <a:ea typeface="Microsoft YaHei"/>
+                <a:cs typeface="Microsoft YaHei"/>
+              </a:rPr>
+              <a:t>待补截图: 看板</a:t>
+            </a:r>
+          </a:p>
+        </p:txBody>
+      </p:sp>
+      <p:sp>
+        <p:nvSpPr>
+          <p:cNvPr id="49" name="">
+            <a:extLst xmlns:a="http://schemas.openxmlformats.org/drawingml/2006/main">
+              <a:ext uri="{FF2B5EF4-FFF2-40B4-BE49-F238E27FC236}">
+                <a16:creationId xmlns:a16="http://schemas.microsoft.com/office/drawing/2014/main" id="{B874F26A-7827-4968-AF99-40713586DE1B}"/>
+              </a:ext>
+            </a:extLst>
+          </p:cNvPr>
+          <p:cNvSpPr>
+            <a:spLocks xmlns:a="http://schemas.openxmlformats.org/drawingml/2006/main" noGrp="1"/>
+          </p:cNvSpPr>
+          <p:nvPr/>
+        </p:nvSpPr>
+        <p:spPr>
+          <a:xfrm xmlns:a="http://schemas.openxmlformats.org/drawingml/2006/main">
+            <a:off x="9105900" y="2419350"/>
+            <a:ext cx="1524000" cy="419100"/>
+          </a:xfrm>
+          <a:prstGeom xmlns:a="http://schemas.openxmlformats.org/drawingml/2006/main" prst="roundRect">
+            <a:avLst>
+              <a:gd name="adj" fmla="val 18182"/>
+            </a:avLst>
+          </a:prstGeom>
+          <a:solidFill xmlns:a="http://schemas.openxmlformats.org/drawingml/2006/main">
+            <a:srgbClr val="F7FAF8"/>
+          </a:solidFill>
+          <a:ln xmlns:a="http://schemas.openxmlformats.org/drawingml/2006/main" w="13335">
+            <a:solidFill>
+              <a:srgbClr val="1F6B57"/>
+            </a:solidFill>
+            <a:prstDash val="dash"/>
+          </a:ln>
+        </p:spPr>
+      </p:sp>
+      <p:sp>
+        <p:nvSpPr>
+          <p:cNvPr id="50" name="">
+            <a:extLst xmlns:a="http://schemas.openxmlformats.org/drawingml/2006/main">
+              <a:ext uri="{FF2B5EF4-FFF2-40B4-BE49-F238E27FC236}">
+                <a16:creationId xmlns:a16="http://schemas.microsoft.com/office/drawing/2014/main" id="{E5B7365F-EDC3-43B7-A804-A7E803F5B99E}"/>
+              </a:ext>
+            </a:extLst>
+          </p:cNvPr>
+          <p:cNvSpPr>
+            <a:spLocks xmlns:a="http://schemas.openxmlformats.org/drawingml/2006/main" noGrp="1"/>
+          </p:cNvSpPr>
+          <p:nvPr/>
+        </p:nvSpPr>
+        <p:spPr>
+          <a:xfrm xmlns:a="http://schemas.openxmlformats.org/drawingml/2006/main">
+            <a:off x="9201150" y="2533650"/>
+            <a:ext cx="1333500" cy="190500"/>
+          </a:xfrm>
+          <a:prstGeom xmlns:a="http://schemas.openxmlformats.org/drawingml/2006/main" prst="rect">
+            <a:avLst/>
+          </a:prstGeom>
+          <a:noFill xmlns:a="http://schemas.openxmlformats.org/drawingml/2006/main"/>
+          <a:ln xmlns:a="http://schemas.openxmlformats.org/drawingml/2006/main" w="0">
+            <a:noFill/>
+            <a:prstDash val="solid"/>
+          </a:ln>
+        </p:spPr>
+        <p:txBody>
+          <a:bodyPr xmlns:a="http://schemas.openxmlformats.org/drawingml/2006/main"/>
+          <a:lstStyle xmlns:a="http://schemas.openxmlformats.org/drawingml/2006/main"/>
+          <a:p xmlns:a="http://schemas.openxmlformats.org/drawingml/2006/main">
+            <a:pPr algn="ctr">
+              <a:buNone/>
+              <a:defRPr sz="863" b="1">
+                <a:solidFill>
+                  <a:srgbClr val="1F6B57"/>
+                </a:solidFill>
+                <a:latin typeface="Microsoft YaHei"/>
+                <a:ea typeface="Microsoft YaHei"/>
+                <a:cs typeface="Microsoft YaHei"/>
+              </a:defRPr>
+            </a:pPr>
+            <a:r>
+              <a:rPr sz="863" b="1">
+                <a:solidFill>
+                  <a:srgbClr val="1F6B57"/>
+                </a:solidFill>
+                <a:latin typeface="Microsoft YaHei"/>
+                <a:ea typeface="Microsoft YaHei"/>
+                <a:cs typeface="Microsoft YaHei"/>
+              </a:rPr>
+              <a:t>待补截图: 设备</a:t>
+            </a:r>
+          </a:p>
+        </p:txBody>
+      </p:sp>
+      <p:sp>
+        <p:nvSpPr>
+          <p:cNvPr id="51" name="">
+            <a:extLst xmlns:a="http://schemas.openxmlformats.org/drawingml/2006/main">
+              <a:ext uri="{FF2B5EF4-FFF2-40B4-BE49-F238E27FC236}">
+                <a16:creationId xmlns:a16="http://schemas.microsoft.com/office/drawing/2014/main" id="{9640459B-CA8E-45DE-9514-5B38DB331532}"/>
+              </a:ext>
+            </a:extLst>
+          </p:cNvPr>
+          <p:cNvSpPr>
+            <a:spLocks xmlns:a="http://schemas.openxmlformats.org/drawingml/2006/main" noGrp="1"/>
+          </p:cNvSpPr>
+          <p:nvPr/>
+        </p:nvSpPr>
+        <p:spPr>
+          <a:xfrm xmlns:a="http://schemas.openxmlformats.org/drawingml/2006/main">
+            <a:off x="3771900" y="4286250"/>
+            <a:ext cx="1524000" cy="419100"/>
+          </a:xfrm>
+          <a:prstGeom xmlns:a="http://schemas.openxmlformats.org/drawingml/2006/main" prst="roundRect">
+            <a:avLst>
+              <a:gd name="adj" fmla="val 18182"/>
+            </a:avLst>
+          </a:prstGeom>
+          <a:solidFill xmlns:a="http://schemas.openxmlformats.org/drawingml/2006/main">
+            <a:srgbClr val="F7FAF8"/>
+          </a:solidFill>
+          <a:ln xmlns:a="http://schemas.openxmlformats.org/drawingml/2006/main" w="13335">
+            <a:solidFill>
+              <a:srgbClr val="1F6B57"/>
+            </a:solidFill>
+            <a:prstDash val="dash"/>
+          </a:ln>
+        </p:spPr>
+      </p:sp>
+      <p:sp>
+        <p:nvSpPr>
+          <p:cNvPr id="52" name="">
+            <a:extLst xmlns:a="http://schemas.openxmlformats.org/drawingml/2006/main">
+              <a:ext uri="{FF2B5EF4-FFF2-40B4-BE49-F238E27FC236}">
+                <a16:creationId xmlns:a16="http://schemas.microsoft.com/office/drawing/2014/main" id="{C0E9C336-411A-4967-B916-BED28E08025B}"/>
+              </a:ext>
+            </a:extLst>
+          </p:cNvPr>
+          <p:cNvSpPr>
+            <a:spLocks xmlns:a="http://schemas.openxmlformats.org/drawingml/2006/main" noGrp="1"/>
+          </p:cNvSpPr>
+          <p:nvPr/>
+        </p:nvSpPr>
+        <p:spPr>
+          <a:xfrm xmlns:a="http://schemas.openxmlformats.org/drawingml/2006/main">
+            <a:off x="3867150" y="4400550"/>
+            <a:ext cx="1333500" cy="190500"/>
+          </a:xfrm>
+          <a:prstGeom xmlns:a="http://schemas.openxmlformats.org/drawingml/2006/main" prst="rect">
+            <a:avLst/>
+          </a:prstGeom>
+          <a:noFill xmlns:a="http://schemas.openxmlformats.org/drawingml/2006/main"/>
+          <a:ln xmlns:a="http://schemas.openxmlformats.org/drawingml/2006/main" w="0">
+            <a:noFill/>
+            <a:prstDash val="solid"/>
+          </a:ln>
+        </p:spPr>
+        <p:txBody>
+          <a:bodyPr xmlns:a="http://schemas.openxmlformats.org/drawingml/2006/main"/>
+          <a:lstStyle xmlns:a="http://schemas.openxmlformats.org/drawingml/2006/main"/>
+          <a:p xmlns:a="http://schemas.openxmlformats.org/drawingml/2006/main">
+            <a:pPr algn="ctr">
+              <a:buNone/>
+              <a:defRPr sz="863" b="1">
+                <a:solidFill>
+                  <a:srgbClr val="1F6B57"/>
+                </a:solidFill>
+                <a:latin typeface="Microsoft YaHei"/>
+                <a:ea typeface="Microsoft YaHei"/>
+                <a:cs typeface="Microsoft YaHei"/>
+              </a:defRPr>
+            </a:pPr>
+            <a:r>
+              <a:rPr sz="863" b="1">
+                <a:solidFill>
+                  <a:srgbClr val="1F6B57"/>
+                </a:solidFill>
+                <a:latin typeface="Microsoft YaHei"/>
+                <a:ea typeface="Microsoft YaHei"/>
+                <a:cs typeface="Microsoft YaHei"/>
+              </a:rPr>
+              <a:t>待补截图: 诊断</a:t>
+            </a:r>
+          </a:p>
+        </p:txBody>
+      </p:sp>
+      <p:sp>
+        <p:nvSpPr>
+          <p:cNvPr id="53" name="">
+            <a:extLst xmlns:a="http://schemas.openxmlformats.org/drawingml/2006/main">
+              <a:ext uri="{FF2B5EF4-FFF2-40B4-BE49-F238E27FC236}">
+                <a16:creationId xmlns:a16="http://schemas.microsoft.com/office/drawing/2014/main" id="{B76623B8-A867-4237-A119-645B86C1E528}"/>
+              </a:ext>
+            </a:extLst>
+          </p:cNvPr>
+          <p:cNvSpPr>
+            <a:spLocks xmlns:a="http://schemas.openxmlformats.org/drawingml/2006/main" noGrp="1"/>
+          </p:cNvSpPr>
+          <p:nvPr/>
+        </p:nvSpPr>
+        <p:spPr>
+          <a:xfrm xmlns:a="http://schemas.openxmlformats.org/drawingml/2006/main">
+            <a:off x="9105900" y="4286250"/>
+            <a:ext cx="1524000" cy="419100"/>
+          </a:xfrm>
+          <a:prstGeom xmlns:a="http://schemas.openxmlformats.org/drawingml/2006/main" prst="roundRect">
+            <a:avLst>
+              <a:gd name="adj" fmla="val 18182"/>
+            </a:avLst>
+          </a:prstGeom>
+          <a:solidFill xmlns:a="http://schemas.openxmlformats.org/drawingml/2006/main">
+            <a:srgbClr val="F7FAF8"/>
+          </a:solidFill>
+          <a:ln xmlns:a="http://schemas.openxmlformats.org/drawingml/2006/main" w="13335">
+            <a:solidFill>
+              <a:srgbClr val="1F6B57"/>
+            </a:solidFill>
+            <a:prstDash val="dash"/>
+          </a:ln>
+        </p:spPr>
+      </p:sp>
+      <p:sp>
+        <p:nvSpPr>
+          <p:cNvPr id="54" name="">
+            <a:extLst xmlns:a="http://schemas.openxmlformats.org/drawingml/2006/main">
+              <a:ext uri="{FF2B5EF4-FFF2-40B4-BE49-F238E27FC236}">
+                <a16:creationId xmlns:a16="http://schemas.microsoft.com/office/drawing/2014/main" id="{D179521C-F4F4-46FE-B165-EE361117F040}"/>
+              </a:ext>
+            </a:extLst>
+          </p:cNvPr>
+          <p:cNvSpPr>
+            <a:spLocks xmlns:a="http://schemas.openxmlformats.org/drawingml/2006/main" noGrp="1"/>
+          </p:cNvSpPr>
+          <p:nvPr/>
+        </p:nvSpPr>
+        <p:spPr>
+          <a:xfrm xmlns:a="http://schemas.openxmlformats.org/drawingml/2006/main">
+            <a:off x="9201150" y="4400550"/>
+            <a:ext cx="1333500" cy="190500"/>
+          </a:xfrm>
+          <a:prstGeom xmlns:a="http://schemas.openxmlformats.org/drawingml/2006/main" prst="rect">
+            <a:avLst/>
+          </a:prstGeom>
+          <a:noFill xmlns:a="http://schemas.openxmlformats.org/drawingml/2006/main"/>
+          <a:ln xmlns:a="http://schemas.openxmlformats.org/drawingml/2006/main" w="0">
+            <a:noFill/>
+            <a:prstDash val="solid"/>
+          </a:ln>
+        </p:spPr>
+        <p:txBody>
+          <a:bodyPr xmlns:a="http://schemas.openxmlformats.org/drawingml/2006/main"/>
+          <a:lstStyle xmlns:a="http://schemas.openxmlformats.org/drawingml/2006/main"/>
+          <a:p xmlns:a="http://schemas.openxmlformats.org/drawingml/2006/main">
+            <a:pPr algn="ctr">
+              <a:buNone/>
+              <a:defRPr sz="863" b="1">
+                <a:solidFill>
+                  <a:srgbClr val="1F6B57"/>
+                </a:solidFill>
+                <a:latin typeface="Microsoft YaHei"/>
+                <a:ea typeface="Microsoft YaHei"/>
+                <a:cs typeface="Microsoft YaHei"/>
+              </a:defRPr>
+            </a:pPr>
+            <a:r>
+              <a:rPr sz="863" b="1">
+                <a:solidFill>
+                  <a:srgbClr val="1F6B57"/>
+                </a:solidFill>
+                <a:latin typeface="Microsoft YaHei"/>
+                <a:ea typeface="Microsoft YaHei"/>
+                <a:cs typeface="Microsoft YaHei"/>
+              </a:rPr>
+              <a:t>待补截图: 工单</a:t>
+            </a:r>
+          </a:p>
+        </p:txBody>
+      </p:sp>
+      <p:sp>
+        <p:nvSpPr>
+          <p:cNvPr id="55" name="">
+            <a:extLst xmlns:a="http://schemas.openxmlformats.org/drawingml/2006/main">
+              <a:ext uri="{FF2B5EF4-FFF2-40B4-BE49-F238E27FC236}">
+                <a16:creationId xmlns:a16="http://schemas.microsoft.com/office/drawing/2014/main" id="{F0522483-D96B-45A0-880C-176B085F7A94}"/>
+              </a:ext>
+            </a:extLst>
+          </p:cNvPr>
+          <p:cNvSpPr>
+            <a:spLocks xmlns:a="http://schemas.openxmlformats.org/drawingml/2006/main" noGrp="1"/>
+          </p:cNvSpPr>
+          <p:nvPr/>
+        </p:nvSpPr>
+        <p:spPr>
+          <a:xfrm xmlns:a="http://schemas.openxmlformats.org/drawingml/2006/main">
+            <a:off x="4667250" y="5334000"/>
+            <a:ext cx="419100" cy="285750"/>
+          </a:xfrm>
+          <a:prstGeom xmlns:a="http://schemas.openxmlformats.org/drawingml/2006/main" prst="rect">
+            <a:avLst/>
+          </a:prstGeom>
+          <a:solidFill xmlns:a="http://schemas.openxmlformats.org/drawingml/2006/main">
+            <a:srgbClr val="FBFCFA"/>
+          </a:solidFill>
+          <a:ln xmlns:a="http://schemas.openxmlformats.org/drawingml/2006/main" w="0">
+            <a:noFill/>
+            <a:prstDash val="solid"/>
+          </a:ln>
+        </p:spPr>
+      </p:sp>
+      <p:sp>
+        <p:nvSpPr>
+          <p:cNvPr id="56" name="">
+            <a:extLst xmlns:a="http://schemas.openxmlformats.org/drawingml/2006/main">
+              <a:ext uri="{FF2B5EF4-FFF2-40B4-BE49-F238E27FC236}">
+                <a16:creationId xmlns:a16="http://schemas.microsoft.com/office/drawing/2014/main" id="{425A31C2-81AE-4EC1-B6A0-77C086E75A0D}"/>
+              </a:ext>
+            </a:extLst>
+          </p:cNvPr>
+          <p:cNvSpPr>
+            <a:spLocks xmlns:a="http://schemas.openxmlformats.org/drawingml/2006/main" noGrp="1"/>
+          </p:cNvSpPr>
+          <p:nvPr/>
+        </p:nvSpPr>
+        <p:spPr>
+          <a:xfrm xmlns:a="http://schemas.openxmlformats.org/drawingml/2006/main">
+            <a:off x="10001250" y="5334000"/>
+            <a:ext cx="419100" cy="285750"/>
+          </a:xfrm>
+          <a:prstGeom xmlns:a="http://schemas.openxmlformats.org/drawingml/2006/main" prst="rect">
+            <a:avLst/>
+          </a:prstGeom>
+          <a:solidFill xmlns:a="http://schemas.openxmlformats.org/drawingml/2006/main">
+            <a:srgbClr val="FBFCFA"/>
+          </a:solidFill>
+          <a:ln xmlns:a="http://schemas.openxmlformats.org/drawingml/2006/main" w="0">
+            <a:noFill/>
+            <a:prstDash val="solid"/>
+          </a:ln>
+        </p:spPr>
       </p:sp>
     </p:spTree>
     <p:extLst>
@@ -5914,6 +7339,7 @@
           <a:lstStyle xmlns:a="http://schemas.openxmlformats.org/drawingml/2006/main"/>
           <a:p xmlns:a="http://schemas.openxmlformats.org/drawingml/2006/main">
             <a:pPr algn="l">
+              <a:buNone/>
               <a:defRPr sz="975" b="1">
                 <a:solidFill>
                   <a:srgbClr val="C47A2C"/>
@@ -5970,6 +7396,7 @@
           <a:lstStyle xmlns:a="http://schemas.openxmlformats.org/drawingml/2006/main"/>
           <a:p xmlns:a="http://schemas.openxmlformats.org/drawingml/2006/main">
             <a:pPr algn="l">
+              <a:buNone/>
               <a:defRPr sz="2175" b="1">
                 <a:solidFill>
                   <a:srgbClr val="17211F"/>
@@ -6026,6 +7453,7 @@
           <a:lstStyle xmlns:a="http://schemas.openxmlformats.org/drawingml/2006/main"/>
           <a:p xmlns:a="http://schemas.openxmlformats.org/drawingml/2006/main">
             <a:pPr algn="l">
+              <a:buNone/>
               <a:defRPr sz="1200" b="0">
                 <a:solidFill>
                   <a:srgbClr val="65716D"/>
@@ -6218,6 +7646,7 @@
           <a:lstStyle xmlns:a="http://schemas.openxmlformats.org/drawingml/2006/main"/>
           <a:p xmlns:a="http://schemas.openxmlformats.org/drawingml/2006/main">
             <a:pPr algn="ctr">
+              <a:buNone/>
               <a:defRPr sz="1800" b="1">
                 <a:solidFill>
                   <a:srgbClr val="1F6B57"/>
@@ -6274,6 +7703,7 @@
           <a:lstStyle xmlns:a="http://schemas.openxmlformats.org/drawingml/2006/main"/>
           <a:p xmlns:a="http://schemas.openxmlformats.org/drawingml/2006/main">
             <a:pPr algn="ctr">
+              <a:buNone/>
               <a:defRPr sz="1800" b="1">
                 <a:solidFill>
                   <a:srgbClr val="218A8A"/>
@@ -6330,6 +7760,7 @@
           <a:lstStyle xmlns:a="http://schemas.openxmlformats.org/drawingml/2006/main"/>
           <a:p xmlns:a="http://schemas.openxmlformats.org/drawingml/2006/main">
             <a:pPr algn="ctr">
+              <a:buNone/>
               <a:defRPr sz="1800" b="1">
                 <a:solidFill>
                   <a:srgbClr val="C47A2C"/>
@@ -6417,6 +7848,7 @@
           <a:lstStyle xmlns:a="http://schemas.openxmlformats.org/drawingml/2006/main"/>
           <a:p xmlns:a="http://schemas.openxmlformats.org/drawingml/2006/main">
             <a:pPr algn="l">
+              <a:buNone/>
               <a:defRPr sz="1125" b="0">
                 <a:solidFill>
                   <a:srgbClr val="17211F"/>
@@ -6504,6 +7936,7 @@
           <a:lstStyle xmlns:a="http://schemas.openxmlformats.org/drawingml/2006/main"/>
           <a:p xmlns:a="http://schemas.openxmlformats.org/drawingml/2006/main">
             <a:pPr algn="l">
+              <a:buNone/>
               <a:defRPr sz="1125" b="0">
                 <a:solidFill>
                   <a:srgbClr val="17211F"/>
@@ -6591,6 +8024,7 @@
           <a:lstStyle xmlns:a="http://schemas.openxmlformats.org/drawingml/2006/main"/>
           <a:p xmlns:a="http://schemas.openxmlformats.org/drawingml/2006/main">
             <a:pPr algn="l">
+              <a:buNone/>
               <a:defRPr sz="1125" b="0">
                 <a:solidFill>
                   <a:srgbClr val="17211F"/>
@@ -6678,6 +8112,7 @@
           <a:lstStyle xmlns:a="http://schemas.openxmlformats.org/drawingml/2006/main"/>
           <a:p xmlns:a="http://schemas.openxmlformats.org/drawingml/2006/main">
             <a:pPr algn="l">
+              <a:buNone/>
               <a:defRPr sz="1125" b="0">
                 <a:solidFill>
                   <a:srgbClr val="17211F"/>
@@ -6765,6 +8200,7 @@
           <a:lstStyle xmlns:a="http://schemas.openxmlformats.org/drawingml/2006/main"/>
           <a:p xmlns:a="http://schemas.openxmlformats.org/drawingml/2006/main">
             <a:pPr algn="l">
+              <a:buNone/>
               <a:defRPr sz="1125" b="0">
                 <a:solidFill>
                   <a:srgbClr val="17211F"/>
@@ -6852,6 +8288,7 @@
           <a:lstStyle xmlns:a="http://schemas.openxmlformats.org/drawingml/2006/main"/>
           <a:p xmlns:a="http://schemas.openxmlformats.org/drawingml/2006/main">
             <a:pPr algn="l">
+              <a:buNone/>
               <a:defRPr sz="1125" b="0">
                 <a:solidFill>
                   <a:srgbClr val="17211F"/>
@@ -6939,6 +8376,7 @@
           <a:lstStyle xmlns:a="http://schemas.openxmlformats.org/drawingml/2006/main"/>
           <a:p xmlns:a="http://schemas.openxmlformats.org/drawingml/2006/main">
             <a:pPr algn="l">
+              <a:buNone/>
               <a:defRPr sz="1125" b="0">
                 <a:solidFill>
                   <a:srgbClr val="17211F"/>
@@ -7026,6 +8464,7 @@
           <a:lstStyle xmlns:a="http://schemas.openxmlformats.org/drawingml/2006/main"/>
           <a:p xmlns:a="http://schemas.openxmlformats.org/drawingml/2006/main">
             <a:pPr algn="l">
+              <a:buNone/>
               <a:defRPr sz="1125" b="0">
                 <a:solidFill>
                   <a:srgbClr val="17211F"/>
@@ -7113,6 +8552,7 @@
           <a:lstStyle xmlns:a="http://schemas.openxmlformats.org/drawingml/2006/main"/>
           <a:p xmlns:a="http://schemas.openxmlformats.org/drawingml/2006/main">
             <a:pPr algn="l">
+              <a:buNone/>
               <a:defRPr sz="1125" b="0">
                 <a:solidFill>
                   <a:srgbClr val="17211F"/>
@@ -7200,6 +8640,7 @@
           <a:lstStyle xmlns:a="http://schemas.openxmlformats.org/drawingml/2006/main"/>
           <a:p xmlns:a="http://schemas.openxmlformats.org/drawingml/2006/main">
             <a:pPr algn="l">
+              <a:buNone/>
               <a:defRPr sz="1125" b="0">
                 <a:solidFill>
                   <a:srgbClr val="17211F"/>
@@ -7287,6 +8728,7 @@
           <a:lstStyle xmlns:a="http://schemas.openxmlformats.org/drawingml/2006/main"/>
           <a:p xmlns:a="http://schemas.openxmlformats.org/drawingml/2006/main">
             <a:pPr algn="l">
+              <a:buNone/>
               <a:defRPr sz="1125" b="0">
                 <a:solidFill>
                   <a:srgbClr val="17211F"/>
@@ -7374,6 +8816,7 @@
           <a:lstStyle xmlns:a="http://schemas.openxmlformats.org/drawingml/2006/main"/>
           <a:p xmlns:a="http://schemas.openxmlformats.org/drawingml/2006/main">
             <a:pPr algn="l">
+              <a:buNone/>
               <a:defRPr sz="1125" b="0">
                 <a:solidFill>
                   <a:srgbClr val="17211F"/>
@@ -7461,6 +8904,7 @@
           <a:lstStyle xmlns:a="http://schemas.openxmlformats.org/drawingml/2006/main"/>
           <a:p xmlns:a="http://schemas.openxmlformats.org/drawingml/2006/main">
             <a:pPr algn="l">
+              <a:buNone/>
               <a:defRPr sz="1125" b="0">
                 <a:solidFill>
                   <a:srgbClr val="17211F"/>
@@ -7548,6 +8992,7 @@
           <a:lstStyle xmlns:a="http://schemas.openxmlformats.org/drawingml/2006/main"/>
           <a:p xmlns:a="http://schemas.openxmlformats.org/drawingml/2006/main">
             <a:pPr algn="l">
+              <a:buNone/>
               <a:defRPr sz="1125" b="0">
                 <a:solidFill>
                   <a:srgbClr val="17211F"/>
@@ -7666,6 +9111,7 @@
           <a:lstStyle xmlns:a="http://schemas.openxmlformats.org/drawingml/2006/main"/>
           <a:p xmlns:a="http://schemas.openxmlformats.org/drawingml/2006/main">
             <a:pPr algn="ctr">
+              <a:buNone/>
               <a:defRPr sz="1500" b="1">
                 <a:solidFill>
                   <a:srgbClr val="17211F"/>
@@ -7722,6 +9168,7 @@
           <a:lstStyle xmlns:a="http://schemas.openxmlformats.org/drawingml/2006/main"/>
           <a:p xmlns:a="http://schemas.openxmlformats.org/drawingml/2006/main">
             <a:pPr algn="l">
+              <a:buNone/>
               <a:defRPr sz="750" b="0">
                 <a:solidFill>
                   <a:srgbClr val="65716D"/>
@@ -7741,6 +9188,212 @@
                 <a:cs typeface="Microsoft YaHei"/>
               </a:rPr>
               <a:t>作品集用途：求职面试 / 产品经理能力证明；所有指标以可公开证据为准</a:t>
+            </a:r>
+          </a:p>
+        </p:txBody>
+      </p:sp>
+      <p:sp>
+        <p:nvSpPr>
+          <p:cNvPr id="43" name="material-slot-Vibe Coding过程证据">
+            <a:extLst xmlns:a="http://schemas.openxmlformats.org/drawingml/2006/main">
+              <a:ext uri="{FF2B5EF4-FFF2-40B4-BE49-F238E27FC236}">
+                <a16:creationId xmlns:a16="http://schemas.microsoft.com/office/drawing/2014/main" id="{3E9AD099-7772-423B-8BC3-7593CC1DAB0C}"/>
+              </a:ext>
+            </a:extLst>
+          </p:cNvPr>
+          <p:cNvSpPr>
+            <a:spLocks xmlns:a="http://schemas.openxmlformats.org/drawingml/2006/main" noGrp="1"/>
+          </p:cNvSpPr>
+          <p:nvPr/>
+        </p:nvSpPr>
+        <p:spPr>
+          <a:xfrm xmlns:a="http://schemas.openxmlformats.org/drawingml/2006/main">
+            <a:off x="7829550" y="5162550"/>
+            <a:ext cx="3238500" cy="838200"/>
+          </a:xfrm>
+          <a:prstGeom xmlns:a="http://schemas.openxmlformats.org/drawingml/2006/main" prst="roundRect">
+            <a:avLst>
+              <a:gd name="adj" fmla="val 9091"/>
+            </a:avLst>
+          </a:prstGeom>
+          <a:solidFill xmlns:a="http://schemas.openxmlformats.org/drawingml/2006/main">
+            <a:srgbClr val="FFF8F1"/>
+          </a:solidFill>
+          <a:ln xmlns:a="http://schemas.openxmlformats.org/drawingml/2006/main" w="14288">
+            <a:solidFill>
+              <a:srgbClr val="C47A2C"/>
+            </a:solidFill>
+            <a:prstDash val="dash"/>
+          </a:ln>
+        </p:spPr>
+      </p:sp>
+      <p:sp>
+        <p:nvSpPr>
+          <p:cNvPr id="44" name="">
+            <a:extLst xmlns:a="http://schemas.openxmlformats.org/drawingml/2006/main">
+              <a:ext uri="{FF2B5EF4-FFF2-40B4-BE49-F238E27FC236}">
+                <a16:creationId xmlns:a16="http://schemas.microsoft.com/office/drawing/2014/main" id="{FAA4F1F9-BF61-4F34-9C6E-573EE85E8C44}"/>
+              </a:ext>
+            </a:extLst>
+          </p:cNvPr>
+          <p:cNvSpPr>
+            <a:spLocks xmlns:a="http://schemas.openxmlformats.org/drawingml/2006/main" noGrp="1"/>
+          </p:cNvSpPr>
+          <p:nvPr/>
+        </p:nvSpPr>
+        <p:spPr>
+          <a:xfrm xmlns:a="http://schemas.openxmlformats.org/drawingml/2006/main">
+            <a:off x="8001000" y="5295900"/>
+            <a:ext cx="781050" cy="228600"/>
+          </a:xfrm>
+          <a:prstGeom xmlns:a="http://schemas.openxmlformats.org/drawingml/2006/main" prst="rect">
+            <a:avLst/>
+          </a:prstGeom>
+          <a:noFill xmlns:a="http://schemas.openxmlformats.org/drawingml/2006/main"/>
+          <a:ln xmlns:a="http://schemas.openxmlformats.org/drawingml/2006/main" w="0">
+            <a:noFill/>
+            <a:prstDash val="solid"/>
+          </a:ln>
+        </p:spPr>
+        <p:txBody>
+          <a:bodyPr xmlns:a="http://schemas.openxmlformats.org/drawingml/2006/main"/>
+          <a:lstStyle xmlns:a="http://schemas.openxmlformats.org/drawingml/2006/main"/>
+          <a:p xmlns:a="http://schemas.openxmlformats.org/drawingml/2006/main">
+            <a:pPr>
+              <a:buNone/>
+              <a:defRPr sz="975" b="1">
+                <a:solidFill>
+                  <a:srgbClr val="C47A2C"/>
+                </a:solidFill>
+                <a:latin typeface="Microsoft YaHei"/>
+                <a:ea typeface="Microsoft YaHei"/>
+                <a:cs typeface="Microsoft YaHei"/>
+              </a:defRPr>
+            </a:pPr>
+            <a:r>
+              <a:rPr sz="975" b="1">
+                <a:solidFill>
+                  <a:srgbClr val="C47A2C"/>
+                </a:solidFill>
+                <a:latin typeface="Microsoft YaHei"/>
+                <a:ea typeface="Microsoft YaHei"/>
+                <a:cs typeface="Microsoft YaHei"/>
+              </a:rPr>
+              <a:t>待补充</a:t>
+            </a:r>
+          </a:p>
+        </p:txBody>
+      </p:sp>
+      <p:sp>
+        <p:nvSpPr>
+          <p:cNvPr id="45" name="">
+            <a:extLst xmlns:a="http://schemas.openxmlformats.org/drawingml/2006/main">
+              <a:ext uri="{FF2B5EF4-FFF2-40B4-BE49-F238E27FC236}">
+                <a16:creationId xmlns:a16="http://schemas.microsoft.com/office/drawing/2014/main" id="{70517643-8C80-4EC1-B096-95D82C9F14CC}"/>
+              </a:ext>
+            </a:extLst>
+          </p:cNvPr>
+          <p:cNvSpPr>
+            <a:spLocks xmlns:a="http://schemas.openxmlformats.org/drawingml/2006/main" noGrp="1"/>
+          </p:cNvSpPr>
+          <p:nvPr/>
+        </p:nvSpPr>
+        <p:spPr>
+          <a:xfrm xmlns:a="http://schemas.openxmlformats.org/drawingml/2006/main">
+            <a:off x="8801100" y="5276850"/>
+            <a:ext cx="2095500" cy="266700"/>
+          </a:xfrm>
+          <a:prstGeom xmlns:a="http://schemas.openxmlformats.org/drawingml/2006/main" prst="rect">
+            <a:avLst/>
+          </a:prstGeom>
+          <a:noFill xmlns:a="http://schemas.openxmlformats.org/drawingml/2006/main"/>
+          <a:ln xmlns:a="http://schemas.openxmlformats.org/drawingml/2006/main" w="0">
+            <a:noFill/>
+            <a:prstDash val="solid"/>
+          </a:ln>
+        </p:spPr>
+        <p:txBody>
+          <a:bodyPr xmlns:a="http://schemas.openxmlformats.org/drawingml/2006/main"/>
+          <a:lstStyle xmlns:a="http://schemas.openxmlformats.org/drawingml/2006/main"/>
+          <a:p xmlns:a="http://schemas.openxmlformats.org/drawingml/2006/main">
+            <a:pPr>
+              <a:buNone/>
+              <a:defRPr sz="1275" b="1">
+                <a:solidFill>
+                  <a:srgbClr val="1A2A26"/>
+                </a:solidFill>
+                <a:latin typeface="Microsoft YaHei"/>
+                <a:ea typeface="Microsoft YaHei"/>
+                <a:cs typeface="Microsoft YaHei"/>
+              </a:defRPr>
+            </a:pPr>
+            <a:r>
+              <a:rPr sz="1275" b="1">
+                <a:solidFill>
+                  <a:srgbClr val="1A2A26"/>
+                </a:solidFill>
+                <a:latin typeface="Microsoft YaHei"/>
+                <a:ea typeface="Microsoft YaHei"/>
+                <a:cs typeface="Microsoft YaHei"/>
+              </a:rPr>
+              <a:t>Vibe Coding过程证据</a:t>
+            </a:r>
+          </a:p>
+        </p:txBody>
+      </p:sp>
+      <p:sp>
+        <p:nvSpPr>
+          <p:cNvPr id="46" name="">
+            <a:extLst xmlns:a="http://schemas.openxmlformats.org/drawingml/2006/main">
+              <a:ext uri="{FF2B5EF4-FFF2-40B4-BE49-F238E27FC236}">
+                <a16:creationId xmlns:a16="http://schemas.microsoft.com/office/drawing/2014/main" id="{5998791E-F2A3-403C-B774-F1135D1F8D6B}"/>
+              </a:ext>
+            </a:extLst>
+          </p:cNvPr>
+          <p:cNvSpPr>
+            <a:spLocks xmlns:a="http://schemas.openxmlformats.org/drawingml/2006/main" noGrp="1"/>
+          </p:cNvSpPr>
+          <p:nvPr/>
+        </p:nvSpPr>
+        <p:spPr>
+          <a:xfrm xmlns:a="http://schemas.openxmlformats.org/drawingml/2006/main">
+            <a:off x="8001000" y="5562600"/>
+            <a:ext cx="2895600" cy="361950"/>
+          </a:xfrm>
+          <a:prstGeom xmlns:a="http://schemas.openxmlformats.org/drawingml/2006/main" prst="rect">
+            <a:avLst/>
+          </a:prstGeom>
+          <a:noFill xmlns:a="http://schemas.openxmlformats.org/drawingml/2006/main"/>
+          <a:ln xmlns:a="http://schemas.openxmlformats.org/drawingml/2006/main" w="0">
+            <a:noFill/>
+            <a:prstDash val="solid"/>
+          </a:ln>
+        </p:spPr>
+        <p:txBody>
+          <a:bodyPr xmlns:a="http://schemas.openxmlformats.org/drawingml/2006/main"/>
+          <a:lstStyle xmlns:a="http://schemas.openxmlformats.org/drawingml/2006/main"/>
+          <a:p xmlns:a="http://schemas.openxmlformats.org/drawingml/2006/main">
+            <a:pPr>
+              <a:buNone/>
+              <a:defRPr sz="938">
+                <a:solidFill>
+                  <a:srgbClr val="6B746F"/>
+                </a:solidFill>
+                <a:latin typeface="Microsoft YaHei"/>
+                <a:ea typeface="Microsoft YaHei"/>
+                <a:cs typeface="Microsoft YaHei"/>
+              </a:defRPr>
+            </a:pPr>
+            <a:r>
+              <a:rPr sz="938">
+                <a:solidFill>
+                  <a:srgbClr val="6B746F"/>
+                </a:solidFill>
+                <a:latin typeface="Microsoft YaHei"/>
+                <a:ea typeface="Microsoft YaHei"/>
+                <a:cs typeface="Microsoft YaHei"/>
+              </a:rPr>
+              <a:t>PRD输入、原型迭代、问题清单、研发对齐材料截图</a:t>
             </a:r>
           </a:p>
         </p:txBody>
@@ -7807,6 +9460,7 @@
           <a:lstStyle xmlns:a="http://schemas.openxmlformats.org/drawingml/2006/main"/>
           <a:p xmlns:a="http://schemas.openxmlformats.org/drawingml/2006/main">
             <a:pPr algn="l">
+              <a:buNone/>
               <a:defRPr sz="975" b="1">
                 <a:solidFill>
                   <a:srgbClr val="C47A2C"/>
@@ -7863,6 +9517,7 @@
           <a:lstStyle xmlns:a="http://schemas.openxmlformats.org/drawingml/2006/main"/>
           <a:p xmlns:a="http://schemas.openxmlformats.org/drawingml/2006/main">
             <a:pPr algn="l">
+              <a:buNone/>
               <a:defRPr sz="2175" b="1">
                 <a:solidFill>
                   <a:srgbClr val="17211F"/>
@@ -7919,6 +9574,7 @@
           <a:lstStyle xmlns:a="http://schemas.openxmlformats.org/drawingml/2006/main"/>
           <a:p xmlns:a="http://schemas.openxmlformats.org/drawingml/2006/main">
             <a:pPr algn="l">
+              <a:buNone/>
               <a:defRPr sz="1200" b="0">
                 <a:solidFill>
                   <a:srgbClr val="65716D"/>
@@ -8041,6 +9697,7 @@
           <a:lstStyle xmlns:a="http://schemas.openxmlformats.org/drawingml/2006/main"/>
           <a:p xmlns:a="http://schemas.openxmlformats.org/drawingml/2006/main">
             <a:pPr algn="ctr">
+              <a:buNone/>
               <a:defRPr sz="1050" b="1">
                 <a:solidFill>
                   <a:srgbClr val="17211F"/>
@@ -8163,6 +9820,7 @@
           <a:lstStyle xmlns:a="http://schemas.openxmlformats.org/drawingml/2006/main"/>
           <a:p xmlns:a="http://schemas.openxmlformats.org/drawingml/2006/main">
             <a:pPr algn="ctr">
+              <a:buNone/>
               <a:defRPr sz="1050" b="1">
                 <a:solidFill>
                   <a:srgbClr val="17211F"/>
@@ -8285,6 +9943,7 @@
           <a:lstStyle xmlns:a="http://schemas.openxmlformats.org/drawingml/2006/main"/>
           <a:p xmlns:a="http://schemas.openxmlformats.org/drawingml/2006/main">
             <a:pPr algn="ctr">
+              <a:buNone/>
               <a:defRPr sz="1050" b="1">
                 <a:solidFill>
                   <a:srgbClr val="17211F"/>
@@ -8407,6 +10066,7 @@
           <a:lstStyle xmlns:a="http://schemas.openxmlformats.org/drawingml/2006/main"/>
           <a:p xmlns:a="http://schemas.openxmlformats.org/drawingml/2006/main">
             <a:pPr algn="ctr">
+              <a:buNone/>
               <a:defRPr sz="1050" b="1">
                 <a:solidFill>
                   <a:srgbClr val="17211F"/>
@@ -8529,6 +10189,7 @@
           <a:lstStyle xmlns:a="http://schemas.openxmlformats.org/drawingml/2006/main"/>
           <a:p xmlns:a="http://schemas.openxmlformats.org/drawingml/2006/main">
             <a:pPr algn="ctr">
+              <a:buNone/>
               <a:defRPr sz="1050" b="1">
                 <a:solidFill>
                   <a:srgbClr val="17211F"/>
@@ -8651,6 +10312,7 @@
           <a:lstStyle xmlns:a="http://schemas.openxmlformats.org/drawingml/2006/main"/>
           <a:p xmlns:a="http://schemas.openxmlformats.org/drawingml/2006/main">
             <a:pPr algn="ctr">
+              <a:buNone/>
               <a:defRPr sz="1050" b="1">
                 <a:solidFill>
                   <a:srgbClr val="17211F"/>
@@ -8773,6 +10435,7 @@
           <a:lstStyle xmlns:a="http://schemas.openxmlformats.org/drawingml/2006/main"/>
           <a:p xmlns:a="http://schemas.openxmlformats.org/drawingml/2006/main">
             <a:pPr algn="l">
+              <a:buNone/>
               <a:defRPr sz="1350" b="0">
                 <a:solidFill>
                   <a:srgbClr val="17211F"/>
@@ -8860,6 +10523,7 @@
           <a:lstStyle xmlns:a="http://schemas.openxmlformats.org/drawingml/2006/main"/>
           <a:p xmlns:a="http://schemas.openxmlformats.org/drawingml/2006/main">
             <a:pPr algn="l">
+              <a:buNone/>
               <a:defRPr sz="1350" b="0">
                 <a:solidFill>
                   <a:srgbClr val="17211F"/>
@@ -8947,6 +10611,7 @@
           <a:lstStyle xmlns:a="http://schemas.openxmlformats.org/drawingml/2006/main"/>
           <a:p xmlns:a="http://schemas.openxmlformats.org/drawingml/2006/main">
             <a:pPr algn="l">
+              <a:buNone/>
               <a:defRPr sz="1350" b="0">
                 <a:solidFill>
                   <a:srgbClr val="17211F"/>
@@ -9003,6 +10668,7 @@
           <a:lstStyle xmlns:a="http://schemas.openxmlformats.org/drawingml/2006/main"/>
           <a:p xmlns:a="http://schemas.openxmlformats.org/drawingml/2006/main">
             <a:pPr algn="ctr">
+              <a:buNone/>
               <a:defRPr sz="1500" b="1">
                 <a:solidFill>
                   <a:srgbClr val="1F6B57"/>
@@ -9059,6 +10725,7 @@
           <a:lstStyle xmlns:a="http://schemas.openxmlformats.org/drawingml/2006/main"/>
           <a:p xmlns:a="http://schemas.openxmlformats.org/drawingml/2006/main">
             <a:pPr algn="l">
+              <a:buNone/>
               <a:defRPr sz="750" b="0">
                 <a:solidFill>
                   <a:srgbClr val="65716D"/>
@@ -9078,6 +10745,212 @@
                 <a:cs typeface="Microsoft YaHei"/>
               </a:rPr>
               <a:t>作品集用途：求职面试 / 产品经理能力证明；所有指标以可公开证据为准</a:t>
+            </a:r>
+          </a:p>
+        </p:txBody>
+      </p:sp>
+      <p:sp>
+        <p:nvSpPr>
+          <p:cNvPr id="31" name="material-slot-支撑案例资料截图">
+            <a:extLst xmlns:a="http://schemas.openxmlformats.org/drawingml/2006/main">
+              <a:ext uri="{FF2B5EF4-FFF2-40B4-BE49-F238E27FC236}">
+                <a16:creationId xmlns:a16="http://schemas.microsoft.com/office/drawing/2014/main" id="{AAD5F356-25ED-4A23-826C-E958C7D2EA44}"/>
+              </a:ext>
+            </a:extLst>
+          </p:cNvPr>
+          <p:cNvSpPr>
+            <a:spLocks xmlns:a="http://schemas.openxmlformats.org/drawingml/2006/main" noGrp="1"/>
+          </p:cNvSpPr>
+          <p:nvPr/>
+        </p:nvSpPr>
+        <p:spPr>
+          <a:xfrm xmlns:a="http://schemas.openxmlformats.org/drawingml/2006/main">
+            <a:off x="7829550" y="5162550"/>
+            <a:ext cx="3238500" cy="838200"/>
+          </a:xfrm>
+          <a:prstGeom xmlns:a="http://schemas.openxmlformats.org/drawingml/2006/main" prst="roundRect">
+            <a:avLst>
+              <a:gd name="adj" fmla="val 9091"/>
+            </a:avLst>
+          </a:prstGeom>
+          <a:solidFill xmlns:a="http://schemas.openxmlformats.org/drawingml/2006/main">
+            <a:srgbClr val="F7FAF8"/>
+          </a:solidFill>
+          <a:ln xmlns:a="http://schemas.openxmlformats.org/drawingml/2006/main" w="14288">
+            <a:solidFill>
+              <a:srgbClr val="1F6B57"/>
+            </a:solidFill>
+            <a:prstDash val="dash"/>
+          </a:ln>
+        </p:spPr>
+      </p:sp>
+      <p:sp>
+        <p:nvSpPr>
+          <p:cNvPr id="32" name="">
+            <a:extLst xmlns:a="http://schemas.openxmlformats.org/drawingml/2006/main">
+              <a:ext uri="{FF2B5EF4-FFF2-40B4-BE49-F238E27FC236}">
+                <a16:creationId xmlns:a16="http://schemas.microsoft.com/office/drawing/2014/main" id="{D01FEE1B-C499-4AF9-A8C3-5EE81AE00E49}"/>
+              </a:ext>
+            </a:extLst>
+          </p:cNvPr>
+          <p:cNvSpPr>
+            <a:spLocks xmlns:a="http://schemas.openxmlformats.org/drawingml/2006/main" noGrp="1"/>
+          </p:cNvSpPr>
+          <p:nvPr/>
+        </p:nvSpPr>
+        <p:spPr>
+          <a:xfrm xmlns:a="http://schemas.openxmlformats.org/drawingml/2006/main">
+            <a:off x="8001000" y="5295900"/>
+            <a:ext cx="781050" cy="228600"/>
+          </a:xfrm>
+          <a:prstGeom xmlns:a="http://schemas.openxmlformats.org/drawingml/2006/main" prst="rect">
+            <a:avLst/>
+          </a:prstGeom>
+          <a:noFill xmlns:a="http://schemas.openxmlformats.org/drawingml/2006/main"/>
+          <a:ln xmlns:a="http://schemas.openxmlformats.org/drawingml/2006/main" w="0">
+            <a:noFill/>
+            <a:prstDash val="solid"/>
+          </a:ln>
+        </p:spPr>
+        <p:txBody>
+          <a:bodyPr xmlns:a="http://schemas.openxmlformats.org/drawingml/2006/main"/>
+          <a:lstStyle xmlns:a="http://schemas.openxmlformats.org/drawingml/2006/main"/>
+          <a:p xmlns:a="http://schemas.openxmlformats.org/drawingml/2006/main">
+            <a:pPr>
+              <a:buNone/>
+              <a:defRPr sz="975" b="1">
+                <a:solidFill>
+                  <a:srgbClr val="1F6B57"/>
+                </a:solidFill>
+                <a:latin typeface="Microsoft YaHei"/>
+                <a:ea typeface="Microsoft YaHei"/>
+                <a:cs typeface="Microsoft YaHei"/>
+              </a:defRPr>
+            </a:pPr>
+            <a:r>
+              <a:rPr sz="975" b="1">
+                <a:solidFill>
+                  <a:srgbClr val="1F6B57"/>
+                </a:solidFill>
+                <a:latin typeface="Microsoft YaHei"/>
+                <a:ea typeface="Microsoft YaHei"/>
+                <a:cs typeface="Microsoft YaHei"/>
+              </a:rPr>
+              <a:t>待补充</a:t>
+            </a:r>
+          </a:p>
+        </p:txBody>
+      </p:sp>
+      <p:sp>
+        <p:nvSpPr>
+          <p:cNvPr id="33" name="">
+            <a:extLst xmlns:a="http://schemas.openxmlformats.org/drawingml/2006/main">
+              <a:ext uri="{FF2B5EF4-FFF2-40B4-BE49-F238E27FC236}">
+                <a16:creationId xmlns:a16="http://schemas.microsoft.com/office/drawing/2014/main" id="{171E1123-CBA9-4972-AEE6-EA0B4BB4193E}"/>
+              </a:ext>
+            </a:extLst>
+          </p:cNvPr>
+          <p:cNvSpPr>
+            <a:spLocks xmlns:a="http://schemas.openxmlformats.org/drawingml/2006/main" noGrp="1"/>
+          </p:cNvSpPr>
+          <p:nvPr/>
+        </p:nvSpPr>
+        <p:spPr>
+          <a:xfrm xmlns:a="http://schemas.openxmlformats.org/drawingml/2006/main">
+            <a:off x="8801100" y="5276850"/>
+            <a:ext cx="2095500" cy="266700"/>
+          </a:xfrm>
+          <a:prstGeom xmlns:a="http://schemas.openxmlformats.org/drawingml/2006/main" prst="rect">
+            <a:avLst/>
+          </a:prstGeom>
+          <a:noFill xmlns:a="http://schemas.openxmlformats.org/drawingml/2006/main"/>
+          <a:ln xmlns:a="http://schemas.openxmlformats.org/drawingml/2006/main" w="0">
+            <a:noFill/>
+            <a:prstDash val="solid"/>
+          </a:ln>
+        </p:spPr>
+        <p:txBody>
+          <a:bodyPr xmlns:a="http://schemas.openxmlformats.org/drawingml/2006/main"/>
+          <a:lstStyle xmlns:a="http://schemas.openxmlformats.org/drawingml/2006/main"/>
+          <a:p xmlns:a="http://schemas.openxmlformats.org/drawingml/2006/main">
+            <a:pPr>
+              <a:buNone/>
+              <a:defRPr sz="1275" b="1">
+                <a:solidFill>
+                  <a:srgbClr val="1A2A26"/>
+                </a:solidFill>
+                <a:latin typeface="Microsoft YaHei"/>
+                <a:ea typeface="Microsoft YaHei"/>
+                <a:cs typeface="Microsoft YaHei"/>
+              </a:defRPr>
+            </a:pPr>
+            <a:r>
+              <a:rPr sz="1275" b="1">
+                <a:solidFill>
+                  <a:srgbClr val="1A2A26"/>
+                </a:solidFill>
+                <a:latin typeface="Microsoft YaHei"/>
+                <a:ea typeface="Microsoft YaHei"/>
+                <a:cs typeface="Microsoft YaHei"/>
+              </a:rPr>
+              <a:t>支撑案例资料截图</a:t>
+            </a:r>
+          </a:p>
+        </p:txBody>
+      </p:sp>
+      <p:sp>
+        <p:nvSpPr>
+          <p:cNvPr id="34" name="">
+            <a:extLst xmlns:a="http://schemas.openxmlformats.org/drawingml/2006/main">
+              <a:ext uri="{FF2B5EF4-FFF2-40B4-BE49-F238E27FC236}">
+                <a16:creationId xmlns:a16="http://schemas.microsoft.com/office/drawing/2014/main" id="{F291F442-B20A-439B-80A4-CCA646824D68}"/>
+              </a:ext>
+            </a:extLst>
+          </p:cNvPr>
+          <p:cNvSpPr>
+            <a:spLocks xmlns:a="http://schemas.openxmlformats.org/drawingml/2006/main" noGrp="1"/>
+          </p:cNvSpPr>
+          <p:nvPr/>
+        </p:nvSpPr>
+        <p:spPr>
+          <a:xfrm xmlns:a="http://schemas.openxmlformats.org/drawingml/2006/main">
+            <a:off x="8001000" y="5562600"/>
+            <a:ext cx="2895600" cy="361950"/>
+          </a:xfrm>
+          <a:prstGeom xmlns:a="http://schemas.openxmlformats.org/drawingml/2006/main" prst="rect">
+            <a:avLst/>
+          </a:prstGeom>
+          <a:noFill xmlns:a="http://schemas.openxmlformats.org/drawingml/2006/main"/>
+          <a:ln xmlns:a="http://schemas.openxmlformats.org/drawingml/2006/main" w="0">
+            <a:noFill/>
+            <a:prstDash val="solid"/>
+          </a:ln>
+        </p:spPr>
+        <p:txBody>
+          <a:bodyPr xmlns:a="http://schemas.openxmlformats.org/drawingml/2006/main"/>
+          <a:lstStyle xmlns:a="http://schemas.openxmlformats.org/drawingml/2006/main"/>
+          <a:p xmlns:a="http://schemas.openxmlformats.org/drawingml/2006/main">
+            <a:pPr>
+              <a:buNone/>
+              <a:defRPr sz="938">
+                <a:solidFill>
+                  <a:srgbClr val="6B746F"/>
+                </a:solidFill>
+                <a:latin typeface="Microsoft YaHei"/>
+                <a:ea typeface="Microsoft YaHei"/>
+                <a:cs typeface="Microsoft YaHei"/>
+              </a:defRPr>
+            </a:pPr>
+            <a:r>
+              <a:rPr sz="938">
+                <a:solidFill>
+                  <a:srgbClr val="6B746F"/>
+                </a:solidFill>
+                <a:latin typeface="Microsoft YaHei"/>
+                <a:ea typeface="Microsoft YaHei"/>
+                <a:cs typeface="Microsoft YaHei"/>
+              </a:rPr>
+              <a:t>DFS接入/清洗、Designer场景配置、3D/IoT上下文截图</a:t>
             </a:r>
           </a:p>
         </p:txBody>
@@ -9144,6 +11017,7 @@
           <a:lstStyle xmlns:a="http://schemas.openxmlformats.org/drawingml/2006/main"/>
           <a:p xmlns:a="http://schemas.openxmlformats.org/drawingml/2006/main">
             <a:pPr algn="l">
+              <a:buNone/>
               <a:defRPr sz="975" b="1">
                 <a:solidFill>
                   <a:srgbClr val="C47A2C"/>
@@ -9200,6 +11074,7 @@
           <a:lstStyle xmlns:a="http://schemas.openxmlformats.org/drawingml/2006/main"/>
           <a:p xmlns:a="http://schemas.openxmlformats.org/drawingml/2006/main">
             <a:pPr algn="l">
+              <a:buNone/>
               <a:defRPr sz="2175" b="1">
                 <a:solidFill>
                   <a:srgbClr val="17211F"/>
@@ -9256,6 +11131,7 @@
           <a:lstStyle xmlns:a="http://schemas.openxmlformats.org/drawingml/2006/main"/>
           <a:p xmlns:a="http://schemas.openxmlformats.org/drawingml/2006/main">
             <a:pPr algn="l">
+              <a:buNone/>
               <a:defRPr sz="1200" b="0">
                 <a:solidFill>
                   <a:srgbClr val="65716D"/>
@@ -9378,6 +11254,7 @@
           <a:lstStyle xmlns:a="http://schemas.openxmlformats.org/drawingml/2006/main"/>
           <a:p xmlns:a="http://schemas.openxmlformats.org/drawingml/2006/main">
             <a:pPr algn="l">
+              <a:buNone/>
               <a:defRPr sz="1950" b="1">
                 <a:solidFill>
                   <a:srgbClr val="1F6B57"/>
@@ -9465,6 +11342,7 @@
           <a:lstStyle xmlns:a="http://schemas.openxmlformats.org/drawingml/2006/main"/>
           <a:p xmlns:a="http://schemas.openxmlformats.org/drawingml/2006/main">
             <a:pPr algn="l">
+              <a:buNone/>
               <a:defRPr sz="1275" b="0">
                 <a:solidFill>
                   <a:srgbClr val="17211F"/>
@@ -9552,6 +11430,7 @@
           <a:lstStyle xmlns:a="http://schemas.openxmlformats.org/drawingml/2006/main"/>
           <a:p xmlns:a="http://schemas.openxmlformats.org/drawingml/2006/main">
             <a:pPr algn="l">
+              <a:buNone/>
               <a:defRPr sz="1275" b="0">
                 <a:solidFill>
                   <a:srgbClr val="17211F"/>
@@ -9639,6 +11518,7 @@
           <a:lstStyle xmlns:a="http://schemas.openxmlformats.org/drawingml/2006/main"/>
           <a:p xmlns:a="http://schemas.openxmlformats.org/drawingml/2006/main">
             <a:pPr algn="l">
+              <a:buNone/>
               <a:defRPr sz="1275" b="0">
                 <a:solidFill>
                   <a:srgbClr val="17211F"/>
@@ -9726,6 +11606,7 @@
           <a:lstStyle xmlns:a="http://schemas.openxmlformats.org/drawingml/2006/main"/>
           <a:p xmlns:a="http://schemas.openxmlformats.org/drawingml/2006/main">
             <a:pPr algn="l">
+              <a:buNone/>
               <a:defRPr sz="1275" b="0">
                 <a:solidFill>
                   <a:srgbClr val="17211F"/>
@@ -9817,6 +11698,7 @@
           <a:lstStyle xmlns:a="http://schemas.openxmlformats.org/drawingml/2006/main"/>
           <a:p xmlns:a="http://schemas.openxmlformats.org/drawingml/2006/main">
             <a:pPr algn="l">
+              <a:buNone/>
               <a:defRPr sz="1950" b="1">
                 <a:solidFill>
                   <a:srgbClr val="102C35"/>
@@ -9873,6 +11755,7 @@
           <a:lstStyle xmlns:a="http://schemas.openxmlformats.org/drawingml/2006/main"/>
           <a:p xmlns:a="http://schemas.openxmlformats.org/drawingml/2006/main">
             <a:pPr algn="l">
+              <a:buNone/>
               <a:defRPr sz="1350" b="1">
                 <a:solidFill>
                   <a:srgbClr val="1F6B57"/>
@@ -9929,6 +11812,7 @@
           <a:lstStyle xmlns:a="http://schemas.openxmlformats.org/drawingml/2006/main"/>
           <a:p xmlns:a="http://schemas.openxmlformats.org/drawingml/2006/main">
             <a:pPr algn="l">
+              <a:buNone/>
               <a:defRPr sz="1125" b="0">
                 <a:solidFill>
                   <a:srgbClr val="17211F"/>
@@ -9985,6 +11869,7 @@
           <a:lstStyle xmlns:a="http://schemas.openxmlformats.org/drawingml/2006/main"/>
           <a:p xmlns:a="http://schemas.openxmlformats.org/drawingml/2006/main">
             <a:pPr algn="l">
+              <a:buNone/>
               <a:defRPr sz="1350" b="1">
                 <a:solidFill>
                   <a:srgbClr val="C47A2C"/>
@@ -10041,6 +11926,7 @@
           <a:lstStyle xmlns:a="http://schemas.openxmlformats.org/drawingml/2006/main"/>
           <a:p xmlns:a="http://schemas.openxmlformats.org/drawingml/2006/main">
             <a:pPr algn="l">
+              <a:buNone/>
               <a:defRPr sz="1125" b="0">
                 <a:solidFill>
                   <a:srgbClr val="17211F"/>
@@ -10097,6 +11983,7 @@
           <a:lstStyle xmlns:a="http://schemas.openxmlformats.org/drawingml/2006/main"/>
           <a:p xmlns:a="http://schemas.openxmlformats.org/drawingml/2006/main">
             <a:pPr algn="l">
+              <a:buNone/>
               <a:defRPr sz="1350" b="1">
                 <a:solidFill>
                   <a:srgbClr val="2D5F9A"/>
@@ -10153,6 +12040,7 @@
           <a:lstStyle xmlns:a="http://schemas.openxmlformats.org/drawingml/2006/main"/>
           <a:p xmlns:a="http://schemas.openxmlformats.org/drawingml/2006/main">
             <a:pPr algn="l">
+              <a:buNone/>
               <a:defRPr sz="1125" b="0">
                 <a:solidFill>
                   <a:srgbClr val="17211F"/>
@@ -10209,6 +12097,7 @@
           <a:lstStyle xmlns:a="http://schemas.openxmlformats.org/drawingml/2006/main"/>
           <a:p xmlns:a="http://schemas.openxmlformats.org/drawingml/2006/main">
             <a:pPr algn="ctr">
+              <a:buNone/>
               <a:defRPr sz="1500" b="1">
                 <a:solidFill>
                   <a:srgbClr val="B24A3B"/>
@@ -10265,6 +12154,7 @@
           <a:lstStyle xmlns:a="http://schemas.openxmlformats.org/drawingml/2006/main"/>
           <a:p xmlns:a="http://schemas.openxmlformats.org/drawingml/2006/main">
             <a:pPr algn="l">
+              <a:buNone/>
               <a:defRPr sz="750" b="0">
                 <a:solidFill>
                   <a:srgbClr val="65716D"/>
@@ -10284,6 +12174,212 @@
                 <a:cs typeface="Microsoft YaHei"/>
               </a:rPr>
               <a:t>作品集用途：求职面试 / 产品经理能力证明；所有指标以可公开证据为准</a:t>
+            </a:r>
+          </a:p>
+        </p:txBody>
+      </p:sp>
+      <p:sp>
+        <p:nvSpPr>
+          <p:cNvPr id="25" name="material-slot-材料槽位">
+            <a:extLst xmlns:a="http://schemas.openxmlformats.org/drawingml/2006/main">
+              <a:ext uri="{FF2B5EF4-FFF2-40B4-BE49-F238E27FC236}">
+                <a16:creationId xmlns:a16="http://schemas.microsoft.com/office/drawing/2014/main" id="{F8DBA457-521B-46DE-A84B-56A3D1A4E12A}"/>
+              </a:ext>
+            </a:extLst>
+          </p:cNvPr>
+          <p:cNvSpPr>
+            <a:spLocks xmlns:a="http://schemas.openxmlformats.org/drawingml/2006/main" noGrp="1"/>
+          </p:cNvSpPr>
+          <p:nvPr/>
+        </p:nvSpPr>
+        <p:spPr>
+          <a:xfrm xmlns:a="http://schemas.openxmlformats.org/drawingml/2006/main">
+            <a:off x="6019800" y="4781550"/>
+            <a:ext cx="4838700" cy="590550"/>
+          </a:xfrm>
+          <a:prstGeom xmlns:a="http://schemas.openxmlformats.org/drawingml/2006/main" prst="roundRect">
+            <a:avLst>
+              <a:gd name="adj" fmla="val 12903"/>
+            </a:avLst>
+          </a:prstGeom>
+          <a:solidFill xmlns:a="http://schemas.openxmlformats.org/drawingml/2006/main">
+            <a:srgbClr val="FFF8F1"/>
+          </a:solidFill>
+          <a:ln xmlns:a="http://schemas.openxmlformats.org/drawingml/2006/main" w="14288">
+            <a:solidFill>
+              <a:srgbClr val="C47A2C"/>
+            </a:solidFill>
+            <a:prstDash val="dash"/>
+          </a:ln>
+        </p:spPr>
+      </p:sp>
+      <p:sp>
+        <p:nvSpPr>
+          <p:cNvPr id="26" name="">
+            <a:extLst xmlns:a="http://schemas.openxmlformats.org/drawingml/2006/main">
+              <a:ext uri="{FF2B5EF4-FFF2-40B4-BE49-F238E27FC236}">
+                <a16:creationId xmlns:a16="http://schemas.microsoft.com/office/drawing/2014/main" id="{1F7FA086-C66F-48DC-9454-154A828F123B}"/>
+              </a:ext>
+            </a:extLst>
+          </p:cNvPr>
+          <p:cNvSpPr>
+            <a:spLocks xmlns:a="http://schemas.openxmlformats.org/drawingml/2006/main" noGrp="1"/>
+          </p:cNvSpPr>
+          <p:nvPr/>
+        </p:nvSpPr>
+        <p:spPr>
+          <a:xfrm xmlns:a="http://schemas.openxmlformats.org/drawingml/2006/main">
+            <a:off x="6191250" y="4914900"/>
+            <a:ext cx="781050" cy="228600"/>
+          </a:xfrm>
+          <a:prstGeom xmlns:a="http://schemas.openxmlformats.org/drawingml/2006/main" prst="rect">
+            <a:avLst/>
+          </a:prstGeom>
+          <a:noFill xmlns:a="http://schemas.openxmlformats.org/drawingml/2006/main"/>
+          <a:ln xmlns:a="http://schemas.openxmlformats.org/drawingml/2006/main" w="0">
+            <a:noFill/>
+            <a:prstDash val="solid"/>
+          </a:ln>
+        </p:spPr>
+        <p:txBody>
+          <a:bodyPr xmlns:a="http://schemas.openxmlformats.org/drawingml/2006/main"/>
+          <a:lstStyle xmlns:a="http://schemas.openxmlformats.org/drawingml/2006/main"/>
+          <a:p xmlns:a="http://schemas.openxmlformats.org/drawingml/2006/main">
+            <a:pPr>
+              <a:buNone/>
+              <a:defRPr sz="975" b="1">
+                <a:solidFill>
+                  <a:srgbClr val="C47A2C"/>
+                </a:solidFill>
+                <a:latin typeface="Microsoft YaHei"/>
+                <a:ea typeface="Microsoft YaHei"/>
+                <a:cs typeface="Microsoft YaHei"/>
+              </a:defRPr>
+            </a:pPr>
+            <a:r>
+              <a:rPr sz="975" b="1">
+                <a:solidFill>
+                  <a:srgbClr val="C47A2C"/>
+                </a:solidFill>
+                <a:latin typeface="Microsoft YaHei"/>
+                <a:ea typeface="Microsoft YaHei"/>
+                <a:cs typeface="Microsoft YaHei"/>
+              </a:rPr>
+              <a:t>待补充</a:t>
+            </a:r>
+          </a:p>
+        </p:txBody>
+      </p:sp>
+      <p:sp>
+        <p:nvSpPr>
+          <p:cNvPr id="27" name="">
+            <a:extLst xmlns:a="http://schemas.openxmlformats.org/drawingml/2006/main">
+              <a:ext uri="{FF2B5EF4-FFF2-40B4-BE49-F238E27FC236}">
+                <a16:creationId xmlns:a16="http://schemas.microsoft.com/office/drawing/2014/main" id="{F0007422-4A2D-4524-80AD-032F0BC03D4A}"/>
+              </a:ext>
+            </a:extLst>
+          </p:cNvPr>
+          <p:cNvSpPr>
+            <a:spLocks xmlns:a="http://schemas.openxmlformats.org/drawingml/2006/main" noGrp="1"/>
+          </p:cNvSpPr>
+          <p:nvPr/>
+        </p:nvSpPr>
+        <p:spPr>
+          <a:xfrm xmlns:a="http://schemas.openxmlformats.org/drawingml/2006/main">
+            <a:off x="6991350" y="4895850"/>
+            <a:ext cx="3695700" cy="266700"/>
+          </a:xfrm>
+          <a:prstGeom xmlns:a="http://schemas.openxmlformats.org/drawingml/2006/main" prst="rect">
+            <a:avLst/>
+          </a:prstGeom>
+          <a:noFill xmlns:a="http://schemas.openxmlformats.org/drawingml/2006/main"/>
+          <a:ln xmlns:a="http://schemas.openxmlformats.org/drawingml/2006/main" w="0">
+            <a:noFill/>
+            <a:prstDash val="solid"/>
+          </a:ln>
+        </p:spPr>
+        <p:txBody>
+          <a:bodyPr xmlns:a="http://schemas.openxmlformats.org/drawingml/2006/main"/>
+          <a:lstStyle xmlns:a="http://schemas.openxmlformats.org/drawingml/2006/main"/>
+          <a:p xmlns:a="http://schemas.openxmlformats.org/drawingml/2006/main">
+            <a:pPr>
+              <a:buNone/>
+              <a:defRPr sz="1275" b="1">
+                <a:solidFill>
+                  <a:srgbClr val="1A2A26"/>
+                </a:solidFill>
+                <a:latin typeface="Microsoft YaHei"/>
+                <a:ea typeface="Microsoft YaHei"/>
+                <a:cs typeface="Microsoft YaHei"/>
+              </a:defRPr>
+            </a:pPr>
+            <a:r>
+              <a:rPr sz="1275" b="1">
+                <a:solidFill>
+                  <a:srgbClr val="1A2A26"/>
+                </a:solidFill>
+                <a:latin typeface="Microsoft YaHei"/>
+                <a:ea typeface="Microsoft YaHei"/>
+                <a:cs typeface="Microsoft YaHei"/>
+              </a:rPr>
+              <a:t>材料槽位</a:t>
+            </a:r>
+          </a:p>
+        </p:txBody>
+      </p:sp>
+      <p:sp>
+        <p:nvSpPr>
+          <p:cNvPr id="28" name="">
+            <a:extLst xmlns:a="http://schemas.openxmlformats.org/drawingml/2006/main">
+              <a:ext uri="{FF2B5EF4-FFF2-40B4-BE49-F238E27FC236}">
+                <a16:creationId xmlns:a16="http://schemas.microsoft.com/office/drawing/2014/main" id="{D602427D-435C-41E1-A5DF-202913389966}"/>
+              </a:ext>
+            </a:extLst>
+          </p:cNvPr>
+          <p:cNvSpPr>
+            <a:spLocks xmlns:a="http://schemas.openxmlformats.org/drawingml/2006/main" noGrp="1"/>
+          </p:cNvSpPr>
+          <p:nvPr/>
+        </p:nvSpPr>
+        <p:spPr>
+          <a:xfrm xmlns:a="http://schemas.openxmlformats.org/drawingml/2006/main">
+            <a:off x="6191250" y="5181600"/>
+            <a:ext cx="4495800" cy="114300"/>
+          </a:xfrm>
+          <a:prstGeom xmlns:a="http://schemas.openxmlformats.org/drawingml/2006/main" prst="rect">
+            <a:avLst/>
+          </a:prstGeom>
+          <a:noFill xmlns:a="http://schemas.openxmlformats.org/drawingml/2006/main"/>
+          <a:ln xmlns:a="http://schemas.openxmlformats.org/drawingml/2006/main" w="0">
+            <a:noFill/>
+            <a:prstDash val="solid"/>
+          </a:ln>
+        </p:spPr>
+        <p:txBody>
+          <a:bodyPr xmlns:a="http://schemas.openxmlformats.org/drawingml/2006/main"/>
+          <a:lstStyle xmlns:a="http://schemas.openxmlformats.org/drawingml/2006/main"/>
+          <a:p xmlns:a="http://schemas.openxmlformats.org/drawingml/2006/main">
+            <a:pPr>
+              <a:buNone/>
+              <a:defRPr sz="938">
+                <a:solidFill>
+                  <a:srgbClr val="6B746F"/>
+                </a:solidFill>
+                <a:latin typeface="Microsoft YaHei"/>
+                <a:ea typeface="Microsoft YaHei"/>
+                <a:cs typeface="Microsoft YaHei"/>
+              </a:defRPr>
+            </a:pPr>
+            <a:r>
+              <a:rPr sz="938">
+                <a:solidFill>
+                  <a:srgbClr val="6B746F"/>
+                </a:solidFill>
+                <a:latin typeface="Microsoft YaHei"/>
+                <a:ea typeface="Microsoft YaHei"/>
+                <a:cs typeface="Microsoft YaHei"/>
+              </a:rPr>
+              <a:t>补充脱敏截图、客户/用户反馈、验收记录、可公开指标或过程记录</a:t>
             </a:r>
           </a:p>
         </p:txBody>
@@ -10350,6 +12446,7 @@
           <a:lstStyle xmlns:a="http://schemas.openxmlformats.org/drawingml/2006/main"/>
           <a:p xmlns:a="http://schemas.openxmlformats.org/drawingml/2006/main">
             <a:pPr algn="l">
+              <a:buNone/>
               <a:defRPr sz="975" b="1">
                 <a:solidFill>
                   <a:srgbClr val="C47A2C"/>
@@ -10406,6 +12503,7 @@
           <a:lstStyle xmlns:a="http://schemas.openxmlformats.org/drawingml/2006/main"/>
           <a:p xmlns:a="http://schemas.openxmlformats.org/drawingml/2006/main">
             <a:pPr algn="l">
+              <a:buNone/>
               <a:defRPr sz="2175" b="1">
                 <a:solidFill>
                   <a:srgbClr val="17211F"/>
@@ -10462,6 +12560,7 @@
           <a:lstStyle xmlns:a="http://schemas.openxmlformats.org/drawingml/2006/main"/>
           <a:p xmlns:a="http://schemas.openxmlformats.org/drawingml/2006/main">
             <a:pPr algn="l">
+              <a:buNone/>
               <a:defRPr sz="1200" b="0">
                 <a:solidFill>
                   <a:srgbClr val="65716D"/>
@@ -10584,6 +12683,7 @@
           <a:lstStyle xmlns:a="http://schemas.openxmlformats.org/drawingml/2006/main"/>
           <a:p xmlns:a="http://schemas.openxmlformats.org/drawingml/2006/main">
             <a:pPr algn="l">
+              <a:buNone/>
               <a:defRPr sz="1800" b="1">
                 <a:solidFill>
                   <a:srgbClr val="1F6B57"/>
@@ -10671,6 +12771,7 @@
           <a:lstStyle xmlns:a="http://schemas.openxmlformats.org/drawingml/2006/main"/>
           <a:p xmlns:a="http://schemas.openxmlformats.org/drawingml/2006/main">
             <a:pPr algn="l">
+              <a:buNone/>
               <a:defRPr sz="1350" b="0">
                 <a:solidFill>
                   <a:srgbClr val="17211F"/>
@@ -10758,6 +12859,7 @@
           <a:lstStyle xmlns:a="http://schemas.openxmlformats.org/drawingml/2006/main"/>
           <a:p xmlns:a="http://schemas.openxmlformats.org/drawingml/2006/main">
             <a:pPr algn="l">
+              <a:buNone/>
               <a:defRPr sz="1350" b="0">
                 <a:solidFill>
                   <a:srgbClr val="17211F"/>
@@ -10845,6 +12947,7 @@
           <a:lstStyle xmlns:a="http://schemas.openxmlformats.org/drawingml/2006/main"/>
           <a:p xmlns:a="http://schemas.openxmlformats.org/drawingml/2006/main">
             <a:pPr algn="l">
+              <a:buNone/>
               <a:defRPr sz="1350" b="0">
                 <a:solidFill>
                   <a:srgbClr val="17211F"/>
@@ -10936,6 +13039,7 @@
           <a:lstStyle xmlns:a="http://schemas.openxmlformats.org/drawingml/2006/main"/>
           <a:p xmlns:a="http://schemas.openxmlformats.org/drawingml/2006/main">
             <a:pPr algn="l">
+              <a:buNone/>
               <a:defRPr sz="1800" b="1">
                 <a:solidFill>
                   <a:srgbClr val="218A8A"/>
@@ -11023,6 +13127,7 @@
           <a:lstStyle xmlns:a="http://schemas.openxmlformats.org/drawingml/2006/main"/>
           <a:p xmlns:a="http://schemas.openxmlformats.org/drawingml/2006/main">
             <a:pPr algn="l">
+              <a:buNone/>
               <a:defRPr sz="1350" b="0">
                 <a:solidFill>
                   <a:srgbClr val="17211F"/>
@@ -11110,6 +13215,7 @@
           <a:lstStyle xmlns:a="http://schemas.openxmlformats.org/drawingml/2006/main"/>
           <a:p xmlns:a="http://schemas.openxmlformats.org/drawingml/2006/main">
             <a:pPr algn="l">
+              <a:buNone/>
               <a:defRPr sz="1350" b="0">
                 <a:solidFill>
                   <a:srgbClr val="17211F"/>
@@ -11197,6 +13303,7 @@
           <a:lstStyle xmlns:a="http://schemas.openxmlformats.org/drawingml/2006/main"/>
           <a:p xmlns:a="http://schemas.openxmlformats.org/drawingml/2006/main">
             <a:pPr algn="l">
+              <a:buNone/>
               <a:defRPr sz="1350" b="0">
                 <a:solidFill>
                   <a:srgbClr val="17211F"/>
@@ -11288,6 +13395,7 @@
           <a:lstStyle xmlns:a="http://schemas.openxmlformats.org/drawingml/2006/main"/>
           <a:p xmlns:a="http://schemas.openxmlformats.org/drawingml/2006/main">
             <a:pPr algn="l">
+              <a:buNone/>
               <a:defRPr sz="1800" b="1">
                 <a:solidFill>
                   <a:srgbClr val="1F6B57"/>
@@ -11375,6 +13483,7 @@
           <a:lstStyle xmlns:a="http://schemas.openxmlformats.org/drawingml/2006/main"/>
           <a:p xmlns:a="http://schemas.openxmlformats.org/drawingml/2006/main">
             <a:pPr algn="l">
+              <a:buNone/>
               <a:defRPr sz="1350" b="0">
                 <a:solidFill>
                   <a:srgbClr val="17211F"/>
@@ -11462,6 +13571,7 @@
           <a:lstStyle xmlns:a="http://schemas.openxmlformats.org/drawingml/2006/main"/>
           <a:p xmlns:a="http://schemas.openxmlformats.org/drawingml/2006/main">
             <a:pPr algn="l">
+              <a:buNone/>
               <a:defRPr sz="1350" b="0">
                 <a:solidFill>
                   <a:srgbClr val="17211F"/>
@@ -11549,6 +13659,7 @@
           <a:lstStyle xmlns:a="http://schemas.openxmlformats.org/drawingml/2006/main"/>
           <a:p xmlns:a="http://schemas.openxmlformats.org/drawingml/2006/main">
             <a:pPr algn="l">
+              <a:buNone/>
               <a:defRPr sz="1350" b="0">
                 <a:solidFill>
                   <a:srgbClr val="17211F"/>
@@ -11605,6 +13716,7 @@
           <a:lstStyle xmlns:a="http://schemas.openxmlformats.org/drawingml/2006/main"/>
           <a:p xmlns:a="http://schemas.openxmlformats.org/drawingml/2006/main">
             <a:pPr algn="l">
+              <a:buNone/>
               <a:defRPr sz="1575" b="1">
                 <a:solidFill>
                   <a:srgbClr val="17211F"/>
@@ -11661,6 +13773,7 @@
           <a:lstStyle xmlns:a="http://schemas.openxmlformats.org/drawingml/2006/main"/>
           <a:p xmlns:a="http://schemas.openxmlformats.org/drawingml/2006/main">
             <a:pPr algn="l">
+              <a:buNone/>
               <a:defRPr sz="750" b="0">
                 <a:solidFill>
                   <a:srgbClr val="65716D"/>
@@ -11746,6 +13859,7 @@
           <a:lstStyle xmlns:a="http://schemas.openxmlformats.org/drawingml/2006/main"/>
           <a:p xmlns:a="http://schemas.openxmlformats.org/drawingml/2006/main">
             <a:pPr algn="l">
+              <a:buNone/>
               <a:defRPr sz="975" b="1">
                 <a:solidFill>
                   <a:srgbClr val="C47A2C"/>
@@ -11802,6 +13916,7 @@
           <a:lstStyle xmlns:a="http://schemas.openxmlformats.org/drawingml/2006/main"/>
           <a:p xmlns:a="http://schemas.openxmlformats.org/drawingml/2006/main">
             <a:pPr algn="l">
+              <a:buNone/>
               <a:defRPr sz="2175" b="1">
                 <a:solidFill>
                   <a:srgbClr val="17211F"/>
@@ -11858,6 +13973,7 @@
           <a:lstStyle xmlns:a="http://schemas.openxmlformats.org/drawingml/2006/main"/>
           <a:p xmlns:a="http://schemas.openxmlformats.org/drawingml/2006/main">
             <a:pPr algn="l">
+              <a:buNone/>
               <a:defRPr sz="1200" b="0">
                 <a:solidFill>
                   <a:srgbClr val="65716D"/>
@@ -11980,6 +14096,7 @@
           <a:lstStyle xmlns:a="http://schemas.openxmlformats.org/drawingml/2006/main"/>
           <a:p xmlns:a="http://schemas.openxmlformats.org/drawingml/2006/main">
             <a:pPr algn="ctr">
+              <a:buNone/>
               <a:defRPr sz="1050" b="1">
                 <a:solidFill>
                   <a:srgbClr val="17211F"/>
@@ -12102,6 +14219,7 @@
           <a:lstStyle xmlns:a="http://schemas.openxmlformats.org/drawingml/2006/main"/>
           <a:p xmlns:a="http://schemas.openxmlformats.org/drawingml/2006/main">
             <a:pPr algn="ctr">
+              <a:buNone/>
               <a:defRPr sz="1050" b="1">
                 <a:solidFill>
                   <a:srgbClr val="17211F"/>
@@ -12224,6 +14342,7 @@
           <a:lstStyle xmlns:a="http://schemas.openxmlformats.org/drawingml/2006/main"/>
           <a:p xmlns:a="http://schemas.openxmlformats.org/drawingml/2006/main">
             <a:pPr algn="ctr">
+              <a:buNone/>
               <a:defRPr sz="1050" b="1">
                 <a:solidFill>
                   <a:srgbClr val="17211F"/>
@@ -12346,6 +14465,7 @@
           <a:lstStyle xmlns:a="http://schemas.openxmlformats.org/drawingml/2006/main"/>
           <a:p xmlns:a="http://schemas.openxmlformats.org/drawingml/2006/main">
             <a:pPr algn="ctr">
+              <a:buNone/>
               <a:defRPr sz="1050" b="1">
                 <a:solidFill>
                   <a:srgbClr val="17211F"/>
@@ -12468,6 +14588,7 @@
           <a:lstStyle xmlns:a="http://schemas.openxmlformats.org/drawingml/2006/main"/>
           <a:p xmlns:a="http://schemas.openxmlformats.org/drawingml/2006/main">
             <a:pPr algn="ctr">
+              <a:buNone/>
               <a:defRPr sz="1050" b="1">
                 <a:solidFill>
                   <a:srgbClr val="17211F"/>
@@ -12590,6 +14711,7 @@
           <a:lstStyle xmlns:a="http://schemas.openxmlformats.org/drawingml/2006/main"/>
           <a:p xmlns:a="http://schemas.openxmlformats.org/drawingml/2006/main">
             <a:pPr algn="ctr">
+              <a:buNone/>
               <a:defRPr sz="1050" b="1">
                 <a:solidFill>
                   <a:srgbClr val="17211F"/>
@@ -12712,6 +14834,7 @@
           <a:lstStyle xmlns:a="http://schemas.openxmlformats.org/drawingml/2006/main"/>
           <a:p xmlns:a="http://schemas.openxmlformats.org/drawingml/2006/main">
             <a:pPr algn="ctr">
+              <a:buNone/>
               <a:defRPr sz="1050" b="1">
                 <a:solidFill>
                   <a:srgbClr val="17211F"/>
@@ -12834,6 +14957,7 @@
           <a:lstStyle xmlns:a="http://schemas.openxmlformats.org/drawingml/2006/main"/>
           <a:p xmlns:a="http://schemas.openxmlformats.org/drawingml/2006/main">
             <a:pPr algn="ctr">
+              <a:buNone/>
               <a:defRPr sz="1050" b="1">
                 <a:solidFill>
                   <a:srgbClr val="17211F"/>
@@ -12925,6 +15049,7 @@
           <a:lstStyle xmlns:a="http://schemas.openxmlformats.org/drawingml/2006/main"/>
           <a:p xmlns:a="http://schemas.openxmlformats.org/drawingml/2006/main">
             <a:pPr algn="l">
+              <a:buNone/>
               <a:defRPr sz="1350" b="0">
                 <a:solidFill>
                   <a:srgbClr val="17211F"/>
@@ -13016,6 +15141,7 @@
           <a:lstStyle xmlns:a="http://schemas.openxmlformats.org/drawingml/2006/main"/>
           <a:p xmlns:a="http://schemas.openxmlformats.org/drawingml/2006/main">
             <a:pPr algn="l">
+              <a:buNone/>
               <a:defRPr sz="1350" b="0">
                 <a:solidFill>
                   <a:srgbClr val="17211F"/>
@@ -13107,6 +15233,7 @@
           <a:lstStyle xmlns:a="http://schemas.openxmlformats.org/drawingml/2006/main"/>
           <a:p xmlns:a="http://schemas.openxmlformats.org/drawingml/2006/main">
             <a:pPr algn="l">
+              <a:buNone/>
               <a:defRPr sz="1350" b="0">
                 <a:solidFill>
                   <a:srgbClr val="17211F"/>
@@ -13163,6 +15290,7 @@
           <a:lstStyle xmlns:a="http://schemas.openxmlformats.org/drawingml/2006/main"/>
           <a:p xmlns:a="http://schemas.openxmlformats.org/drawingml/2006/main">
             <a:pPr algn="l">
+              <a:buNone/>
               <a:defRPr sz="1500" b="1">
                 <a:solidFill>
                   <a:srgbClr val="1F6B57"/>
@@ -13219,6 +15347,7 @@
           <a:lstStyle xmlns:a="http://schemas.openxmlformats.org/drawingml/2006/main"/>
           <a:p xmlns:a="http://schemas.openxmlformats.org/drawingml/2006/main">
             <a:pPr algn="l">
+              <a:buNone/>
               <a:defRPr sz="750" b="0">
                 <a:solidFill>
                   <a:srgbClr val="65716D"/>
@@ -13304,6 +15433,7 @@
           <a:lstStyle xmlns:a="http://schemas.openxmlformats.org/drawingml/2006/main"/>
           <a:p xmlns:a="http://schemas.openxmlformats.org/drawingml/2006/main">
             <a:pPr algn="l">
+              <a:buNone/>
               <a:defRPr sz="975" b="1">
                 <a:solidFill>
                   <a:srgbClr val="C47A2C"/>
@@ -13360,6 +15490,7 @@
           <a:lstStyle xmlns:a="http://schemas.openxmlformats.org/drawingml/2006/main"/>
           <a:p xmlns:a="http://schemas.openxmlformats.org/drawingml/2006/main">
             <a:pPr algn="l">
+              <a:buNone/>
               <a:defRPr sz="2175" b="1">
                 <a:solidFill>
                   <a:srgbClr val="17211F"/>
@@ -13416,6 +15547,7 @@
           <a:lstStyle xmlns:a="http://schemas.openxmlformats.org/drawingml/2006/main"/>
           <a:p xmlns:a="http://schemas.openxmlformats.org/drawingml/2006/main">
             <a:pPr algn="l">
+              <a:buNone/>
               <a:defRPr sz="1200" b="0">
                 <a:solidFill>
                   <a:srgbClr val="65716D"/>
@@ -13503,6 +15635,7 @@
           <a:lstStyle xmlns:a="http://schemas.openxmlformats.org/drawingml/2006/main"/>
           <a:p xmlns:a="http://schemas.openxmlformats.org/drawingml/2006/main">
             <a:pPr algn="l">
+              <a:buNone/>
               <a:defRPr sz="1800" b="1">
                 <a:solidFill>
                   <a:srgbClr val="B24A3B"/>
@@ -13559,6 +15692,7 @@
           <a:lstStyle xmlns:a="http://schemas.openxmlformats.org/drawingml/2006/main"/>
           <a:p xmlns:a="http://schemas.openxmlformats.org/drawingml/2006/main">
             <a:pPr algn="l">
+              <a:buNone/>
               <a:defRPr sz="1800" b="1">
                 <a:solidFill>
                   <a:srgbClr val="1F6B57"/>
@@ -13716,6 +15850,7 @@
           <a:lstStyle xmlns:a="http://schemas.openxmlformats.org/drawingml/2006/main"/>
           <a:p xmlns:a="http://schemas.openxmlformats.org/drawingml/2006/main">
             <a:pPr algn="l">
+              <a:buNone/>
               <a:defRPr sz="1350" b="0">
                 <a:solidFill>
                   <a:srgbClr val="17211F"/>
@@ -13803,6 +15938,7 @@
           <a:lstStyle xmlns:a="http://schemas.openxmlformats.org/drawingml/2006/main"/>
           <a:p xmlns:a="http://schemas.openxmlformats.org/drawingml/2006/main">
             <a:pPr algn="l">
+              <a:buNone/>
               <a:defRPr sz="1350" b="0">
                 <a:solidFill>
                   <a:srgbClr val="17211F"/>
@@ -13890,6 +16026,7 @@
           <a:lstStyle xmlns:a="http://schemas.openxmlformats.org/drawingml/2006/main"/>
           <a:p xmlns:a="http://schemas.openxmlformats.org/drawingml/2006/main">
             <a:pPr algn="l">
+              <a:buNone/>
               <a:defRPr sz="1350" b="0">
                 <a:solidFill>
                   <a:srgbClr val="17211F"/>
@@ -13977,6 +16114,7 @@
           <a:lstStyle xmlns:a="http://schemas.openxmlformats.org/drawingml/2006/main"/>
           <a:p xmlns:a="http://schemas.openxmlformats.org/drawingml/2006/main">
             <a:pPr algn="l">
+              <a:buNone/>
               <a:defRPr sz="1350" b="0">
                 <a:solidFill>
                   <a:srgbClr val="17211F"/>
@@ -14064,6 +16202,7 @@
           <a:lstStyle xmlns:a="http://schemas.openxmlformats.org/drawingml/2006/main"/>
           <a:p xmlns:a="http://schemas.openxmlformats.org/drawingml/2006/main">
             <a:pPr algn="l">
+              <a:buNone/>
               <a:defRPr sz="1350" b="0">
                 <a:solidFill>
                   <a:srgbClr val="17211F"/>
@@ -14151,6 +16290,7 @@
           <a:lstStyle xmlns:a="http://schemas.openxmlformats.org/drawingml/2006/main"/>
           <a:p xmlns:a="http://schemas.openxmlformats.org/drawingml/2006/main">
             <a:pPr algn="l">
+              <a:buNone/>
               <a:defRPr sz="1350" b="0">
                 <a:solidFill>
                   <a:srgbClr val="17211F"/>
@@ -14238,6 +16378,7 @@
           <a:lstStyle xmlns:a="http://schemas.openxmlformats.org/drawingml/2006/main"/>
           <a:p xmlns:a="http://schemas.openxmlformats.org/drawingml/2006/main">
             <a:pPr algn="l">
+              <a:buNone/>
               <a:defRPr sz="1350" b="0">
                 <a:solidFill>
                   <a:srgbClr val="17211F"/>
@@ -14325,6 +16466,7 @@
           <a:lstStyle xmlns:a="http://schemas.openxmlformats.org/drawingml/2006/main"/>
           <a:p xmlns:a="http://schemas.openxmlformats.org/drawingml/2006/main">
             <a:pPr algn="l">
+              <a:buNone/>
               <a:defRPr sz="1350" b="0">
                 <a:solidFill>
                   <a:srgbClr val="17211F"/>
@@ -14412,6 +16554,7 @@
           <a:lstStyle xmlns:a="http://schemas.openxmlformats.org/drawingml/2006/main"/>
           <a:p xmlns:a="http://schemas.openxmlformats.org/drawingml/2006/main">
             <a:pPr algn="ctr">
+              <a:buNone/>
               <a:defRPr sz="1275" b="1">
                 <a:solidFill>
                   <a:srgbClr val="FFFFFF"/>
@@ -14468,6 +16611,7 @@
           <a:lstStyle xmlns:a="http://schemas.openxmlformats.org/drawingml/2006/main"/>
           <a:p xmlns:a="http://schemas.openxmlformats.org/drawingml/2006/main">
             <a:pPr algn="ctr">
+              <a:buNone/>
               <a:defRPr sz="1575" b="1">
                 <a:solidFill>
                   <a:srgbClr val="17211F"/>
@@ -14524,6 +16668,7 @@
           <a:lstStyle xmlns:a="http://schemas.openxmlformats.org/drawingml/2006/main"/>
           <a:p xmlns:a="http://schemas.openxmlformats.org/drawingml/2006/main">
             <a:pPr algn="l">
+              <a:buNone/>
               <a:defRPr sz="750" b="0">
                 <a:solidFill>
                   <a:srgbClr val="65716D"/>
@@ -14609,6 +16754,7 @@
           <a:lstStyle xmlns:a="http://schemas.openxmlformats.org/drawingml/2006/main"/>
           <a:p xmlns:a="http://schemas.openxmlformats.org/drawingml/2006/main">
             <a:pPr algn="l">
+              <a:buNone/>
               <a:defRPr sz="975" b="1">
                 <a:solidFill>
                   <a:srgbClr val="C47A2C"/>
@@ -14665,6 +16811,7 @@
           <a:lstStyle xmlns:a="http://schemas.openxmlformats.org/drawingml/2006/main"/>
           <a:p xmlns:a="http://schemas.openxmlformats.org/drawingml/2006/main">
             <a:pPr algn="l">
+              <a:buNone/>
               <a:defRPr sz="2175" b="1">
                 <a:solidFill>
                   <a:srgbClr val="17211F"/>
@@ -14721,6 +16868,7 @@
           <a:lstStyle xmlns:a="http://schemas.openxmlformats.org/drawingml/2006/main"/>
           <a:p xmlns:a="http://schemas.openxmlformats.org/drawingml/2006/main">
             <a:pPr algn="l">
+              <a:buNone/>
               <a:defRPr sz="1200" b="0">
                 <a:solidFill>
                   <a:srgbClr val="65716D"/>
@@ -14843,6 +16991,7 @@
           <a:lstStyle xmlns:a="http://schemas.openxmlformats.org/drawingml/2006/main"/>
           <a:p xmlns:a="http://schemas.openxmlformats.org/drawingml/2006/main">
             <a:pPr algn="ctr">
+              <a:buNone/>
               <a:defRPr sz="1425" b="1">
                 <a:solidFill>
                   <a:srgbClr val="1F6B57"/>
@@ -14934,6 +17083,7 @@
           <a:lstStyle xmlns:a="http://schemas.openxmlformats.org/drawingml/2006/main"/>
           <a:p xmlns:a="http://schemas.openxmlformats.org/drawingml/2006/main">
             <a:pPr algn="l">
+              <a:buNone/>
               <a:defRPr sz="1350" b="0">
                 <a:solidFill>
                   <a:srgbClr val="17211F"/>
@@ -15025,6 +17175,7 @@
           <a:lstStyle xmlns:a="http://schemas.openxmlformats.org/drawingml/2006/main"/>
           <a:p xmlns:a="http://schemas.openxmlformats.org/drawingml/2006/main">
             <a:pPr algn="ctr">
+              <a:buNone/>
               <a:defRPr sz="1425" b="1">
                 <a:solidFill>
                   <a:srgbClr val="1F6B57"/>
@@ -15116,6 +17267,7 @@
           <a:lstStyle xmlns:a="http://schemas.openxmlformats.org/drawingml/2006/main"/>
           <a:p xmlns:a="http://schemas.openxmlformats.org/drawingml/2006/main">
             <a:pPr algn="l">
+              <a:buNone/>
               <a:defRPr sz="1350" b="0">
                 <a:solidFill>
                   <a:srgbClr val="17211F"/>
@@ -15207,6 +17359,7 @@
           <a:lstStyle xmlns:a="http://schemas.openxmlformats.org/drawingml/2006/main"/>
           <a:p xmlns:a="http://schemas.openxmlformats.org/drawingml/2006/main">
             <a:pPr algn="ctr">
+              <a:buNone/>
               <a:defRPr sz="1425" b="1">
                 <a:solidFill>
                   <a:srgbClr val="1F6B57"/>
@@ -15298,6 +17451,7 @@
           <a:lstStyle xmlns:a="http://schemas.openxmlformats.org/drawingml/2006/main"/>
           <a:p xmlns:a="http://schemas.openxmlformats.org/drawingml/2006/main">
             <a:pPr algn="l">
+              <a:buNone/>
               <a:defRPr sz="1350" b="0">
                 <a:solidFill>
                   <a:srgbClr val="17211F"/>
@@ -15389,6 +17543,7 @@
           <a:lstStyle xmlns:a="http://schemas.openxmlformats.org/drawingml/2006/main"/>
           <a:p xmlns:a="http://schemas.openxmlformats.org/drawingml/2006/main">
             <a:pPr algn="ctr">
+              <a:buNone/>
               <a:defRPr sz="1425" b="1">
                 <a:solidFill>
                   <a:srgbClr val="1F6B57"/>
@@ -15480,6 +17635,7 @@
           <a:lstStyle xmlns:a="http://schemas.openxmlformats.org/drawingml/2006/main"/>
           <a:p xmlns:a="http://schemas.openxmlformats.org/drawingml/2006/main">
             <a:pPr algn="l">
+              <a:buNone/>
               <a:defRPr sz="1350" b="0">
                 <a:solidFill>
                   <a:srgbClr val="17211F"/>
@@ -15536,6 +17692,7 @@
           <a:lstStyle xmlns:a="http://schemas.openxmlformats.org/drawingml/2006/main"/>
           <a:p xmlns:a="http://schemas.openxmlformats.org/drawingml/2006/main">
             <a:pPr algn="l">
+              <a:buNone/>
               <a:defRPr sz="1500" b="1">
                 <a:solidFill>
                   <a:srgbClr val="1F6B57"/>
@@ -15592,6 +17749,7 @@
           <a:lstStyle xmlns:a="http://schemas.openxmlformats.org/drawingml/2006/main"/>
           <a:p xmlns:a="http://schemas.openxmlformats.org/drawingml/2006/main">
             <a:pPr algn="l">
+              <a:buNone/>
               <a:defRPr sz="750" b="0">
                 <a:solidFill>
                   <a:srgbClr val="65716D"/>
@@ -15611,6 +17769,212 @@
                 <a:cs typeface="Microsoft YaHei"/>
               </a:rPr>
               <a:t>作品集用途：求职面试 / 产品经理能力证明；所有指标以可公开证据为准</a:t>
+            </a:r>
+          </a:p>
+        </p:txBody>
+      </p:sp>
+      <p:sp>
+        <p:nvSpPr>
+          <p:cNvPr id="23" name="material-slot-0-1范围判断证据">
+            <a:extLst xmlns:a="http://schemas.openxmlformats.org/drawingml/2006/main">
+              <a:ext uri="{FF2B5EF4-FFF2-40B4-BE49-F238E27FC236}">
+                <a16:creationId xmlns:a16="http://schemas.microsoft.com/office/drawing/2014/main" id="{A078C50D-7C21-401A-909F-8F76B927585E}"/>
+              </a:ext>
+            </a:extLst>
+          </p:cNvPr>
+          <p:cNvSpPr>
+            <a:spLocks xmlns:a="http://schemas.openxmlformats.org/drawingml/2006/main" noGrp="1"/>
+          </p:cNvSpPr>
+          <p:nvPr/>
+        </p:nvSpPr>
+        <p:spPr>
+          <a:xfrm xmlns:a="http://schemas.openxmlformats.org/drawingml/2006/main">
+            <a:off x="7829550" y="5162550"/>
+            <a:ext cx="3238500" cy="838200"/>
+          </a:xfrm>
+          <a:prstGeom xmlns:a="http://schemas.openxmlformats.org/drawingml/2006/main" prst="roundRect">
+            <a:avLst>
+              <a:gd name="adj" fmla="val 9091"/>
+            </a:avLst>
+          </a:prstGeom>
+          <a:solidFill xmlns:a="http://schemas.openxmlformats.org/drawingml/2006/main">
+            <a:srgbClr val="F7FAF8"/>
+          </a:solidFill>
+          <a:ln xmlns:a="http://schemas.openxmlformats.org/drawingml/2006/main" w="14288">
+            <a:solidFill>
+              <a:srgbClr val="1F6B57"/>
+            </a:solidFill>
+            <a:prstDash val="dash"/>
+          </a:ln>
+        </p:spPr>
+      </p:sp>
+      <p:sp>
+        <p:nvSpPr>
+          <p:cNvPr id="24" name="">
+            <a:extLst xmlns:a="http://schemas.openxmlformats.org/drawingml/2006/main">
+              <a:ext uri="{FF2B5EF4-FFF2-40B4-BE49-F238E27FC236}">
+                <a16:creationId xmlns:a16="http://schemas.microsoft.com/office/drawing/2014/main" id="{79157664-78C3-4090-AFC0-78D1C89FFA36}"/>
+              </a:ext>
+            </a:extLst>
+          </p:cNvPr>
+          <p:cNvSpPr>
+            <a:spLocks xmlns:a="http://schemas.openxmlformats.org/drawingml/2006/main" noGrp="1"/>
+          </p:cNvSpPr>
+          <p:nvPr/>
+        </p:nvSpPr>
+        <p:spPr>
+          <a:xfrm xmlns:a="http://schemas.openxmlformats.org/drawingml/2006/main">
+            <a:off x="8001000" y="5295900"/>
+            <a:ext cx="781050" cy="228600"/>
+          </a:xfrm>
+          <a:prstGeom xmlns:a="http://schemas.openxmlformats.org/drawingml/2006/main" prst="rect">
+            <a:avLst/>
+          </a:prstGeom>
+          <a:noFill xmlns:a="http://schemas.openxmlformats.org/drawingml/2006/main"/>
+          <a:ln xmlns:a="http://schemas.openxmlformats.org/drawingml/2006/main" w="0">
+            <a:noFill/>
+            <a:prstDash val="solid"/>
+          </a:ln>
+        </p:spPr>
+        <p:txBody>
+          <a:bodyPr xmlns:a="http://schemas.openxmlformats.org/drawingml/2006/main"/>
+          <a:lstStyle xmlns:a="http://schemas.openxmlformats.org/drawingml/2006/main"/>
+          <a:p xmlns:a="http://schemas.openxmlformats.org/drawingml/2006/main">
+            <a:pPr>
+              <a:buNone/>
+              <a:defRPr sz="975" b="1">
+                <a:solidFill>
+                  <a:srgbClr val="1F6B57"/>
+                </a:solidFill>
+                <a:latin typeface="Microsoft YaHei"/>
+                <a:ea typeface="Microsoft YaHei"/>
+                <a:cs typeface="Microsoft YaHei"/>
+              </a:defRPr>
+            </a:pPr>
+            <a:r>
+              <a:rPr sz="975" b="1">
+                <a:solidFill>
+                  <a:srgbClr val="1F6B57"/>
+                </a:solidFill>
+                <a:latin typeface="Microsoft YaHei"/>
+                <a:ea typeface="Microsoft YaHei"/>
+                <a:cs typeface="Microsoft YaHei"/>
+              </a:rPr>
+              <a:t>待补充</a:t>
+            </a:r>
+          </a:p>
+        </p:txBody>
+      </p:sp>
+      <p:sp>
+        <p:nvSpPr>
+          <p:cNvPr id="25" name="">
+            <a:extLst xmlns:a="http://schemas.openxmlformats.org/drawingml/2006/main">
+              <a:ext uri="{FF2B5EF4-FFF2-40B4-BE49-F238E27FC236}">
+                <a16:creationId xmlns:a16="http://schemas.microsoft.com/office/drawing/2014/main" id="{55CE6B59-9E81-474D-BA23-952029EA6666}"/>
+              </a:ext>
+            </a:extLst>
+          </p:cNvPr>
+          <p:cNvSpPr>
+            <a:spLocks xmlns:a="http://schemas.openxmlformats.org/drawingml/2006/main" noGrp="1"/>
+          </p:cNvSpPr>
+          <p:nvPr/>
+        </p:nvSpPr>
+        <p:spPr>
+          <a:xfrm xmlns:a="http://schemas.openxmlformats.org/drawingml/2006/main">
+            <a:off x="8801100" y="5276850"/>
+            <a:ext cx="2095500" cy="266700"/>
+          </a:xfrm>
+          <a:prstGeom xmlns:a="http://schemas.openxmlformats.org/drawingml/2006/main" prst="rect">
+            <a:avLst/>
+          </a:prstGeom>
+          <a:noFill xmlns:a="http://schemas.openxmlformats.org/drawingml/2006/main"/>
+          <a:ln xmlns:a="http://schemas.openxmlformats.org/drawingml/2006/main" w="0">
+            <a:noFill/>
+            <a:prstDash val="solid"/>
+          </a:ln>
+        </p:spPr>
+        <p:txBody>
+          <a:bodyPr xmlns:a="http://schemas.openxmlformats.org/drawingml/2006/main"/>
+          <a:lstStyle xmlns:a="http://schemas.openxmlformats.org/drawingml/2006/main"/>
+          <a:p xmlns:a="http://schemas.openxmlformats.org/drawingml/2006/main">
+            <a:pPr>
+              <a:buNone/>
+              <a:defRPr sz="1275" b="1">
+                <a:solidFill>
+                  <a:srgbClr val="1A2A26"/>
+                </a:solidFill>
+                <a:latin typeface="Microsoft YaHei"/>
+                <a:ea typeface="Microsoft YaHei"/>
+                <a:cs typeface="Microsoft YaHei"/>
+              </a:defRPr>
+            </a:pPr>
+            <a:r>
+              <a:rPr sz="1275" b="1">
+                <a:solidFill>
+                  <a:srgbClr val="1A2A26"/>
+                </a:solidFill>
+                <a:latin typeface="Microsoft YaHei"/>
+                <a:ea typeface="Microsoft YaHei"/>
+                <a:cs typeface="Microsoft YaHei"/>
+              </a:rPr>
+              <a:t>0-1范围判断证据</a:t>
+            </a:r>
+          </a:p>
+        </p:txBody>
+      </p:sp>
+      <p:sp>
+        <p:nvSpPr>
+          <p:cNvPr id="26" name="">
+            <a:extLst xmlns:a="http://schemas.openxmlformats.org/drawingml/2006/main">
+              <a:ext uri="{FF2B5EF4-FFF2-40B4-BE49-F238E27FC236}">
+                <a16:creationId xmlns:a16="http://schemas.microsoft.com/office/drawing/2014/main" id="{F8B789FF-7F7A-4EC5-8B33-2A7AB21E2D24}"/>
+              </a:ext>
+            </a:extLst>
+          </p:cNvPr>
+          <p:cNvSpPr>
+            <a:spLocks xmlns:a="http://schemas.openxmlformats.org/drawingml/2006/main" noGrp="1"/>
+          </p:cNvSpPr>
+          <p:nvPr/>
+        </p:nvSpPr>
+        <p:spPr>
+          <a:xfrm xmlns:a="http://schemas.openxmlformats.org/drawingml/2006/main">
+            <a:off x="8001000" y="5562600"/>
+            <a:ext cx="2895600" cy="361950"/>
+          </a:xfrm>
+          <a:prstGeom xmlns:a="http://schemas.openxmlformats.org/drawingml/2006/main" prst="rect">
+            <a:avLst/>
+          </a:prstGeom>
+          <a:noFill xmlns:a="http://schemas.openxmlformats.org/drawingml/2006/main"/>
+          <a:ln xmlns:a="http://schemas.openxmlformats.org/drawingml/2006/main" w="0">
+            <a:noFill/>
+            <a:prstDash val="solid"/>
+          </a:ln>
+        </p:spPr>
+        <p:txBody>
+          <a:bodyPr xmlns:a="http://schemas.openxmlformats.org/drawingml/2006/main"/>
+          <a:lstStyle xmlns:a="http://schemas.openxmlformats.org/drawingml/2006/main"/>
+          <a:p xmlns:a="http://schemas.openxmlformats.org/drawingml/2006/main">
+            <a:pPr>
+              <a:buNone/>
+              <a:defRPr sz="938">
+                <a:solidFill>
+                  <a:srgbClr val="6B746F"/>
+                </a:solidFill>
+                <a:latin typeface="Microsoft YaHei"/>
+                <a:ea typeface="Microsoft YaHei"/>
+                <a:cs typeface="Microsoft YaHei"/>
+              </a:defRPr>
+            </a:pPr>
+            <a:r>
+              <a:rPr sz="938">
+                <a:solidFill>
+                  <a:srgbClr val="6B746F"/>
+                </a:solidFill>
+                <a:latin typeface="Microsoft YaHei"/>
+                <a:ea typeface="Microsoft YaHei"/>
+                <a:cs typeface="Microsoft YaHei"/>
+              </a:rPr>
+              <a:t>PRD片段 / 范围取舍记录 / 用户访谈或评审纪要截图</a:t>
             </a:r>
           </a:p>
         </p:txBody>
@@ -15677,6 +18041,7 @@
           <a:lstStyle xmlns:a="http://schemas.openxmlformats.org/drawingml/2006/main"/>
           <a:p xmlns:a="http://schemas.openxmlformats.org/drawingml/2006/main">
             <a:pPr algn="l">
+              <a:buNone/>
               <a:defRPr sz="975" b="1">
                 <a:solidFill>
                   <a:srgbClr val="C47A2C"/>
@@ -15733,6 +18098,7 @@
           <a:lstStyle xmlns:a="http://schemas.openxmlformats.org/drawingml/2006/main"/>
           <a:p xmlns:a="http://schemas.openxmlformats.org/drawingml/2006/main">
             <a:pPr algn="l">
+              <a:buNone/>
               <a:defRPr sz="2175" b="1">
                 <a:solidFill>
                   <a:srgbClr val="17211F"/>
@@ -15789,6 +18155,7 @@
           <a:lstStyle xmlns:a="http://schemas.openxmlformats.org/drawingml/2006/main"/>
           <a:p xmlns:a="http://schemas.openxmlformats.org/drawingml/2006/main">
             <a:pPr algn="l">
+              <a:buNone/>
               <a:defRPr sz="1200" b="0">
                 <a:solidFill>
                   <a:srgbClr val="65716D"/>
@@ -15911,6 +18278,7 @@
           <a:lstStyle xmlns:a="http://schemas.openxmlformats.org/drawingml/2006/main"/>
           <a:p xmlns:a="http://schemas.openxmlformats.org/drawingml/2006/main">
             <a:pPr algn="l">
+              <a:buNone/>
               <a:defRPr sz="1800" b="1">
                 <a:solidFill>
                   <a:srgbClr val="1F6B57"/>
@@ -15998,6 +18366,7 @@
           <a:lstStyle xmlns:a="http://schemas.openxmlformats.org/drawingml/2006/main"/>
           <a:p xmlns:a="http://schemas.openxmlformats.org/drawingml/2006/main">
             <a:pPr algn="l">
+              <a:buNone/>
               <a:defRPr sz="1350" b="0">
                 <a:solidFill>
                   <a:srgbClr val="17211F"/>
@@ -16085,6 +18454,7 @@
           <a:lstStyle xmlns:a="http://schemas.openxmlformats.org/drawingml/2006/main"/>
           <a:p xmlns:a="http://schemas.openxmlformats.org/drawingml/2006/main">
             <a:pPr algn="l">
+              <a:buNone/>
               <a:defRPr sz="1350" b="0">
                 <a:solidFill>
                   <a:srgbClr val="17211F"/>
@@ -16172,6 +18542,7 @@
           <a:lstStyle xmlns:a="http://schemas.openxmlformats.org/drawingml/2006/main"/>
           <a:p xmlns:a="http://schemas.openxmlformats.org/drawingml/2006/main">
             <a:pPr algn="l">
+              <a:buNone/>
               <a:defRPr sz="1350" b="0">
                 <a:solidFill>
                   <a:srgbClr val="17211F"/>
@@ -16259,6 +18630,7 @@
           <a:lstStyle xmlns:a="http://schemas.openxmlformats.org/drawingml/2006/main"/>
           <a:p xmlns:a="http://schemas.openxmlformats.org/drawingml/2006/main">
             <a:pPr algn="l">
+              <a:buNone/>
               <a:defRPr sz="1350" b="0">
                 <a:solidFill>
                   <a:srgbClr val="17211F"/>
@@ -16346,6 +18718,7 @@
           <a:lstStyle xmlns:a="http://schemas.openxmlformats.org/drawingml/2006/main"/>
           <a:p xmlns:a="http://schemas.openxmlformats.org/drawingml/2006/main">
             <a:pPr algn="l">
+              <a:buNone/>
               <a:defRPr sz="1350" b="0">
                 <a:solidFill>
                   <a:srgbClr val="17211F"/>
@@ -16433,6 +18806,7 @@
           <a:lstStyle xmlns:a="http://schemas.openxmlformats.org/drawingml/2006/main"/>
           <a:p xmlns:a="http://schemas.openxmlformats.org/drawingml/2006/main">
             <a:pPr algn="l">
+              <a:buNone/>
               <a:defRPr sz="1350" b="0">
                 <a:solidFill>
                   <a:srgbClr val="17211F"/>
@@ -16524,6 +18898,7 @@
           <a:lstStyle xmlns:a="http://schemas.openxmlformats.org/drawingml/2006/main"/>
           <a:p xmlns:a="http://schemas.openxmlformats.org/drawingml/2006/main">
             <a:pPr algn="l">
+              <a:buNone/>
               <a:defRPr sz="1800" b="1">
                 <a:solidFill>
                   <a:srgbClr val="2D5F9A"/>
@@ -16611,6 +18986,7 @@
           <a:lstStyle xmlns:a="http://schemas.openxmlformats.org/drawingml/2006/main"/>
           <a:p xmlns:a="http://schemas.openxmlformats.org/drawingml/2006/main">
             <a:pPr algn="l">
+              <a:buNone/>
               <a:defRPr sz="1350" b="0">
                 <a:solidFill>
                   <a:srgbClr val="17211F"/>
@@ -16698,6 +19074,7 @@
           <a:lstStyle xmlns:a="http://schemas.openxmlformats.org/drawingml/2006/main"/>
           <a:p xmlns:a="http://schemas.openxmlformats.org/drawingml/2006/main">
             <a:pPr algn="l">
+              <a:buNone/>
               <a:defRPr sz="1350" b="0">
                 <a:solidFill>
                   <a:srgbClr val="17211F"/>
@@ -16785,6 +19162,7 @@
           <a:lstStyle xmlns:a="http://schemas.openxmlformats.org/drawingml/2006/main"/>
           <a:p xmlns:a="http://schemas.openxmlformats.org/drawingml/2006/main">
             <a:pPr algn="l">
+              <a:buNone/>
               <a:defRPr sz="1350" b="0">
                 <a:solidFill>
                   <a:srgbClr val="17211F"/>
@@ -16872,6 +19250,7 @@
           <a:lstStyle xmlns:a="http://schemas.openxmlformats.org/drawingml/2006/main"/>
           <a:p xmlns:a="http://schemas.openxmlformats.org/drawingml/2006/main">
             <a:pPr algn="l">
+              <a:buNone/>
               <a:defRPr sz="1350" b="0">
                 <a:solidFill>
                   <a:srgbClr val="17211F"/>
@@ -16963,6 +19342,7 @@
           <a:lstStyle xmlns:a="http://schemas.openxmlformats.org/drawingml/2006/main"/>
           <a:p xmlns:a="http://schemas.openxmlformats.org/drawingml/2006/main">
             <a:pPr algn="l">
+              <a:buNone/>
               <a:defRPr sz="1800" b="1">
                 <a:solidFill>
                   <a:srgbClr val="B24A3B"/>
@@ -17050,6 +19430,7 @@
           <a:lstStyle xmlns:a="http://schemas.openxmlformats.org/drawingml/2006/main"/>
           <a:p xmlns:a="http://schemas.openxmlformats.org/drawingml/2006/main">
             <a:pPr algn="l">
+              <a:buNone/>
               <a:defRPr sz="1350" b="0">
                 <a:solidFill>
                   <a:srgbClr val="17211F"/>
@@ -17137,6 +19518,7 @@
           <a:lstStyle xmlns:a="http://schemas.openxmlformats.org/drawingml/2006/main"/>
           <a:p xmlns:a="http://schemas.openxmlformats.org/drawingml/2006/main">
             <a:pPr algn="l">
+              <a:buNone/>
               <a:defRPr sz="1350" b="0">
                 <a:solidFill>
                   <a:srgbClr val="17211F"/>
@@ -17224,6 +19606,7 @@
           <a:lstStyle xmlns:a="http://schemas.openxmlformats.org/drawingml/2006/main"/>
           <a:p xmlns:a="http://schemas.openxmlformats.org/drawingml/2006/main">
             <a:pPr algn="l">
+              <a:buNone/>
               <a:defRPr sz="1350" b="0">
                 <a:solidFill>
                   <a:srgbClr val="17211F"/>
@@ -17311,6 +19694,7 @@
           <a:lstStyle xmlns:a="http://schemas.openxmlformats.org/drawingml/2006/main"/>
           <a:p xmlns:a="http://schemas.openxmlformats.org/drawingml/2006/main">
             <a:pPr algn="l">
+              <a:buNone/>
               <a:defRPr sz="1350" b="0">
                 <a:solidFill>
                   <a:srgbClr val="17211F"/>
@@ -17367,6 +19751,7 @@
           <a:lstStyle xmlns:a="http://schemas.openxmlformats.org/drawingml/2006/main"/>
           <a:p xmlns:a="http://schemas.openxmlformats.org/drawingml/2006/main">
             <a:pPr algn="ctr">
+              <a:buNone/>
               <a:defRPr sz="1650" b="1">
                 <a:solidFill>
                   <a:srgbClr val="17211F"/>
@@ -17423,6 +19808,7 @@
           <a:lstStyle xmlns:a="http://schemas.openxmlformats.org/drawingml/2006/main"/>
           <a:p xmlns:a="http://schemas.openxmlformats.org/drawingml/2006/main">
             <a:pPr algn="l">
+              <a:buNone/>
               <a:defRPr sz="750" b="0">
                 <a:solidFill>
                   <a:srgbClr val="65716D"/>
@@ -17442,6 +19828,212 @@
                 <a:cs typeface="Microsoft YaHei"/>
               </a:rPr>
               <a:t>作品集用途：求职面试 / 产品经理能力证明；所有指标以可公开证据为准</a:t>
+            </a:r>
+          </a:p>
+        </p:txBody>
+      </p:sp>
+      <p:sp>
+        <p:nvSpPr>
+          <p:cNvPr id="41" name="material-slot-MVP范围与风险文档">
+            <a:extLst xmlns:a="http://schemas.openxmlformats.org/drawingml/2006/main">
+              <a:ext uri="{FF2B5EF4-FFF2-40B4-BE49-F238E27FC236}">
+                <a16:creationId xmlns:a16="http://schemas.microsoft.com/office/drawing/2014/main" id="{162DF5F3-98D2-43EE-905B-D3C051FA7E21}"/>
+              </a:ext>
+            </a:extLst>
+          </p:cNvPr>
+          <p:cNvSpPr>
+            <a:spLocks xmlns:a="http://schemas.openxmlformats.org/drawingml/2006/main" noGrp="1"/>
+          </p:cNvSpPr>
+          <p:nvPr/>
+        </p:nvSpPr>
+        <p:spPr>
+          <a:xfrm xmlns:a="http://schemas.openxmlformats.org/drawingml/2006/main">
+            <a:off x="7829550" y="5162550"/>
+            <a:ext cx="3238500" cy="838200"/>
+          </a:xfrm>
+          <a:prstGeom xmlns:a="http://schemas.openxmlformats.org/drawingml/2006/main" prst="roundRect">
+            <a:avLst>
+              <a:gd name="adj" fmla="val 9091"/>
+            </a:avLst>
+          </a:prstGeom>
+          <a:solidFill xmlns:a="http://schemas.openxmlformats.org/drawingml/2006/main">
+            <a:srgbClr val="F7FAF8"/>
+          </a:solidFill>
+          <a:ln xmlns:a="http://schemas.openxmlformats.org/drawingml/2006/main" w="14288">
+            <a:solidFill>
+              <a:srgbClr val="1F6B57"/>
+            </a:solidFill>
+            <a:prstDash val="dash"/>
+          </a:ln>
+        </p:spPr>
+      </p:sp>
+      <p:sp>
+        <p:nvSpPr>
+          <p:cNvPr id="42" name="">
+            <a:extLst xmlns:a="http://schemas.openxmlformats.org/drawingml/2006/main">
+              <a:ext uri="{FF2B5EF4-FFF2-40B4-BE49-F238E27FC236}">
+                <a16:creationId xmlns:a16="http://schemas.microsoft.com/office/drawing/2014/main" id="{D8AC6C07-CC2D-49AF-A6BE-65B53509FBF9}"/>
+              </a:ext>
+            </a:extLst>
+          </p:cNvPr>
+          <p:cNvSpPr>
+            <a:spLocks xmlns:a="http://schemas.openxmlformats.org/drawingml/2006/main" noGrp="1"/>
+          </p:cNvSpPr>
+          <p:nvPr/>
+        </p:nvSpPr>
+        <p:spPr>
+          <a:xfrm xmlns:a="http://schemas.openxmlformats.org/drawingml/2006/main">
+            <a:off x="8001000" y="5295900"/>
+            <a:ext cx="781050" cy="228600"/>
+          </a:xfrm>
+          <a:prstGeom xmlns:a="http://schemas.openxmlformats.org/drawingml/2006/main" prst="rect">
+            <a:avLst/>
+          </a:prstGeom>
+          <a:noFill xmlns:a="http://schemas.openxmlformats.org/drawingml/2006/main"/>
+          <a:ln xmlns:a="http://schemas.openxmlformats.org/drawingml/2006/main" w="0">
+            <a:noFill/>
+            <a:prstDash val="solid"/>
+          </a:ln>
+        </p:spPr>
+        <p:txBody>
+          <a:bodyPr xmlns:a="http://schemas.openxmlformats.org/drawingml/2006/main"/>
+          <a:lstStyle xmlns:a="http://schemas.openxmlformats.org/drawingml/2006/main"/>
+          <a:p xmlns:a="http://schemas.openxmlformats.org/drawingml/2006/main">
+            <a:pPr>
+              <a:buNone/>
+              <a:defRPr sz="975" b="1">
+                <a:solidFill>
+                  <a:srgbClr val="1F6B57"/>
+                </a:solidFill>
+                <a:latin typeface="Microsoft YaHei"/>
+                <a:ea typeface="Microsoft YaHei"/>
+                <a:cs typeface="Microsoft YaHei"/>
+              </a:defRPr>
+            </a:pPr>
+            <a:r>
+              <a:rPr sz="975" b="1">
+                <a:solidFill>
+                  <a:srgbClr val="1F6B57"/>
+                </a:solidFill>
+                <a:latin typeface="Microsoft YaHei"/>
+                <a:ea typeface="Microsoft YaHei"/>
+                <a:cs typeface="Microsoft YaHei"/>
+              </a:rPr>
+              <a:t>待补充</a:t>
+            </a:r>
+          </a:p>
+        </p:txBody>
+      </p:sp>
+      <p:sp>
+        <p:nvSpPr>
+          <p:cNvPr id="43" name="">
+            <a:extLst xmlns:a="http://schemas.openxmlformats.org/drawingml/2006/main">
+              <a:ext uri="{FF2B5EF4-FFF2-40B4-BE49-F238E27FC236}">
+                <a16:creationId xmlns:a16="http://schemas.microsoft.com/office/drawing/2014/main" id="{77583AD9-C222-4121-A54C-0CC2ACBD5772}"/>
+              </a:ext>
+            </a:extLst>
+          </p:cNvPr>
+          <p:cNvSpPr>
+            <a:spLocks xmlns:a="http://schemas.openxmlformats.org/drawingml/2006/main" noGrp="1"/>
+          </p:cNvSpPr>
+          <p:nvPr/>
+        </p:nvSpPr>
+        <p:spPr>
+          <a:xfrm xmlns:a="http://schemas.openxmlformats.org/drawingml/2006/main">
+            <a:off x="8801100" y="5276850"/>
+            <a:ext cx="2095500" cy="266700"/>
+          </a:xfrm>
+          <a:prstGeom xmlns:a="http://schemas.openxmlformats.org/drawingml/2006/main" prst="rect">
+            <a:avLst/>
+          </a:prstGeom>
+          <a:noFill xmlns:a="http://schemas.openxmlformats.org/drawingml/2006/main"/>
+          <a:ln xmlns:a="http://schemas.openxmlformats.org/drawingml/2006/main" w="0">
+            <a:noFill/>
+            <a:prstDash val="solid"/>
+          </a:ln>
+        </p:spPr>
+        <p:txBody>
+          <a:bodyPr xmlns:a="http://schemas.openxmlformats.org/drawingml/2006/main"/>
+          <a:lstStyle xmlns:a="http://schemas.openxmlformats.org/drawingml/2006/main"/>
+          <a:p xmlns:a="http://schemas.openxmlformats.org/drawingml/2006/main">
+            <a:pPr>
+              <a:buNone/>
+              <a:defRPr sz="1275" b="1">
+                <a:solidFill>
+                  <a:srgbClr val="1A2A26"/>
+                </a:solidFill>
+                <a:latin typeface="Microsoft YaHei"/>
+                <a:ea typeface="Microsoft YaHei"/>
+                <a:cs typeface="Microsoft YaHei"/>
+              </a:defRPr>
+            </a:pPr>
+            <a:r>
+              <a:rPr sz="1275" b="1">
+                <a:solidFill>
+                  <a:srgbClr val="1A2A26"/>
+                </a:solidFill>
+                <a:latin typeface="Microsoft YaHei"/>
+                <a:ea typeface="Microsoft YaHei"/>
+                <a:cs typeface="Microsoft YaHei"/>
+              </a:rPr>
+              <a:t>MVP范围与风险文档</a:t>
+            </a:r>
+          </a:p>
+        </p:txBody>
+      </p:sp>
+      <p:sp>
+        <p:nvSpPr>
+          <p:cNvPr id="44" name="">
+            <a:extLst xmlns:a="http://schemas.openxmlformats.org/drawingml/2006/main">
+              <a:ext uri="{FF2B5EF4-FFF2-40B4-BE49-F238E27FC236}">
+                <a16:creationId xmlns:a16="http://schemas.microsoft.com/office/drawing/2014/main" id="{E37E8B4D-AF3D-4F92-BD79-24382C7588CF}"/>
+              </a:ext>
+            </a:extLst>
+          </p:cNvPr>
+          <p:cNvSpPr>
+            <a:spLocks xmlns:a="http://schemas.openxmlformats.org/drawingml/2006/main" noGrp="1"/>
+          </p:cNvSpPr>
+          <p:nvPr/>
+        </p:nvSpPr>
+        <p:spPr>
+          <a:xfrm xmlns:a="http://schemas.openxmlformats.org/drawingml/2006/main">
+            <a:off x="8001000" y="5562600"/>
+            <a:ext cx="2895600" cy="361950"/>
+          </a:xfrm>
+          <a:prstGeom xmlns:a="http://schemas.openxmlformats.org/drawingml/2006/main" prst="rect">
+            <a:avLst/>
+          </a:prstGeom>
+          <a:noFill xmlns:a="http://schemas.openxmlformats.org/drawingml/2006/main"/>
+          <a:ln xmlns:a="http://schemas.openxmlformats.org/drawingml/2006/main" w="0">
+            <a:noFill/>
+            <a:prstDash val="solid"/>
+          </a:ln>
+        </p:spPr>
+        <p:txBody>
+          <a:bodyPr xmlns:a="http://schemas.openxmlformats.org/drawingml/2006/main"/>
+          <a:lstStyle xmlns:a="http://schemas.openxmlformats.org/drawingml/2006/main"/>
+          <a:p xmlns:a="http://schemas.openxmlformats.org/drawingml/2006/main">
+            <a:pPr>
+              <a:buNone/>
+              <a:defRPr sz="938">
+                <a:solidFill>
+                  <a:srgbClr val="6B746F"/>
+                </a:solidFill>
+                <a:latin typeface="Microsoft YaHei"/>
+                <a:ea typeface="Microsoft YaHei"/>
+                <a:cs typeface="Microsoft YaHei"/>
+              </a:defRPr>
+            </a:pPr>
+            <a:r>
+              <a:rPr sz="938">
+                <a:solidFill>
+                  <a:srgbClr val="6B746F"/>
+                </a:solidFill>
+                <a:latin typeface="Microsoft YaHei"/>
+                <a:ea typeface="Microsoft YaHei"/>
+                <a:cs typeface="Microsoft YaHei"/>
+              </a:rPr>
+              <a:t>保留/延后/禁止自动化清单、验收口径或需求评审截图</a:t>
             </a:r>
           </a:p>
         </p:txBody>
@@ -17508,6 +20100,7 @@
           <a:lstStyle xmlns:a="http://schemas.openxmlformats.org/drawingml/2006/main"/>
           <a:p xmlns:a="http://schemas.openxmlformats.org/drawingml/2006/main">
             <a:pPr algn="l">
+              <a:buNone/>
               <a:defRPr sz="975" b="1">
                 <a:solidFill>
                   <a:srgbClr val="C47A2C"/>
@@ -17564,6 +20157,7 @@
           <a:lstStyle xmlns:a="http://schemas.openxmlformats.org/drawingml/2006/main"/>
           <a:p xmlns:a="http://schemas.openxmlformats.org/drawingml/2006/main">
             <a:pPr algn="l">
+              <a:buNone/>
               <a:defRPr sz="2175" b="1">
                 <a:solidFill>
                   <a:srgbClr val="17211F"/>
@@ -17620,6 +20214,7 @@
           <a:lstStyle xmlns:a="http://schemas.openxmlformats.org/drawingml/2006/main"/>
           <a:p xmlns:a="http://schemas.openxmlformats.org/drawingml/2006/main">
             <a:pPr algn="l">
+              <a:buNone/>
               <a:defRPr sz="1200" b="0">
                 <a:solidFill>
                   <a:srgbClr val="65716D"/>
@@ -17742,6 +20337,7 @@
           <a:lstStyle xmlns:a="http://schemas.openxmlformats.org/drawingml/2006/main"/>
           <a:p xmlns:a="http://schemas.openxmlformats.org/drawingml/2006/main">
             <a:pPr algn="ctr">
+              <a:buNone/>
               <a:defRPr sz="1050" b="1">
                 <a:solidFill>
                   <a:srgbClr val="17211F"/>
@@ -17864,6 +20460,7 @@
           <a:lstStyle xmlns:a="http://schemas.openxmlformats.org/drawingml/2006/main"/>
           <a:p xmlns:a="http://schemas.openxmlformats.org/drawingml/2006/main">
             <a:pPr algn="ctr">
+              <a:buNone/>
               <a:defRPr sz="1050" b="1">
                 <a:solidFill>
                   <a:srgbClr val="17211F"/>
@@ -17986,6 +20583,7 @@
           <a:lstStyle xmlns:a="http://schemas.openxmlformats.org/drawingml/2006/main"/>
           <a:p xmlns:a="http://schemas.openxmlformats.org/drawingml/2006/main">
             <a:pPr algn="ctr">
+              <a:buNone/>
               <a:defRPr sz="1050" b="1">
                 <a:solidFill>
                   <a:srgbClr val="17211F"/>
@@ -18108,6 +20706,7 @@
           <a:lstStyle xmlns:a="http://schemas.openxmlformats.org/drawingml/2006/main"/>
           <a:p xmlns:a="http://schemas.openxmlformats.org/drawingml/2006/main">
             <a:pPr algn="ctr">
+              <a:buNone/>
               <a:defRPr sz="1050" b="1">
                 <a:solidFill>
                   <a:srgbClr val="17211F"/>
@@ -18230,6 +20829,7 @@
           <a:lstStyle xmlns:a="http://schemas.openxmlformats.org/drawingml/2006/main"/>
           <a:p xmlns:a="http://schemas.openxmlformats.org/drawingml/2006/main">
             <a:pPr algn="ctr">
+              <a:buNone/>
               <a:defRPr sz="1050" b="1">
                 <a:solidFill>
                   <a:srgbClr val="17211F"/>
@@ -18352,6 +20952,7 @@
           <a:lstStyle xmlns:a="http://schemas.openxmlformats.org/drawingml/2006/main"/>
           <a:p xmlns:a="http://schemas.openxmlformats.org/drawingml/2006/main">
             <a:pPr algn="ctr">
+              <a:buNone/>
               <a:defRPr sz="1050" b="1">
                 <a:solidFill>
                   <a:srgbClr val="17211F"/>
@@ -18474,6 +21075,7 @@
           <a:lstStyle xmlns:a="http://schemas.openxmlformats.org/drawingml/2006/main"/>
           <a:p xmlns:a="http://schemas.openxmlformats.org/drawingml/2006/main">
             <a:pPr algn="ctr">
+              <a:buNone/>
               <a:defRPr sz="1050" b="1">
                 <a:solidFill>
                   <a:srgbClr val="17211F"/>
@@ -18596,6 +21198,7 @@
           <a:lstStyle xmlns:a="http://schemas.openxmlformats.org/drawingml/2006/main"/>
           <a:p xmlns:a="http://schemas.openxmlformats.org/drawingml/2006/main">
             <a:pPr algn="ctr">
+              <a:buNone/>
               <a:defRPr sz="1050" b="1">
                 <a:solidFill>
                   <a:srgbClr val="17211F"/>
@@ -18687,6 +21290,7 @@
           <a:lstStyle xmlns:a="http://schemas.openxmlformats.org/drawingml/2006/main"/>
           <a:p xmlns:a="http://schemas.openxmlformats.org/drawingml/2006/main">
             <a:pPr algn="ctr">
+              <a:buNone/>
               <a:defRPr sz="1650" b="1">
                 <a:solidFill>
                   <a:srgbClr val="1F6B57"/>
@@ -18743,6 +21347,7 @@
           <a:lstStyle xmlns:a="http://schemas.openxmlformats.org/drawingml/2006/main"/>
           <a:p xmlns:a="http://schemas.openxmlformats.org/drawingml/2006/main">
             <a:pPr algn="ctr">
+              <a:buNone/>
               <a:defRPr sz="1200" b="0">
                 <a:solidFill>
                   <a:srgbClr val="65716D"/>
@@ -18834,6 +21439,7 @@
           <a:lstStyle xmlns:a="http://schemas.openxmlformats.org/drawingml/2006/main"/>
           <a:p xmlns:a="http://schemas.openxmlformats.org/drawingml/2006/main">
             <a:pPr algn="ctr">
+              <a:buNone/>
               <a:defRPr sz="1650" b="1">
                 <a:solidFill>
                   <a:srgbClr val="218A8A"/>
@@ -18890,6 +21496,7 @@
           <a:lstStyle xmlns:a="http://schemas.openxmlformats.org/drawingml/2006/main"/>
           <a:p xmlns:a="http://schemas.openxmlformats.org/drawingml/2006/main">
             <a:pPr algn="ctr">
+              <a:buNone/>
               <a:defRPr sz="1200" b="0">
                 <a:solidFill>
                   <a:srgbClr val="65716D"/>
@@ -18981,6 +21588,7 @@
           <a:lstStyle xmlns:a="http://schemas.openxmlformats.org/drawingml/2006/main"/>
           <a:p xmlns:a="http://schemas.openxmlformats.org/drawingml/2006/main">
             <a:pPr algn="ctr">
+              <a:buNone/>
               <a:defRPr sz="1650" b="1">
                 <a:solidFill>
                   <a:srgbClr val="1F6B57"/>
@@ -19037,6 +21645,7 @@
           <a:lstStyle xmlns:a="http://schemas.openxmlformats.org/drawingml/2006/main"/>
           <a:p xmlns:a="http://schemas.openxmlformats.org/drawingml/2006/main">
             <a:pPr algn="ctr">
+              <a:buNone/>
               <a:defRPr sz="1200" b="0">
                 <a:solidFill>
                   <a:srgbClr val="65716D"/>
@@ -19093,6 +21702,7 @@
           <a:lstStyle xmlns:a="http://schemas.openxmlformats.org/drawingml/2006/main"/>
           <a:p xmlns:a="http://schemas.openxmlformats.org/drawingml/2006/main">
             <a:pPr algn="ctr">
+              <a:buNone/>
               <a:defRPr sz="1500" b="1">
                 <a:solidFill>
                   <a:srgbClr val="17211F"/>
@@ -19149,6 +21759,7 @@
           <a:lstStyle xmlns:a="http://schemas.openxmlformats.org/drawingml/2006/main"/>
           <a:p xmlns:a="http://schemas.openxmlformats.org/drawingml/2006/main">
             <a:pPr algn="l">
+              <a:buNone/>
               <a:defRPr sz="750" b="0">
                 <a:solidFill>
                   <a:srgbClr val="65716D"/>
@@ -19234,6 +21845,7 @@
           <a:lstStyle xmlns:a="http://schemas.openxmlformats.org/drawingml/2006/main"/>
           <a:p xmlns:a="http://schemas.openxmlformats.org/drawingml/2006/main">
             <a:pPr algn="l">
+              <a:buNone/>
               <a:defRPr sz="975" b="1">
                 <a:solidFill>
                   <a:srgbClr val="C47A2C"/>
@@ -19290,6 +21902,7 @@
           <a:lstStyle xmlns:a="http://schemas.openxmlformats.org/drawingml/2006/main"/>
           <a:p xmlns:a="http://schemas.openxmlformats.org/drawingml/2006/main">
             <a:pPr algn="l">
+              <a:buNone/>
               <a:defRPr sz="2175" b="1">
                 <a:solidFill>
                   <a:srgbClr val="17211F"/>
@@ -19346,6 +21959,7 @@
           <a:lstStyle xmlns:a="http://schemas.openxmlformats.org/drawingml/2006/main"/>
           <a:p xmlns:a="http://schemas.openxmlformats.org/drawingml/2006/main">
             <a:pPr algn="l">
+              <a:buNone/>
               <a:defRPr sz="1200" b="0">
                 <a:solidFill>
                   <a:srgbClr val="65716D"/>
@@ -19468,6 +22082,7 @@
           <a:lstStyle xmlns:a="http://schemas.openxmlformats.org/drawingml/2006/main"/>
           <a:p xmlns:a="http://schemas.openxmlformats.org/drawingml/2006/main">
             <a:pPr algn="l">
+              <a:buNone/>
               <a:defRPr sz="1650" b="1">
                 <a:solidFill>
                   <a:srgbClr val="1F6B57"/>
@@ -19555,6 +22170,7 @@
           <a:lstStyle xmlns:a="http://schemas.openxmlformats.org/drawingml/2006/main"/>
           <a:p xmlns:a="http://schemas.openxmlformats.org/drawingml/2006/main">
             <a:pPr algn="l">
+              <a:buNone/>
               <a:defRPr sz="1125" b="0">
                 <a:solidFill>
                   <a:srgbClr val="17211F"/>
@@ -19642,6 +22258,7 @@
           <a:lstStyle xmlns:a="http://schemas.openxmlformats.org/drawingml/2006/main"/>
           <a:p xmlns:a="http://schemas.openxmlformats.org/drawingml/2006/main">
             <a:pPr algn="l">
+              <a:buNone/>
               <a:defRPr sz="1125" b="0">
                 <a:solidFill>
                   <a:srgbClr val="17211F"/>
@@ -19729,6 +22346,7 @@
           <a:lstStyle xmlns:a="http://schemas.openxmlformats.org/drawingml/2006/main"/>
           <a:p xmlns:a="http://schemas.openxmlformats.org/drawingml/2006/main">
             <a:pPr algn="l">
+              <a:buNone/>
               <a:defRPr sz="1125" b="0">
                 <a:solidFill>
                   <a:srgbClr val="17211F"/>
@@ -19820,6 +22438,7 @@
           <a:lstStyle xmlns:a="http://schemas.openxmlformats.org/drawingml/2006/main"/>
           <a:p xmlns:a="http://schemas.openxmlformats.org/drawingml/2006/main">
             <a:pPr algn="l">
+              <a:buNone/>
               <a:defRPr sz="1650" b="1">
                 <a:solidFill>
                   <a:srgbClr val="1F6B57"/>
@@ -19907,6 +22526,7 @@
           <a:lstStyle xmlns:a="http://schemas.openxmlformats.org/drawingml/2006/main"/>
           <a:p xmlns:a="http://schemas.openxmlformats.org/drawingml/2006/main">
             <a:pPr algn="l">
+              <a:buNone/>
               <a:defRPr sz="1125" b="0">
                 <a:solidFill>
                   <a:srgbClr val="17211F"/>
@@ -19994,6 +22614,7 @@
           <a:lstStyle xmlns:a="http://schemas.openxmlformats.org/drawingml/2006/main"/>
           <a:p xmlns:a="http://schemas.openxmlformats.org/drawingml/2006/main">
             <a:pPr algn="l">
+              <a:buNone/>
               <a:defRPr sz="1125" b="0">
                 <a:solidFill>
                   <a:srgbClr val="17211F"/>
@@ -20081,6 +22702,7 @@
           <a:lstStyle xmlns:a="http://schemas.openxmlformats.org/drawingml/2006/main"/>
           <a:p xmlns:a="http://schemas.openxmlformats.org/drawingml/2006/main">
             <a:pPr algn="l">
+              <a:buNone/>
               <a:defRPr sz="1125" b="0">
                 <a:solidFill>
                   <a:srgbClr val="17211F"/>
@@ -20168,6 +22790,7 @@
           <a:lstStyle xmlns:a="http://schemas.openxmlformats.org/drawingml/2006/main"/>
           <a:p xmlns:a="http://schemas.openxmlformats.org/drawingml/2006/main">
             <a:pPr algn="l">
+              <a:buNone/>
               <a:defRPr sz="1125" b="0">
                 <a:solidFill>
                   <a:srgbClr val="17211F"/>
@@ -20259,6 +22882,7 @@
           <a:lstStyle xmlns:a="http://schemas.openxmlformats.org/drawingml/2006/main"/>
           <a:p xmlns:a="http://schemas.openxmlformats.org/drawingml/2006/main">
             <a:pPr algn="l">
+              <a:buNone/>
               <a:defRPr sz="1650" b="1">
                 <a:solidFill>
                   <a:srgbClr val="1F6B57"/>
@@ -20346,6 +22970,7 @@
           <a:lstStyle xmlns:a="http://schemas.openxmlformats.org/drawingml/2006/main"/>
           <a:p xmlns:a="http://schemas.openxmlformats.org/drawingml/2006/main">
             <a:pPr algn="l">
+              <a:buNone/>
               <a:defRPr sz="1125" b="0">
                 <a:solidFill>
                   <a:srgbClr val="17211F"/>
@@ -20433,6 +23058,7 @@
           <a:lstStyle xmlns:a="http://schemas.openxmlformats.org/drawingml/2006/main"/>
           <a:p xmlns:a="http://schemas.openxmlformats.org/drawingml/2006/main">
             <a:pPr algn="l">
+              <a:buNone/>
               <a:defRPr sz="1125" b="0">
                 <a:solidFill>
                   <a:srgbClr val="17211F"/>
@@ -20520,6 +23146,7 @@
           <a:lstStyle xmlns:a="http://schemas.openxmlformats.org/drawingml/2006/main"/>
           <a:p xmlns:a="http://schemas.openxmlformats.org/drawingml/2006/main">
             <a:pPr algn="l">
+              <a:buNone/>
               <a:defRPr sz="1125" b="0">
                 <a:solidFill>
                   <a:srgbClr val="17211F"/>
@@ -20611,6 +23238,7 @@
           <a:lstStyle xmlns:a="http://schemas.openxmlformats.org/drawingml/2006/main"/>
           <a:p xmlns:a="http://schemas.openxmlformats.org/drawingml/2006/main">
             <a:pPr algn="l">
+              <a:buNone/>
               <a:defRPr sz="1650" b="1">
                 <a:solidFill>
                   <a:srgbClr val="B24A3B"/>
@@ -20698,6 +23326,7 @@
           <a:lstStyle xmlns:a="http://schemas.openxmlformats.org/drawingml/2006/main"/>
           <a:p xmlns:a="http://schemas.openxmlformats.org/drawingml/2006/main">
             <a:pPr algn="l">
+              <a:buNone/>
               <a:defRPr sz="1125" b="0">
                 <a:solidFill>
                   <a:srgbClr val="17211F"/>
@@ -20785,6 +23414,7 @@
           <a:lstStyle xmlns:a="http://schemas.openxmlformats.org/drawingml/2006/main"/>
           <a:p xmlns:a="http://schemas.openxmlformats.org/drawingml/2006/main">
             <a:pPr algn="l">
+              <a:buNone/>
               <a:defRPr sz="1125" b="0">
                 <a:solidFill>
                   <a:srgbClr val="17211F"/>
@@ -20872,6 +23502,7 @@
           <a:lstStyle xmlns:a="http://schemas.openxmlformats.org/drawingml/2006/main"/>
           <a:p xmlns:a="http://schemas.openxmlformats.org/drawingml/2006/main">
             <a:pPr algn="l">
+              <a:buNone/>
               <a:defRPr sz="1125" b="0">
                 <a:solidFill>
                   <a:srgbClr val="17211F"/>
@@ -20928,6 +23559,7 @@
           <a:lstStyle xmlns:a="http://schemas.openxmlformats.org/drawingml/2006/main"/>
           <a:p xmlns:a="http://schemas.openxmlformats.org/drawingml/2006/main">
             <a:pPr algn="ctr">
+              <a:buNone/>
               <a:defRPr sz="1500" b="1">
                 <a:solidFill>
                   <a:srgbClr val="17211F"/>
@@ -20984,6 +23616,7 @@
           <a:lstStyle xmlns:a="http://schemas.openxmlformats.org/drawingml/2006/main"/>
           <a:p xmlns:a="http://schemas.openxmlformats.org/drawingml/2006/main">
             <a:pPr algn="l">
+              <a:buNone/>
               <a:defRPr sz="750" b="0">
                 <a:solidFill>
                   <a:srgbClr val="65716D"/>
@@ -21003,6 +23636,212 @@
                 <a:cs typeface="Microsoft YaHei"/>
               </a:rPr>
               <a:t>作品集用途：求职面试 / 产品经理能力证明；所有指标以可公开证据为准</a:t>
+            </a:r>
+          </a:p>
+        </p:txBody>
+      </p:sp>
+      <p:sp>
+        <p:nvSpPr>
+          <p:cNvPr id="41" name="material-slot-Agent需求材料">
+            <a:extLst xmlns:a="http://schemas.openxmlformats.org/drawingml/2006/main">
+              <a:ext uri="{FF2B5EF4-FFF2-40B4-BE49-F238E27FC236}">
+                <a16:creationId xmlns:a16="http://schemas.microsoft.com/office/drawing/2014/main" id="{3B5EE8ED-3A6E-4EAB-996C-537C51182E78}"/>
+              </a:ext>
+            </a:extLst>
+          </p:cNvPr>
+          <p:cNvSpPr>
+            <a:spLocks xmlns:a="http://schemas.openxmlformats.org/drawingml/2006/main" noGrp="1"/>
+          </p:cNvSpPr>
+          <p:nvPr/>
+        </p:nvSpPr>
+        <p:spPr>
+          <a:xfrm xmlns:a="http://schemas.openxmlformats.org/drawingml/2006/main">
+            <a:off x="8343900" y="1123950"/>
+            <a:ext cx="2781300" cy="666750"/>
+          </a:xfrm>
+          <a:prstGeom xmlns:a="http://schemas.openxmlformats.org/drawingml/2006/main" prst="roundRect">
+            <a:avLst>
+              <a:gd name="adj" fmla="val 11429"/>
+            </a:avLst>
+          </a:prstGeom>
+          <a:solidFill xmlns:a="http://schemas.openxmlformats.org/drawingml/2006/main">
+            <a:srgbClr val="F2FAFB"/>
+          </a:solidFill>
+          <a:ln xmlns:a="http://schemas.openxmlformats.org/drawingml/2006/main" w="14288">
+            <a:solidFill>
+              <a:srgbClr val="2A91A3"/>
+            </a:solidFill>
+            <a:prstDash val="dash"/>
+          </a:ln>
+        </p:spPr>
+      </p:sp>
+      <p:sp>
+        <p:nvSpPr>
+          <p:cNvPr id="42" name="">
+            <a:extLst xmlns:a="http://schemas.openxmlformats.org/drawingml/2006/main">
+              <a:ext uri="{FF2B5EF4-FFF2-40B4-BE49-F238E27FC236}">
+                <a16:creationId xmlns:a16="http://schemas.microsoft.com/office/drawing/2014/main" id="{27CEC09E-9565-4CB2-9CC3-1382045683AA}"/>
+              </a:ext>
+            </a:extLst>
+          </p:cNvPr>
+          <p:cNvSpPr>
+            <a:spLocks xmlns:a="http://schemas.openxmlformats.org/drawingml/2006/main" noGrp="1"/>
+          </p:cNvSpPr>
+          <p:nvPr/>
+        </p:nvSpPr>
+        <p:spPr>
+          <a:xfrm xmlns:a="http://schemas.openxmlformats.org/drawingml/2006/main">
+            <a:off x="8515350" y="1257300"/>
+            <a:ext cx="781050" cy="228600"/>
+          </a:xfrm>
+          <a:prstGeom xmlns:a="http://schemas.openxmlformats.org/drawingml/2006/main" prst="rect">
+            <a:avLst/>
+          </a:prstGeom>
+          <a:noFill xmlns:a="http://schemas.openxmlformats.org/drawingml/2006/main"/>
+          <a:ln xmlns:a="http://schemas.openxmlformats.org/drawingml/2006/main" w="0">
+            <a:noFill/>
+            <a:prstDash val="solid"/>
+          </a:ln>
+        </p:spPr>
+        <p:txBody>
+          <a:bodyPr xmlns:a="http://schemas.openxmlformats.org/drawingml/2006/main"/>
+          <a:lstStyle xmlns:a="http://schemas.openxmlformats.org/drawingml/2006/main"/>
+          <a:p xmlns:a="http://schemas.openxmlformats.org/drawingml/2006/main">
+            <a:pPr>
+              <a:buNone/>
+              <a:defRPr sz="975" b="1">
+                <a:solidFill>
+                  <a:srgbClr val="2A91A3"/>
+                </a:solidFill>
+                <a:latin typeface="Microsoft YaHei"/>
+                <a:ea typeface="Microsoft YaHei"/>
+                <a:cs typeface="Microsoft YaHei"/>
+              </a:defRPr>
+            </a:pPr>
+            <a:r>
+              <a:rPr sz="975" b="1">
+                <a:solidFill>
+                  <a:srgbClr val="2A91A3"/>
+                </a:solidFill>
+                <a:latin typeface="Microsoft YaHei"/>
+                <a:ea typeface="Microsoft YaHei"/>
+                <a:cs typeface="Microsoft YaHei"/>
+              </a:rPr>
+              <a:t>待补充</a:t>
+            </a:r>
+          </a:p>
+        </p:txBody>
+      </p:sp>
+      <p:sp>
+        <p:nvSpPr>
+          <p:cNvPr id="43" name="">
+            <a:extLst xmlns:a="http://schemas.openxmlformats.org/drawingml/2006/main">
+              <a:ext uri="{FF2B5EF4-FFF2-40B4-BE49-F238E27FC236}">
+                <a16:creationId xmlns:a16="http://schemas.microsoft.com/office/drawing/2014/main" id="{FF84D5AF-F627-401F-8DB6-7505B9382F52}"/>
+              </a:ext>
+            </a:extLst>
+          </p:cNvPr>
+          <p:cNvSpPr>
+            <a:spLocks xmlns:a="http://schemas.openxmlformats.org/drawingml/2006/main" noGrp="1"/>
+          </p:cNvSpPr>
+          <p:nvPr/>
+        </p:nvSpPr>
+        <p:spPr>
+          <a:xfrm xmlns:a="http://schemas.openxmlformats.org/drawingml/2006/main">
+            <a:off x="9315450" y="1238250"/>
+            <a:ext cx="1638300" cy="266700"/>
+          </a:xfrm>
+          <a:prstGeom xmlns:a="http://schemas.openxmlformats.org/drawingml/2006/main" prst="rect">
+            <a:avLst/>
+          </a:prstGeom>
+          <a:noFill xmlns:a="http://schemas.openxmlformats.org/drawingml/2006/main"/>
+          <a:ln xmlns:a="http://schemas.openxmlformats.org/drawingml/2006/main" w="0">
+            <a:noFill/>
+            <a:prstDash val="solid"/>
+          </a:ln>
+        </p:spPr>
+        <p:txBody>
+          <a:bodyPr xmlns:a="http://schemas.openxmlformats.org/drawingml/2006/main"/>
+          <a:lstStyle xmlns:a="http://schemas.openxmlformats.org/drawingml/2006/main"/>
+          <a:p xmlns:a="http://schemas.openxmlformats.org/drawingml/2006/main">
+            <a:pPr>
+              <a:buNone/>
+              <a:defRPr sz="1275" b="1">
+                <a:solidFill>
+                  <a:srgbClr val="1A2A26"/>
+                </a:solidFill>
+                <a:latin typeface="Microsoft YaHei"/>
+                <a:ea typeface="Microsoft YaHei"/>
+                <a:cs typeface="Microsoft YaHei"/>
+              </a:defRPr>
+            </a:pPr>
+            <a:r>
+              <a:rPr sz="1275" b="1">
+                <a:solidFill>
+                  <a:srgbClr val="1A2A26"/>
+                </a:solidFill>
+                <a:latin typeface="Microsoft YaHei"/>
+                <a:ea typeface="Microsoft YaHei"/>
+                <a:cs typeface="Microsoft YaHei"/>
+              </a:rPr>
+              <a:t>Agent需求材料</a:t>
+            </a:r>
+          </a:p>
+        </p:txBody>
+      </p:sp>
+      <p:sp>
+        <p:nvSpPr>
+          <p:cNvPr id="44" name="">
+            <a:extLst xmlns:a="http://schemas.openxmlformats.org/drawingml/2006/main">
+              <a:ext uri="{FF2B5EF4-FFF2-40B4-BE49-F238E27FC236}">
+                <a16:creationId xmlns:a16="http://schemas.microsoft.com/office/drawing/2014/main" id="{60C10560-228D-4C68-8A87-17BE5A583DC2}"/>
+              </a:ext>
+            </a:extLst>
+          </p:cNvPr>
+          <p:cNvSpPr>
+            <a:spLocks xmlns:a="http://schemas.openxmlformats.org/drawingml/2006/main" noGrp="1"/>
+          </p:cNvSpPr>
+          <p:nvPr/>
+        </p:nvSpPr>
+        <p:spPr>
+          <a:xfrm xmlns:a="http://schemas.openxmlformats.org/drawingml/2006/main">
+            <a:off x="8515350" y="1524000"/>
+            <a:ext cx="2438400" cy="190500"/>
+          </a:xfrm>
+          <a:prstGeom xmlns:a="http://schemas.openxmlformats.org/drawingml/2006/main" prst="rect">
+            <a:avLst/>
+          </a:prstGeom>
+          <a:noFill xmlns:a="http://schemas.openxmlformats.org/drawingml/2006/main"/>
+          <a:ln xmlns:a="http://schemas.openxmlformats.org/drawingml/2006/main" w="0">
+            <a:noFill/>
+            <a:prstDash val="solid"/>
+          </a:ln>
+        </p:spPr>
+        <p:txBody>
+          <a:bodyPr xmlns:a="http://schemas.openxmlformats.org/drawingml/2006/main"/>
+          <a:lstStyle xmlns:a="http://schemas.openxmlformats.org/drawingml/2006/main"/>
+          <a:p xmlns:a="http://schemas.openxmlformats.org/drawingml/2006/main">
+            <a:pPr>
+              <a:buNone/>
+              <a:defRPr sz="938">
+                <a:solidFill>
+                  <a:srgbClr val="6B746F"/>
+                </a:solidFill>
+                <a:latin typeface="Microsoft YaHei"/>
+                <a:ea typeface="Microsoft YaHei"/>
+                <a:cs typeface="Microsoft YaHei"/>
+              </a:defRPr>
+            </a:pPr>
+            <a:r>
+              <a:rPr sz="938">
+                <a:solidFill>
+                  <a:srgbClr val="6B746F"/>
+                </a:solidFill>
+                <a:latin typeface="Microsoft YaHei"/>
+                <a:ea typeface="Microsoft YaHei"/>
+                <a:cs typeface="Microsoft YaHei"/>
+              </a:rPr>
+              <a:t>输入输出字段、Prompt/工具调用、低置信度兜底规则截图</a:t>
             </a:r>
           </a:p>
         </p:txBody>
@@ -21069,6 +23908,7 @@
           <a:lstStyle xmlns:a="http://schemas.openxmlformats.org/drawingml/2006/main"/>
           <a:p xmlns:a="http://schemas.openxmlformats.org/drawingml/2006/main">
             <a:pPr algn="l">
+              <a:buNone/>
               <a:defRPr sz="975" b="1">
                 <a:solidFill>
                   <a:srgbClr val="C47A2C"/>
@@ -21125,6 +23965,7 @@
           <a:lstStyle xmlns:a="http://schemas.openxmlformats.org/drawingml/2006/main"/>
           <a:p xmlns:a="http://schemas.openxmlformats.org/drawingml/2006/main">
             <a:pPr algn="l">
+              <a:buNone/>
               <a:defRPr sz="2175" b="1">
                 <a:solidFill>
                   <a:srgbClr val="17211F"/>
@@ -21181,6 +24022,7 @@
           <a:lstStyle xmlns:a="http://schemas.openxmlformats.org/drawingml/2006/main"/>
           <a:p xmlns:a="http://schemas.openxmlformats.org/drawingml/2006/main">
             <a:pPr algn="l">
+              <a:buNone/>
               <a:defRPr sz="1200" b="0">
                 <a:solidFill>
                   <a:srgbClr val="65716D"/>
@@ -21303,6 +24145,7 @@
           <a:lstStyle xmlns:a="http://schemas.openxmlformats.org/drawingml/2006/main"/>
           <a:p xmlns:a="http://schemas.openxmlformats.org/drawingml/2006/main">
             <a:pPr algn="ctr">
+              <a:buNone/>
               <a:defRPr sz="1050" b="1">
                 <a:solidFill>
                   <a:srgbClr val="17211F"/>
@@ -21425,6 +24268,7 @@
           <a:lstStyle xmlns:a="http://schemas.openxmlformats.org/drawingml/2006/main"/>
           <a:p xmlns:a="http://schemas.openxmlformats.org/drawingml/2006/main">
             <a:pPr algn="ctr">
+              <a:buNone/>
               <a:defRPr sz="1050" b="1">
                 <a:solidFill>
                   <a:srgbClr val="17211F"/>
@@ -21547,6 +24391,7 @@
           <a:lstStyle xmlns:a="http://schemas.openxmlformats.org/drawingml/2006/main"/>
           <a:p xmlns:a="http://schemas.openxmlformats.org/drawingml/2006/main">
             <a:pPr algn="ctr">
+              <a:buNone/>
               <a:defRPr sz="1050" b="1">
                 <a:solidFill>
                   <a:srgbClr val="17211F"/>
@@ -21669,6 +24514,7 @@
           <a:lstStyle xmlns:a="http://schemas.openxmlformats.org/drawingml/2006/main"/>
           <a:p xmlns:a="http://schemas.openxmlformats.org/drawingml/2006/main">
             <a:pPr algn="ctr">
+              <a:buNone/>
               <a:defRPr sz="1050" b="1">
                 <a:solidFill>
                   <a:srgbClr val="17211F"/>
@@ -21791,6 +24637,7 @@
           <a:lstStyle xmlns:a="http://schemas.openxmlformats.org/drawingml/2006/main"/>
           <a:p xmlns:a="http://schemas.openxmlformats.org/drawingml/2006/main">
             <a:pPr algn="ctr">
+              <a:buNone/>
               <a:defRPr sz="1050" b="1">
                 <a:solidFill>
                   <a:srgbClr val="17211F"/>
@@ -21913,6 +24760,7 @@
           <a:lstStyle xmlns:a="http://schemas.openxmlformats.org/drawingml/2006/main"/>
           <a:p xmlns:a="http://schemas.openxmlformats.org/drawingml/2006/main">
             <a:pPr algn="ctr">
+              <a:buNone/>
               <a:defRPr sz="1050" b="1">
                 <a:solidFill>
                   <a:srgbClr val="17211F"/>
@@ -22004,6 +24852,7 @@
           <a:lstStyle xmlns:a="http://schemas.openxmlformats.org/drawingml/2006/main"/>
           <a:p xmlns:a="http://schemas.openxmlformats.org/drawingml/2006/main">
             <a:pPr algn="l">
+              <a:buNone/>
               <a:defRPr sz="1350" b="0">
                 <a:solidFill>
                   <a:srgbClr val="17211F"/>
@@ -22091,6 +24940,7 @@
           <a:lstStyle xmlns:a="http://schemas.openxmlformats.org/drawingml/2006/main"/>
           <a:p xmlns:a="http://schemas.openxmlformats.org/drawingml/2006/main">
             <a:pPr algn="l">
+              <a:buNone/>
               <a:defRPr sz="1350" b="0">
                 <a:solidFill>
                   <a:srgbClr val="17211F"/>
@@ -22178,6 +25028,7 @@
           <a:lstStyle xmlns:a="http://schemas.openxmlformats.org/drawingml/2006/main"/>
           <a:p xmlns:a="http://schemas.openxmlformats.org/drawingml/2006/main">
             <a:pPr algn="l">
+              <a:buNone/>
               <a:defRPr sz="1350" b="0">
                 <a:solidFill>
                   <a:srgbClr val="17211F"/>
@@ -22265,6 +25116,7 @@
           <a:lstStyle xmlns:a="http://schemas.openxmlformats.org/drawingml/2006/main"/>
           <a:p xmlns:a="http://schemas.openxmlformats.org/drawingml/2006/main">
             <a:pPr algn="ctr">
+              <a:buNone/>
               <a:defRPr sz="1575" b="1">
                 <a:solidFill>
                   <a:srgbClr val="1F6B57"/>
@@ -22321,6 +25173,7 @@
           <a:lstStyle xmlns:a="http://schemas.openxmlformats.org/drawingml/2006/main"/>
           <a:p xmlns:a="http://schemas.openxmlformats.org/drawingml/2006/main">
             <a:pPr algn="l">
+              <a:buNone/>
               <a:defRPr sz="750" b="0">
                 <a:solidFill>
                   <a:srgbClr val="65716D"/>
@@ -22340,6 +25193,212 @@
                 <a:cs typeface="Microsoft YaHei"/>
               </a:rPr>
               <a:t>作品集用途：求职面试 / 产品经理能力证明；所有指标以可公开证据为准</a:t>
+            </a:r>
+          </a:p>
+        </p:txBody>
+      </p:sp>
+      <p:sp>
+        <p:nvSpPr>
+          <p:cNvPr id="31" name="material-slot-状态机 / 模板库截图">
+            <a:extLst xmlns:a="http://schemas.openxmlformats.org/drawingml/2006/main">
+              <a:ext uri="{FF2B5EF4-FFF2-40B4-BE49-F238E27FC236}">
+                <a16:creationId xmlns:a16="http://schemas.microsoft.com/office/drawing/2014/main" id="{69A24DF9-A1A4-4686-8888-9361321E5F5F}"/>
+              </a:ext>
+            </a:extLst>
+          </p:cNvPr>
+          <p:cNvSpPr>
+            <a:spLocks xmlns:a="http://schemas.openxmlformats.org/drawingml/2006/main" noGrp="1"/>
+          </p:cNvSpPr>
+          <p:nvPr/>
+        </p:nvSpPr>
+        <p:spPr>
+          <a:xfrm xmlns:a="http://schemas.openxmlformats.org/drawingml/2006/main">
+            <a:off x="6858000" y="3562350"/>
+            <a:ext cx="3562350" cy="1143000"/>
+          </a:xfrm>
+          <a:prstGeom xmlns:a="http://schemas.openxmlformats.org/drawingml/2006/main" prst="roundRect">
+            <a:avLst>
+              <a:gd name="adj" fmla="val 6667"/>
+            </a:avLst>
+          </a:prstGeom>
+          <a:solidFill xmlns:a="http://schemas.openxmlformats.org/drawingml/2006/main">
+            <a:srgbClr val="F7FAF8"/>
+          </a:solidFill>
+          <a:ln xmlns:a="http://schemas.openxmlformats.org/drawingml/2006/main" w="14288">
+            <a:solidFill>
+              <a:srgbClr val="1F6B57"/>
+            </a:solidFill>
+            <a:prstDash val="dash"/>
+          </a:ln>
+        </p:spPr>
+      </p:sp>
+      <p:sp>
+        <p:nvSpPr>
+          <p:cNvPr id="32" name="">
+            <a:extLst xmlns:a="http://schemas.openxmlformats.org/drawingml/2006/main">
+              <a:ext uri="{FF2B5EF4-FFF2-40B4-BE49-F238E27FC236}">
+                <a16:creationId xmlns:a16="http://schemas.microsoft.com/office/drawing/2014/main" id="{13F95A9E-9E89-4798-AED6-83D5CB8CD26B}"/>
+              </a:ext>
+            </a:extLst>
+          </p:cNvPr>
+          <p:cNvSpPr>
+            <a:spLocks xmlns:a="http://schemas.openxmlformats.org/drawingml/2006/main" noGrp="1"/>
+          </p:cNvSpPr>
+          <p:nvPr/>
+        </p:nvSpPr>
+        <p:spPr>
+          <a:xfrm xmlns:a="http://schemas.openxmlformats.org/drawingml/2006/main">
+            <a:off x="7029450" y="3695700"/>
+            <a:ext cx="781050" cy="228600"/>
+          </a:xfrm>
+          <a:prstGeom xmlns:a="http://schemas.openxmlformats.org/drawingml/2006/main" prst="rect">
+            <a:avLst/>
+          </a:prstGeom>
+          <a:noFill xmlns:a="http://schemas.openxmlformats.org/drawingml/2006/main"/>
+          <a:ln xmlns:a="http://schemas.openxmlformats.org/drawingml/2006/main" w="0">
+            <a:noFill/>
+            <a:prstDash val="solid"/>
+          </a:ln>
+        </p:spPr>
+        <p:txBody>
+          <a:bodyPr xmlns:a="http://schemas.openxmlformats.org/drawingml/2006/main"/>
+          <a:lstStyle xmlns:a="http://schemas.openxmlformats.org/drawingml/2006/main"/>
+          <a:p xmlns:a="http://schemas.openxmlformats.org/drawingml/2006/main">
+            <a:pPr>
+              <a:buNone/>
+              <a:defRPr sz="975" b="1">
+                <a:solidFill>
+                  <a:srgbClr val="1F6B57"/>
+                </a:solidFill>
+                <a:latin typeface="Microsoft YaHei"/>
+                <a:ea typeface="Microsoft YaHei"/>
+                <a:cs typeface="Microsoft YaHei"/>
+              </a:defRPr>
+            </a:pPr>
+            <a:r>
+              <a:rPr sz="975" b="1">
+                <a:solidFill>
+                  <a:srgbClr val="1F6B57"/>
+                </a:solidFill>
+                <a:latin typeface="Microsoft YaHei"/>
+                <a:ea typeface="Microsoft YaHei"/>
+                <a:cs typeface="Microsoft YaHei"/>
+              </a:rPr>
+              <a:t>待补充</a:t>
+            </a:r>
+          </a:p>
+        </p:txBody>
+      </p:sp>
+      <p:sp>
+        <p:nvSpPr>
+          <p:cNvPr id="33" name="">
+            <a:extLst xmlns:a="http://schemas.openxmlformats.org/drawingml/2006/main">
+              <a:ext uri="{FF2B5EF4-FFF2-40B4-BE49-F238E27FC236}">
+                <a16:creationId xmlns:a16="http://schemas.microsoft.com/office/drawing/2014/main" id="{7D6BBEB4-62D6-4B88-84AE-3DBC1E2AC43E}"/>
+              </a:ext>
+            </a:extLst>
+          </p:cNvPr>
+          <p:cNvSpPr>
+            <a:spLocks xmlns:a="http://schemas.openxmlformats.org/drawingml/2006/main" noGrp="1"/>
+          </p:cNvSpPr>
+          <p:nvPr/>
+        </p:nvSpPr>
+        <p:spPr>
+          <a:xfrm xmlns:a="http://schemas.openxmlformats.org/drawingml/2006/main">
+            <a:off x="7829550" y="3676650"/>
+            <a:ext cx="2419350" cy="266700"/>
+          </a:xfrm>
+          <a:prstGeom xmlns:a="http://schemas.openxmlformats.org/drawingml/2006/main" prst="rect">
+            <a:avLst/>
+          </a:prstGeom>
+          <a:noFill xmlns:a="http://schemas.openxmlformats.org/drawingml/2006/main"/>
+          <a:ln xmlns:a="http://schemas.openxmlformats.org/drawingml/2006/main" w="0">
+            <a:noFill/>
+            <a:prstDash val="solid"/>
+          </a:ln>
+        </p:spPr>
+        <p:txBody>
+          <a:bodyPr xmlns:a="http://schemas.openxmlformats.org/drawingml/2006/main"/>
+          <a:lstStyle xmlns:a="http://schemas.openxmlformats.org/drawingml/2006/main"/>
+          <a:p xmlns:a="http://schemas.openxmlformats.org/drawingml/2006/main">
+            <a:pPr>
+              <a:buNone/>
+              <a:defRPr sz="1275" b="1">
+                <a:solidFill>
+                  <a:srgbClr val="1A2A26"/>
+                </a:solidFill>
+                <a:latin typeface="Microsoft YaHei"/>
+                <a:ea typeface="Microsoft YaHei"/>
+                <a:cs typeface="Microsoft YaHei"/>
+              </a:defRPr>
+            </a:pPr>
+            <a:r>
+              <a:rPr sz="1275" b="1">
+                <a:solidFill>
+                  <a:srgbClr val="1A2A26"/>
+                </a:solidFill>
+                <a:latin typeface="Microsoft YaHei"/>
+                <a:ea typeface="Microsoft YaHei"/>
+                <a:cs typeface="Microsoft YaHei"/>
+              </a:rPr>
+              <a:t>状态机 / 模板库截图</a:t>
+            </a:r>
+          </a:p>
+        </p:txBody>
+      </p:sp>
+      <p:sp>
+        <p:nvSpPr>
+          <p:cNvPr id="34" name="">
+            <a:extLst xmlns:a="http://schemas.openxmlformats.org/drawingml/2006/main">
+              <a:ext uri="{FF2B5EF4-FFF2-40B4-BE49-F238E27FC236}">
+                <a16:creationId xmlns:a16="http://schemas.microsoft.com/office/drawing/2014/main" id="{8CDC9626-CBDB-4E57-81C8-1E211B8AF736}"/>
+              </a:ext>
+            </a:extLst>
+          </p:cNvPr>
+          <p:cNvSpPr>
+            <a:spLocks xmlns:a="http://schemas.openxmlformats.org/drawingml/2006/main" noGrp="1"/>
+          </p:cNvSpPr>
+          <p:nvPr/>
+        </p:nvSpPr>
+        <p:spPr>
+          <a:xfrm xmlns:a="http://schemas.openxmlformats.org/drawingml/2006/main">
+            <a:off x="7029450" y="3962400"/>
+            <a:ext cx="3219450" cy="666750"/>
+          </a:xfrm>
+          <a:prstGeom xmlns:a="http://schemas.openxmlformats.org/drawingml/2006/main" prst="rect">
+            <a:avLst/>
+          </a:prstGeom>
+          <a:noFill xmlns:a="http://schemas.openxmlformats.org/drawingml/2006/main"/>
+          <a:ln xmlns:a="http://schemas.openxmlformats.org/drawingml/2006/main" w="0">
+            <a:noFill/>
+            <a:prstDash val="solid"/>
+          </a:ln>
+        </p:spPr>
+        <p:txBody>
+          <a:bodyPr xmlns:a="http://schemas.openxmlformats.org/drawingml/2006/main"/>
+          <a:lstStyle xmlns:a="http://schemas.openxmlformats.org/drawingml/2006/main"/>
+          <a:p xmlns:a="http://schemas.openxmlformats.org/drawingml/2006/main">
+            <a:pPr>
+              <a:buNone/>
+              <a:defRPr sz="938">
+                <a:solidFill>
+                  <a:srgbClr val="6B746F"/>
+                </a:solidFill>
+                <a:latin typeface="Microsoft YaHei"/>
+                <a:ea typeface="Microsoft YaHei"/>
+                <a:cs typeface="Microsoft YaHei"/>
+              </a:defRPr>
+            </a:pPr>
+            <a:r>
+              <a:rPr sz="938">
+                <a:solidFill>
+                  <a:srgbClr val="6B746F"/>
+                </a:solidFill>
+                <a:latin typeface="Microsoft YaHei"/>
+                <a:ea typeface="Microsoft YaHei"/>
+                <a:cs typeface="Microsoft YaHei"/>
+              </a:rPr>
+              <a:t>工单状态流转、SOP模板库、审批字段、回写字段的PRD或产品页</a:t>
             </a:r>
           </a:p>
         </p:txBody>

</xml_diff>